<commit_message>
Fix testing pyramid: pipeline is System Test only, not Acceptance
Acceptance Tests are customer-driven validation — the pipeline does
system-level verification through automated log analysis. Only the
System Tests layer is highlighted now.

Co-Authored-By: Claude Opus 4.6 (1M context) <noreply@anthropic.com>
</commit_message>
<xml_diff>
--- a/docs/presentations/MBSE_Pipeline_Executive_Brief.pptx
+++ b/docs/presentations/MBSE_Pipeline_Executive_Brief.pptx
@@ -8091,7 +8091,7 @@
                   <a:srgbClr val="555555"/>
                 </a:solidFill>
               </a:rPr>
-              <a:t>The MBSE pipeline operates at the System and Acceptance test layers — verifying requirements against the deployed product.</a:t>
+              <a:t>The MBSE pipeline operates at the System Test layer — verifying requirements against the deployed product through automated log analysis.</a:t>
             </a:r>
           </a:p>
         </p:txBody>
@@ -8401,12 +8401,10 @@
             <a:avLst/>
           </a:prstGeom>
           <a:solidFill>
-            <a:srgbClr val="0082CC"/>
+            <a:srgbClr val="888888"/>
           </a:solidFill>
-          <a:ln w="25400">
-            <a:solidFill>
-              <a:srgbClr val="0099D6"/>
-            </a:solidFill>
+          <a:ln>
+            <a:noFill/>
           </a:ln>
         </p:spPr>
         <p:style>
@@ -8479,7 +8477,7 @@
                   <a:srgbClr val="BBBBBB"/>
                 </a:solidFill>
               </a:rPr>
-              <a:t>Requirement-level validation</a:t>
+              <a:t>Customer-driven validation</a:t>
             </a:r>
           </a:p>
         </p:txBody>
@@ -8492,7 +8490,7 @@
         </p:nvSpPr>
         <p:spPr>
           <a:xfrm>
-            <a:off x="5303520" y="2560320"/>
+            <a:off x="5303520" y="3200400"/>
             <a:ext cx="1371600" cy="274320"/>
           </a:xfrm>
           <a:prstGeom prst="rect">
@@ -8858,7 +8856,7 @@
                   <a:srgbClr val="888888"/>
                 </a:solidFill>
               </a:rPr>
-              <a:t>Unit and Integration tests are owned by developers in their respective repos. The MBSE pipeline adds the System and Acceptance layers with full traceability.</a:t>
+              <a:t>Unit and Integration tests are owned by developers in their respective repos. The MBSE pipeline adds the System Test layer with full requirement traceability.</a:t>
             </a:r>
           </a:p>
         </p:txBody>

</xml_diff>

<commit_message>
Simplify test pyramid to 3 layers, remove Acceptance/Operational
Three layers: Component Tests, Integration Tests, System Verification.
Pipeline sits at System Verification — no ambiguity about which
layer it occupies.

Co-Authored-By: Claude Opus 4.6 (1M context) <noreply@anthropic.com>
</commit_message>
<xml_diff>
--- a/docs/presentations/MBSE_Pipeline_Executive_Brief.pptx
+++ b/docs/presentations/MBSE_Pipeline_Executive_Brief.pptx
@@ -8091,7 +8091,7 @@
                   <a:srgbClr val="555555"/>
                 </a:solidFill>
               </a:rPr>
-              <a:t>The MBSE pipeline operates at the System Test layer — verifying requirements against the deployed product through automated log analysis.</a:t>
+              <a:t>The MBSE pipeline operates at the System Verification layer — verifying requirements against the deployed product through automated log analysis.</a:t>
             </a:r>
           </a:p>
         </p:txBody>
@@ -8104,8 +8104,8 @@
         </p:nvSpPr>
         <p:spPr>
           <a:xfrm>
-            <a:off x="1371600" y="4754880"/>
-            <a:ext cx="4572000" cy="731520"/>
+            <a:off x="1371600" y="4572000"/>
+            <a:ext cx="4572000" cy="822960"/>
           </a:xfrm>
           <a:prstGeom prst="roundRect">
             <a:avLst/>
@@ -8147,8 +8147,8 @@
         </p:nvSpPr>
         <p:spPr>
           <a:xfrm>
-            <a:off x="1508760" y="4846320"/>
-            <a:ext cx="4297680" cy="594360"/>
+            <a:off x="1508760" y="4663440"/>
+            <a:ext cx="4297680" cy="685800"/>
           </a:xfrm>
           <a:prstGeom prst="rect">
             <a:avLst/>
@@ -8172,7 +8172,7 @@
                   <a:srgbClr val="FFFFFF"/>
                 </a:solidFill>
               </a:rPr>
-              <a:t>Unit Tests</a:t>
+              <a:t>Component Tests</a:t>
             </a:r>
           </a:p>
           <a:p>
@@ -8187,7 +8187,7 @@
                   <a:srgbClr val="BBBBBB"/>
                 </a:solidFill>
               </a:rPr>
-              <a:t>Component-level code coverage</a:t>
+              <a:t>Unit-level code coverage</a:t>
             </a:r>
           </a:p>
         </p:txBody>
@@ -8200,8 +8200,8 @@
         </p:nvSpPr>
         <p:spPr>
           <a:xfrm>
-            <a:off x="1828800" y="3931920"/>
-            <a:ext cx="3657600" cy="731520"/>
+            <a:off x="1828800" y="3566160"/>
+            <a:ext cx="3657600" cy="822960"/>
           </a:xfrm>
           <a:prstGeom prst="roundRect">
             <a:avLst/>
@@ -8243,8 +8243,8 @@
         </p:nvSpPr>
         <p:spPr>
           <a:xfrm>
-            <a:off x="1965960" y="4023360"/>
-            <a:ext cx="3383280" cy="594360"/>
+            <a:off x="1965960" y="3657600"/>
+            <a:ext cx="3383280" cy="685800"/>
           </a:xfrm>
           <a:prstGeom prst="rect">
             <a:avLst/>
@@ -8296,8 +8296,8 @@
         </p:nvSpPr>
         <p:spPr>
           <a:xfrm>
-            <a:off x="2286000" y="3108960"/>
-            <a:ext cx="2743200" cy="731520"/>
+            <a:off x="2286000" y="2560320"/>
+            <a:ext cx="2743200" cy="822960"/>
           </a:xfrm>
           <a:prstGeom prst="roundRect">
             <a:avLst/>
@@ -8341,8 +8341,8 @@
         </p:nvSpPr>
         <p:spPr>
           <a:xfrm>
-            <a:off x="2423160" y="3200400"/>
-            <a:ext cx="2468880" cy="594360"/>
+            <a:off x="2423160" y="2651760"/>
+            <a:ext cx="2468880" cy="685800"/>
           </a:xfrm>
           <a:prstGeom prst="rect">
             <a:avLst/>
@@ -8366,7 +8366,7 @@
                   <a:srgbClr val="FFFFFF"/>
                 </a:solidFill>
               </a:rPr>
-              <a:t>System Tests</a:t>
+              <a:t>System Verification</a:t>
             </a:r>
           </a:p>
           <a:p>
@@ -8381,148 +8381,53 @@
                   <a:srgbClr val="BBBBBB"/>
                 </a:solidFill>
               </a:rPr>
-              <a:t>End-to-end behavior verification</a:t>
-            </a:r>
-          </a:p>
-        </p:txBody>
-      </p:sp>
-      <p:sp>
-        <p:nvSpPr>
-          <p:cNvPr id="10" name="Rounded Rectangle 9"/>
-          <p:cNvSpPr/>
-          <p:nvPr/>
-        </p:nvSpPr>
-        <p:spPr>
-          <a:xfrm>
-            <a:off x="2743200" y="2286000"/>
-            <a:ext cx="1828800" cy="731520"/>
-          </a:xfrm>
-          <a:prstGeom prst="roundRect">
-            <a:avLst/>
-          </a:prstGeom>
-          <a:solidFill>
-            <a:srgbClr val="888888"/>
-          </a:solidFill>
-          <a:ln>
-            <a:noFill/>
-          </a:ln>
-        </p:spPr>
-        <p:style>
-          <a:lnRef idx="1">
-            <a:schemeClr val="accent1"/>
-          </a:lnRef>
-          <a:fillRef idx="3">
-            <a:schemeClr val="accent1"/>
-          </a:fillRef>
-          <a:effectRef idx="2">
-            <a:schemeClr val="accent1"/>
-          </a:effectRef>
-          <a:fontRef idx="minor">
-            <a:schemeClr val="lt1"/>
-          </a:fontRef>
-        </p:style>
-        <p:txBody>
-          <a:bodyPr rtlCol="0" anchor="ctr"/>
-          <a:lstStyle/>
-          <a:p>
-            <a:pPr algn="ctr"/>
+              <a:t>Requirement-level verification
+against the deployed product</a:t>
+            </a:r>
+          </a:p>
+        </p:txBody>
+      </p:sp>
+      <p:sp>
+        <p:nvSpPr>
+          <p:cNvPr id="10" name="TextBox 9"/>
+          <p:cNvSpPr txBox="1"/>
+          <p:nvPr/>
+        </p:nvSpPr>
+        <p:spPr>
+          <a:xfrm>
+            <a:off x="5303520" y="2743200"/>
+            <a:ext cx="1371600" cy="274320"/>
+          </a:xfrm>
+          <a:prstGeom prst="rect">
+            <a:avLst/>
+          </a:prstGeom>
+          <a:noFill/>
+        </p:spPr>
+        <p:txBody>
+          <a:bodyPr wrap="square">
+            <a:spAutoFit/>
+          </a:bodyPr>
+          <a:lstStyle/>
+          <a:p>
+            <a:pPr algn="l">
+              <a:spcAft>
+                <a:spcPts val="0"/>
+              </a:spcAft>
+            </a:pPr>
+            <a:r>
+              <a:rPr sz="1000" b="1">
+                <a:solidFill>
+                  <a:srgbClr val="0069B0"/>
+                </a:solidFill>
+              </a:rPr>
+              <a:t>◀ MBSE Pipeline</a:t>
+            </a:r>
           </a:p>
         </p:txBody>
       </p:sp>
       <p:sp>
         <p:nvSpPr>
           <p:cNvPr id="11" name="TextBox 10"/>
-          <p:cNvSpPr txBox="1"/>
-          <p:nvPr/>
-        </p:nvSpPr>
-        <p:spPr>
-          <a:xfrm>
-            <a:off x="2880360" y="2377440"/>
-            <a:ext cx="1554480" cy="594360"/>
-          </a:xfrm>
-          <a:prstGeom prst="rect">
-            <a:avLst/>
-          </a:prstGeom>
-          <a:noFill/>
-        </p:spPr>
-        <p:txBody>
-          <a:bodyPr wrap="square">
-            <a:spAutoFit/>
-          </a:bodyPr>
-          <a:lstStyle/>
-          <a:p>
-            <a:pPr algn="ctr">
-              <a:spcAft>
-                <a:spcPts val="100"/>
-              </a:spcAft>
-            </a:pPr>
-            <a:r>
-              <a:rPr sz="1100" b="1">
-                <a:solidFill>
-                  <a:srgbClr val="FFFFFF"/>
-                </a:solidFill>
-              </a:rPr>
-              <a:t>Acceptance Tests</a:t>
-            </a:r>
-          </a:p>
-          <a:p>
-            <a:pPr algn="ctr">
-              <a:spcAft>
-                <a:spcPts val="0"/>
-              </a:spcAft>
-            </a:pPr>
-            <a:r>
-              <a:rPr sz="800" b="0">
-                <a:solidFill>
-                  <a:srgbClr val="BBBBBB"/>
-                </a:solidFill>
-              </a:rPr>
-              <a:t>Customer-driven validation</a:t>
-            </a:r>
-          </a:p>
-        </p:txBody>
-      </p:sp>
-      <p:sp>
-        <p:nvSpPr>
-          <p:cNvPr id="12" name="TextBox 11"/>
-          <p:cNvSpPr txBox="1"/>
-          <p:nvPr/>
-        </p:nvSpPr>
-        <p:spPr>
-          <a:xfrm>
-            <a:off x="5303520" y="3200400"/>
-            <a:ext cx="1371600" cy="274320"/>
-          </a:xfrm>
-          <a:prstGeom prst="rect">
-            <a:avLst/>
-          </a:prstGeom>
-          <a:noFill/>
-        </p:spPr>
-        <p:txBody>
-          <a:bodyPr wrap="square">
-            <a:spAutoFit/>
-          </a:bodyPr>
-          <a:lstStyle/>
-          <a:p>
-            <a:pPr algn="l">
-              <a:spcAft>
-                <a:spcPts val="0"/>
-              </a:spcAft>
-            </a:pPr>
-            <a:r>
-              <a:rPr sz="1000" b="1">
-                <a:solidFill>
-                  <a:srgbClr val="0069B0"/>
-                </a:solidFill>
-              </a:rPr>
-              <a:t>◀ MBSE Pipeline</a:t>
-            </a:r>
-          </a:p>
-        </p:txBody>
-      </p:sp>
-      <p:sp>
-        <p:nvSpPr>
-          <p:cNvPr id="13" name="TextBox 12"/>
           <p:cNvSpPr txBox="1"/>
           <p:nvPr/>
         </p:nvSpPr>
@@ -8560,7 +8465,7 @@
       </p:sp>
       <p:sp>
         <p:nvSpPr>
-          <p:cNvPr id="14" name="TextBox 13"/>
+          <p:cNvPr id="12" name="TextBox 11"/>
           <p:cNvSpPr txBox="1"/>
           <p:nvPr/>
         </p:nvSpPr>
@@ -8613,7 +8518,7 @@
       </p:sp>
       <p:sp>
         <p:nvSpPr>
-          <p:cNvPr id="15" name="TextBox 14"/>
+          <p:cNvPr id="13" name="TextBox 12"/>
           <p:cNvSpPr txBox="1"/>
           <p:nvPr/>
         </p:nvSpPr>
@@ -8666,7 +8571,7 @@
       </p:sp>
       <p:sp>
         <p:nvSpPr>
-          <p:cNvPr id="16" name="TextBox 15"/>
+          <p:cNvPr id="14" name="TextBox 13"/>
           <p:cNvSpPr txBox="1"/>
           <p:nvPr/>
         </p:nvSpPr>
@@ -8719,7 +8624,7 @@
       </p:sp>
       <p:sp>
         <p:nvSpPr>
-          <p:cNvPr id="17" name="TextBox 16"/>
+          <p:cNvPr id="15" name="TextBox 14"/>
           <p:cNvSpPr txBox="1"/>
           <p:nvPr/>
         </p:nvSpPr>
@@ -8772,7 +8677,7 @@
       </p:sp>
       <p:sp>
         <p:nvSpPr>
-          <p:cNvPr id="18" name="TextBox 17"/>
+          <p:cNvPr id="16" name="TextBox 15"/>
           <p:cNvSpPr txBox="1"/>
           <p:nvPr/>
         </p:nvSpPr>
@@ -8825,7 +8730,7 @@
       </p:sp>
       <p:sp>
         <p:nvSpPr>
-          <p:cNvPr id="19" name="TextBox 18"/>
+          <p:cNvPr id="17" name="TextBox 16"/>
           <p:cNvSpPr txBox="1"/>
           <p:nvPr/>
         </p:nvSpPr>
@@ -8856,14 +8761,14 @@
                   <a:srgbClr val="888888"/>
                 </a:solidFill>
               </a:rPr>
-              <a:t>Unit and Integration tests are owned by developers in their respective repos. The MBSE pipeline adds the System Test layer with full requirement traceability.</a:t>
-            </a:r>
-          </a:p>
-        </p:txBody>
-      </p:sp>
-      <p:sp>
-        <p:nvSpPr>
-          <p:cNvPr id="20" name="TextBox 19"/>
+              <a:t>Component and Integration tests are owned by developers. The MBSE pipeline adds System Verification with full requirement traceability from the Cameo model.</a:t>
+            </a:r>
+          </a:p>
+        </p:txBody>
+      </p:sp>
+      <p:sp>
+        <p:nvSpPr>
+          <p:cNvPr id="18" name="TextBox 17"/>
           <p:cNvSpPr txBox="1"/>
           <p:nvPr/>
         </p:nvSpPr>

</xml_diff>

<commit_message>
Rebuild test pyramid to match standard 5-layer model
Five layers matching the reference diagram:
- Static Analysis (bottom, dark navy)
- Unit Tests (dark blue)
- Integration Tests (grey)
- E2E Tests (blue, highlighted — MBSE Pipeline sits here)
- Manual & Exploratory (top, grey)

Added Cost/Speed axis labels. Pipeline arrow points to E2E layer.

Co-Authored-By: Claude Opus 4.6 (1M context) <noreply@anthropic.com>
</commit_message>
<xml_diff>
--- a/docs/presentations/MBSE_Pipeline_Executive_Brief.pptx
+++ b/docs/presentations/MBSE_Pipeline_Executive_Brief.pptx
@@ -8091,7 +8091,7 @@
                   <a:srgbClr val="555555"/>
                 </a:solidFill>
               </a:rPr>
-              <a:t>The MBSE pipeline operates at the System Verification layer — verifying requirements against the deployed product through automated log analysis.</a:t>
+              <a:t>The MBSE pipeline automates E2E testing — deploying the product, running simulations, and verifying requirements through log analysis.</a:t>
             </a:r>
           </a:p>
         </p:txBody>
@@ -8104,8 +8104,170 @@
         </p:nvSpPr>
         <p:spPr>
           <a:xfrm>
-            <a:off x="1371600" y="4572000"/>
-            <a:ext cx="4572000" cy="822960"/>
+            <a:off x="457200" y="4937760"/>
+            <a:ext cx="5029200" cy="685800"/>
+          </a:xfrm>
+          <a:prstGeom prst="roundRect">
+            <a:avLst/>
+          </a:prstGeom>
+          <a:solidFill>
+            <a:srgbClr val="003057"/>
+          </a:solidFill>
+          <a:ln>
+            <a:noFill/>
+          </a:ln>
+        </p:spPr>
+        <p:style>
+          <a:lnRef idx="1">
+            <a:schemeClr val="accent1"/>
+          </a:lnRef>
+          <a:fillRef idx="3">
+            <a:schemeClr val="accent1"/>
+          </a:fillRef>
+          <a:effectRef idx="2">
+            <a:schemeClr val="accent1"/>
+          </a:effectRef>
+          <a:fontRef idx="minor">
+            <a:schemeClr val="lt1"/>
+          </a:fontRef>
+        </p:style>
+        <p:txBody>
+          <a:bodyPr rtlCol="0" anchor="ctr"/>
+          <a:lstStyle/>
+          <a:p>
+            <a:pPr algn="ctr"/>
+          </a:p>
+        </p:txBody>
+      </p:sp>
+      <p:sp>
+        <p:nvSpPr>
+          <p:cNvPr id="5" name="TextBox 4"/>
+          <p:cNvSpPr txBox="1"/>
+          <p:nvPr/>
+        </p:nvSpPr>
+        <p:spPr>
+          <a:xfrm>
+            <a:off x="548640" y="5029200"/>
+            <a:ext cx="4846320" cy="594360"/>
+          </a:xfrm>
+          <a:prstGeom prst="rect">
+            <a:avLst/>
+          </a:prstGeom>
+          <a:noFill/>
+        </p:spPr>
+        <p:txBody>
+          <a:bodyPr wrap="square">
+            <a:spAutoFit/>
+          </a:bodyPr>
+          <a:lstStyle/>
+          <a:p>
+            <a:pPr algn="ctr">
+              <a:spcAft>
+                <a:spcPts val="0"/>
+              </a:spcAft>
+            </a:pPr>
+            <a:r>
+              <a:rPr sz="1100" b="1">
+                <a:solidFill>
+                  <a:srgbClr val="FFFFFF"/>
+                </a:solidFill>
+              </a:rPr>
+              <a:t>Static Analysis</a:t>
+            </a:r>
+          </a:p>
+        </p:txBody>
+      </p:sp>
+      <p:sp>
+        <p:nvSpPr>
+          <p:cNvPr id="6" name="Rounded Rectangle 5"/>
+          <p:cNvSpPr/>
+          <p:nvPr/>
+        </p:nvSpPr>
+        <p:spPr>
+          <a:xfrm>
+            <a:off x="822960" y="4114800"/>
+            <a:ext cx="4297680" cy="685800"/>
+          </a:xfrm>
+          <a:prstGeom prst="roundRect">
+            <a:avLst/>
+          </a:prstGeom>
+          <a:solidFill>
+            <a:srgbClr val="004A87"/>
+          </a:solidFill>
+          <a:ln>
+            <a:noFill/>
+          </a:ln>
+        </p:spPr>
+        <p:style>
+          <a:lnRef idx="1">
+            <a:schemeClr val="accent1"/>
+          </a:lnRef>
+          <a:fillRef idx="3">
+            <a:schemeClr val="accent1"/>
+          </a:fillRef>
+          <a:effectRef idx="2">
+            <a:schemeClr val="accent1"/>
+          </a:effectRef>
+          <a:fontRef idx="minor">
+            <a:schemeClr val="lt1"/>
+          </a:fontRef>
+        </p:style>
+        <p:txBody>
+          <a:bodyPr rtlCol="0" anchor="ctr"/>
+          <a:lstStyle/>
+          <a:p>
+            <a:pPr algn="ctr"/>
+          </a:p>
+        </p:txBody>
+      </p:sp>
+      <p:sp>
+        <p:nvSpPr>
+          <p:cNvPr id="7" name="TextBox 6"/>
+          <p:cNvSpPr txBox="1"/>
+          <p:nvPr/>
+        </p:nvSpPr>
+        <p:spPr>
+          <a:xfrm>
+            <a:off x="914400" y="4206240"/>
+            <a:ext cx="4114800" cy="594360"/>
+          </a:xfrm>
+          <a:prstGeom prst="rect">
+            <a:avLst/>
+          </a:prstGeom>
+          <a:noFill/>
+        </p:spPr>
+        <p:txBody>
+          <a:bodyPr wrap="square">
+            <a:spAutoFit/>
+          </a:bodyPr>
+          <a:lstStyle/>
+          <a:p>
+            <a:pPr algn="ctr">
+              <a:spcAft>
+                <a:spcPts val="0"/>
+              </a:spcAft>
+            </a:pPr>
+            <a:r>
+              <a:rPr sz="1100" b="1">
+                <a:solidFill>
+                  <a:srgbClr val="FFFFFF"/>
+                </a:solidFill>
+              </a:rPr>
+              <a:t>Unit Tests</a:t>
+            </a:r>
+          </a:p>
+        </p:txBody>
+      </p:sp>
+      <p:sp>
+        <p:nvSpPr>
+          <p:cNvPr id="8" name="Rounded Rectangle 7"/>
+          <p:cNvSpPr/>
+          <p:nvPr/>
+        </p:nvSpPr>
+        <p:spPr>
+          <a:xfrm>
+            <a:off x="1188720" y="3291840"/>
+            <a:ext cx="3566160" cy="685800"/>
           </a:xfrm>
           <a:prstGeom prst="roundRect">
             <a:avLst/>
@@ -8141,14 +8303,14 @@
       </p:sp>
       <p:sp>
         <p:nvSpPr>
-          <p:cNvPr id="5" name="TextBox 4"/>
-          <p:cNvSpPr txBox="1"/>
-          <p:nvPr/>
-        </p:nvSpPr>
-        <p:spPr>
-          <a:xfrm>
-            <a:off x="1508760" y="4663440"/>
-            <a:ext cx="4297680" cy="685800"/>
+          <p:cNvPr id="9" name="TextBox 8"/>
+          <p:cNvSpPr txBox="1"/>
+          <p:nvPr/>
+        </p:nvSpPr>
+        <p:spPr>
+          <a:xfrm>
+            <a:off x="1280160" y="3383280"/>
+            <a:ext cx="3383280" cy="594360"/>
           </a:xfrm>
           <a:prstGeom prst="rect">
             <a:avLst/>
@@ -8163,7 +8325,7 @@
           <a:p>
             <a:pPr algn="ctr">
               <a:spcAft>
-                <a:spcPts val="100"/>
+                <a:spcPts val="0"/>
               </a:spcAft>
             </a:pPr>
             <a:r>
@@ -8172,9 +8334,77 @@
                   <a:srgbClr val="FFFFFF"/>
                 </a:solidFill>
               </a:rPr>
-              <a:t>Component Tests</a:t>
-            </a:r>
-          </a:p>
+              <a:t>Integration Tests</a:t>
+            </a:r>
+          </a:p>
+        </p:txBody>
+      </p:sp>
+      <p:sp>
+        <p:nvSpPr>
+          <p:cNvPr id="10" name="Rounded Rectangle 9"/>
+          <p:cNvSpPr/>
+          <p:nvPr/>
+        </p:nvSpPr>
+        <p:spPr>
+          <a:xfrm>
+            <a:off x="1554480" y="2468880"/>
+            <a:ext cx="2834640" cy="685800"/>
+          </a:xfrm>
+          <a:prstGeom prst="roundRect">
+            <a:avLst/>
+          </a:prstGeom>
+          <a:solidFill>
+            <a:srgbClr val="0069B0"/>
+          </a:solidFill>
+          <a:ln w="31750">
+            <a:solidFill>
+              <a:srgbClr val="0099D6"/>
+            </a:solidFill>
+          </a:ln>
+        </p:spPr>
+        <p:style>
+          <a:lnRef idx="1">
+            <a:schemeClr val="accent1"/>
+          </a:lnRef>
+          <a:fillRef idx="3">
+            <a:schemeClr val="accent1"/>
+          </a:fillRef>
+          <a:effectRef idx="2">
+            <a:schemeClr val="accent1"/>
+          </a:effectRef>
+          <a:fontRef idx="minor">
+            <a:schemeClr val="lt1"/>
+          </a:fontRef>
+        </p:style>
+        <p:txBody>
+          <a:bodyPr rtlCol="0" anchor="ctr"/>
+          <a:lstStyle/>
+          <a:p>
+            <a:pPr algn="ctr"/>
+          </a:p>
+        </p:txBody>
+      </p:sp>
+      <p:sp>
+        <p:nvSpPr>
+          <p:cNvPr id="11" name="TextBox 10"/>
+          <p:cNvSpPr txBox="1"/>
+          <p:nvPr/>
+        </p:nvSpPr>
+        <p:spPr>
+          <a:xfrm>
+            <a:off x="1645920" y="2560320"/>
+            <a:ext cx="2651760" cy="594360"/>
+          </a:xfrm>
+          <a:prstGeom prst="rect">
+            <a:avLst/>
+          </a:prstGeom>
+          <a:noFill/>
+        </p:spPr>
+        <p:txBody>
+          <a:bodyPr wrap="square">
+            <a:spAutoFit/>
+          </a:bodyPr>
+          <a:lstStyle/>
           <a:p>
             <a:pPr algn="ctr">
               <a:spcAft>
@@ -8182,26 +8412,26 @@
               </a:spcAft>
             </a:pPr>
             <a:r>
-              <a:rPr sz="800" b="0">
-                <a:solidFill>
-                  <a:srgbClr val="BBBBBB"/>
-                </a:solidFill>
-              </a:rPr>
-              <a:t>Unit-level code coverage</a:t>
-            </a:r>
-          </a:p>
-        </p:txBody>
-      </p:sp>
-      <p:sp>
-        <p:nvSpPr>
-          <p:cNvPr id="6" name="Rounded Rectangle 5"/>
+              <a:rPr sz="1100" b="1">
+                <a:solidFill>
+                  <a:srgbClr val="FFFFFF"/>
+                </a:solidFill>
+              </a:rPr>
+              <a:t>E2E Tests</a:t>
+            </a:r>
+          </a:p>
+        </p:txBody>
+      </p:sp>
+      <p:sp>
+        <p:nvSpPr>
+          <p:cNvPr id="12" name="Rounded Rectangle 11"/>
           <p:cNvSpPr/>
           <p:nvPr/>
         </p:nvSpPr>
         <p:spPr>
           <a:xfrm>
-            <a:off x="1828800" y="3566160"/>
-            <a:ext cx="3657600" cy="822960"/>
+            <a:off x="1920240" y="1645920"/>
+            <a:ext cx="2103120" cy="685800"/>
           </a:xfrm>
           <a:prstGeom prst="roundRect">
             <a:avLst/>
@@ -8237,14 +8467,14 @@
       </p:sp>
       <p:sp>
         <p:nvSpPr>
-          <p:cNvPr id="7" name="TextBox 6"/>
-          <p:cNvSpPr txBox="1"/>
-          <p:nvPr/>
-        </p:nvSpPr>
-        <p:spPr>
-          <a:xfrm>
-            <a:off x="1965960" y="3657600"/>
-            <a:ext cx="3383280" cy="685800"/>
+          <p:cNvPr id="13" name="TextBox 12"/>
+          <p:cNvSpPr txBox="1"/>
+          <p:nvPr/>
+        </p:nvSpPr>
+        <p:spPr>
+          <a:xfrm>
+            <a:off x="2011680" y="1737360"/>
+            <a:ext cx="1920240" cy="594360"/>
           </a:xfrm>
           <a:prstGeom prst="rect">
             <a:avLst/>
@@ -8259,7 +8489,7 @@
           <a:p>
             <a:pPr algn="ctr">
               <a:spcAft>
-                <a:spcPts val="100"/>
+                <a:spcPts val="0"/>
               </a:spcAft>
             </a:pPr>
             <a:r>
@@ -8268,9 +8498,33 @@
                   <a:srgbClr val="FFFFFF"/>
                 </a:solidFill>
               </a:rPr>
-              <a:t>Integration Tests</a:t>
-            </a:r>
-          </a:p>
+              <a:t>Manual &amp;
+Exploratory</a:t>
+            </a:r>
+          </a:p>
+        </p:txBody>
+      </p:sp>
+      <p:sp>
+        <p:nvSpPr>
+          <p:cNvPr id="14" name="TextBox 13"/>
+          <p:cNvSpPr txBox="1"/>
+          <p:nvPr/>
+        </p:nvSpPr>
+        <p:spPr>
+          <a:xfrm>
+            <a:off x="45720" y="1554480"/>
+            <a:ext cx="365760" cy="4114800"/>
+          </a:xfrm>
+          <a:prstGeom prst="rect">
+            <a:avLst/>
+          </a:prstGeom>
+          <a:noFill/>
+        </p:spPr>
+        <p:txBody>
+          <a:bodyPr wrap="square">
+            <a:spAutoFit/>
+          </a:bodyPr>
+          <a:lstStyle/>
           <a:p>
             <a:pPr algn="ctr">
               <a:spcAft>
@@ -8278,145 +8532,84 @@
               </a:spcAft>
             </a:pPr>
             <a:r>
-              <a:rPr sz="800" b="0">
-                <a:solidFill>
-                  <a:srgbClr val="BBBBBB"/>
-                </a:solidFill>
-              </a:rPr>
-              <a:t>Module interfaces &amp; data flow</a:t>
-            </a:r>
-          </a:p>
-        </p:txBody>
-      </p:sp>
-      <p:sp>
-        <p:nvSpPr>
-          <p:cNvPr id="8" name="Rounded Rectangle 7"/>
-          <p:cNvSpPr/>
-          <p:nvPr/>
-        </p:nvSpPr>
-        <p:spPr>
-          <a:xfrm>
-            <a:off x="2286000" y="2560320"/>
-            <a:ext cx="2743200" cy="822960"/>
-          </a:xfrm>
-          <a:prstGeom prst="roundRect">
-            <a:avLst/>
-          </a:prstGeom>
-          <a:solidFill>
-            <a:srgbClr val="0069B0"/>
-          </a:solidFill>
-          <a:ln w="25400">
-            <a:solidFill>
-              <a:srgbClr val="0099D6"/>
-            </a:solidFill>
-          </a:ln>
-        </p:spPr>
-        <p:style>
-          <a:lnRef idx="1">
-            <a:schemeClr val="accent1"/>
-          </a:lnRef>
-          <a:fillRef idx="3">
-            <a:schemeClr val="accent1"/>
-          </a:fillRef>
-          <a:effectRef idx="2">
-            <a:schemeClr val="accent1"/>
-          </a:effectRef>
-          <a:fontRef idx="minor">
-            <a:schemeClr val="lt1"/>
-          </a:fontRef>
-        </p:style>
-        <p:txBody>
-          <a:bodyPr rtlCol="0" anchor="ctr"/>
-          <a:lstStyle/>
-          <a:p>
-            <a:pPr algn="ctr"/>
-          </a:p>
-        </p:txBody>
-      </p:sp>
-      <p:sp>
-        <p:nvSpPr>
-          <p:cNvPr id="9" name="TextBox 8"/>
-          <p:cNvSpPr txBox="1"/>
-          <p:nvPr/>
-        </p:nvSpPr>
-        <p:spPr>
-          <a:xfrm>
-            <a:off x="2423160" y="2651760"/>
-            <a:ext cx="2468880" cy="685800"/>
-          </a:xfrm>
-          <a:prstGeom prst="rect">
-            <a:avLst/>
-          </a:prstGeom>
-          <a:noFill/>
-        </p:spPr>
-        <p:txBody>
-          <a:bodyPr wrap="square">
-            <a:spAutoFit/>
-          </a:bodyPr>
-          <a:lstStyle/>
-          <a:p>
-            <a:pPr algn="ctr">
-              <a:spcAft>
-                <a:spcPts val="100"/>
+              <a:rPr sz="900" b="1">
+                <a:solidFill>
+                  <a:srgbClr val="888888"/>
+                </a:solidFill>
+              </a:rPr>
+              <a:t>Cost ↑</a:t>
+            </a:r>
+          </a:p>
+        </p:txBody>
+      </p:sp>
+      <p:sp>
+        <p:nvSpPr>
+          <p:cNvPr id="15" name="TextBox 14"/>
+          <p:cNvSpPr txBox="1"/>
+          <p:nvPr/>
+        </p:nvSpPr>
+        <p:spPr>
+          <a:xfrm>
+            <a:off x="5029200" y="5669280"/>
+            <a:ext cx="731520" cy="274320"/>
+          </a:xfrm>
+          <a:prstGeom prst="rect">
+            <a:avLst/>
+          </a:prstGeom>
+          <a:noFill/>
+        </p:spPr>
+        <p:txBody>
+          <a:bodyPr wrap="square">
+            <a:spAutoFit/>
+          </a:bodyPr>
+          <a:lstStyle/>
+          <a:p>
+            <a:pPr algn="l">
+              <a:spcAft>
+                <a:spcPts val="0"/>
+              </a:spcAft>
+            </a:pPr>
+            <a:r>
+              <a:rPr sz="900" b="1">
+                <a:solidFill>
+                  <a:srgbClr val="888888"/>
+                </a:solidFill>
+              </a:rPr>
+              <a:t>Speed →</a:t>
+            </a:r>
+          </a:p>
+        </p:txBody>
+      </p:sp>
+      <p:sp>
+        <p:nvSpPr>
+          <p:cNvPr id="16" name="TextBox 15"/>
+          <p:cNvSpPr txBox="1"/>
+          <p:nvPr/>
+        </p:nvSpPr>
+        <p:spPr>
+          <a:xfrm>
+            <a:off x="4663440" y="2560320"/>
+            <a:ext cx="1645920" cy="274320"/>
+          </a:xfrm>
+          <a:prstGeom prst="rect">
+            <a:avLst/>
+          </a:prstGeom>
+          <a:noFill/>
+        </p:spPr>
+        <p:txBody>
+          <a:bodyPr wrap="square">
+            <a:spAutoFit/>
+          </a:bodyPr>
+          <a:lstStyle/>
+          <a:p>
+            <a:pPr algn="l">
+              <a:spcAft>
+                <a:spcPts val="0"/>
               </a:spcAft>
             </a:pPr>
             <a:r>
               <a:rPr sz="1100" b="1">
                 <a:solidFill>
-                  <a:srgbClr val="FFFFFF"/>
-                </a:solidFill>
-              </a:rPr>
-              <a:t>System Verification</a:t>
-            </a:r>
-          </a:p>
-          <a:p>
-            <a:pPr algn="ctr">
-              <a:spcAft>
-                <a:spcPts val="0"/>
-              </a:spcAft>
-            </a:pPr>
-            <a:r>
-              <a:rPr sz="800" b="0">
-                <a:solidFill>
-                  <a:srgbClr val="BBBBBB"/>
-                </a:solidFill>
-              </a:rPr>
-              <a:t>Requirement-level verification
-against the deployed product</a:t>
-            </a:r>
-          </a:p>
-        </p:txBody>
-      </p:sp>
-      <p:sp>
-        <p:nvSpPr>
-          <p:cNvPr id="10" name="TextBox 9"/>
-          <p:cNvSpPr txBox="1"/>
-          <p:nvPr/>
-        </p:nvSpPr>
-        <p:spPr>
-          <a:xfrm>
-            <a:off x="5303520" y="2743200"/>
-            <a:ext cx="1371600" cy="274320"/>
-          </a:xfrm>
-          <a:prstGeom prst="rect">
-            <a:avLst/>
-          </a:prstGeom>
-          <a:noFill/>
-        </p:spPr>
-        <p:txBody>
-          <a:bodyPr wrap="square">
-            <a:spAutoFit/>
-          </a:bodyPr>
-          <a:lstStyle/>
-          <a:p>
-            <a:pPr algn="l">
-              <a:spcAft>
-                <a:spcPts val="0"/>
-              </a:spcAft>
-            </a:pPr>
-            <a:r>
-              <a:rPr sz="1000" b="1">
-                <a:solidFill>
                   <a:srgbClr val="0069B0"/>
                 </a:solidFill>
               </a:rPr>
@@ -8427,7 +8620,7 @@
       </p:sp>
       <p:sp>
         <p:nvSpPr>
-          <p:cNvPr id="11" name="TextBox 10"/>
+          <p:cNvPr id="17" name="TextBox 16"/>
           <p:cNvSpPr txBox="1"/>
           <p:nvPr/>
         </p:nvSpPr>
@@ -8465,7 +8658,7 @@
       </p:sp>
       <p:sp>
         <p:nvSpPr>
-          <p:cNvPr id="12" name="TextBox 11"/>
+          <p:cNvPr id="18" name="TextBox 17"/>
           <p:cNvSpPr txBox="1"/>
           <p:nvPr/>
         </p:nvSpPr>
@@ -8518,7 +8711,7 @@
       </p:sp>
       <p:sp>
         <p:nvSpPr>
-          <p:cNvPr id="13" name="TextBox 12"/>
+          <p:cNvPr id="19" name="TextBox 18"/>
           <p:cNvSpPr txBox="1"/>
           <p:nvPr/>
         </p:nvSpPr>
@@ -8549,7 +8742,7 @@
                   <a:srgbClr val="0069B0"/>
                 </a:solidFill>
               </a:rPr>
-              <a:t>Automated Verification</a:t>
+              <a:t>Automated E2E Verification</a:t>
             </a:r>
           </a:p>
           <a:p>
@@ -8564,14 +8757,14 @@
                   <a:srgbClr val="555555"/>
                 </a:solidFill>
               </a:rPr>
-              <a:t>BDD scenarios run against simulation logs after deployment. Results are captured automatically.</a:t>
-            </a:r>
-          </a:p>
-        </p:txBody>
-      </p:sp>
-      <p:sp>
-        <p:nvSpPr>
-          <p:cNvPr id="14" name="TextBox 13"/>
+              <a:t>BDD scenarios run against simulation logs after product deployment. Results captured automatically.</a:t>
+            </a:r>
+          </a:p>
+        </p:txBody>
+      </p:sp>
+      <p:sp>
+        <p:nvSpPr>
+          <p:cNvPr id="20" name="TextBox 19"/>
           <p:cNvSpPr txBox="1"/>
           <p:nvPr/>
         </p:nvSpPr>
@@ -8624,7 +8817,7 @@
       </p:sp>
       <p:sp>
         <p:nvSpPr>
-          <p:cNvPr id="15" name="TextBox 14"/>
+          <p:cNvPr id="21" name="TextBox 20"/>
           <p:cNvSpPr txBox="1"/>
           <p:nvPr/>
         </p:nvSpPr>
@@ -8677,7 +8870,7 @@
       </p:sp>
       <p:sp>
         <p:nvSpPr>
-          <p:cNvPr id="16" name="TextBox 15"/>
+          <p:cNvPr id="22" name="TextBox 21"/>
           <p:cNvSpPr txBox="1"/>
           <p:nvPr/>
         </p:nvSpPr>
@@ -8730,13 +8923,13 @@
       </p:sp>
       <p:sp>
         <p:nvSpPr>
-          <p:cNvPr id="17" name="TextBox 16"/>
-          <p:cNvSpPr txBox="1"/>
-          <p:nvPr/>
-        </p:nvSpPr>
-        <p:spPr>
-          <a:xfrm>
-            <a:off x="731520" y="5943600"/>
+          <p:cNvPr id="23" name="TextBox 22"/>
+          <p:cNvSpPr txBox="1"/>
+          <p:nvPr/>
+        </p:nvSpPr>
+        <p:spPr>
+          <a:xfrm>
+            <a:off x="731520" y="6035040"/>
             <a:ext cx="10972800" cy="274320"/>
           </a:xfrm>
           <a:prstGeom prst="rect">
@@ -8761,14 +8954,14 @@
                   <a:srgbClr val="888888"/>
                 </a:solidFill>
               </a:rPr>
-              <a:t>Component and Integration tests are owned by developers. The MBSE pipeline adds System Verification with full requirement traceability from the Cameo model.</a:t>
-            </a:r>
-          </a:p>
-        </p:txBody>
-      </p:sp>
-      <p:sp>
-        <p:nvSpPr>
-          <p:cNvPr id="18" name="TextBox 17"/>
+              <a:t>Static analysis, unit, and integration tests are owned by developers. The MBSE pipeline automates the E2E layer with full requirement traceability.</a:t>
+            </a:r>
+          </a:p>
+        </p:txBody>
+      </p:sp>
+      <p:sp>
+        <p:nvSpPr>
+          <p:cNvPr id="24" name="TextBox 23"/>
           <p:cNvSpPr txBox="1"/>
           <p:nvPr/>
         </p:nvSpPr>

</xml_diff>

<commit_message>
Fix pyramid: all non-pipeline layers use same grey
Unit Tests and Static Analysis were dark navy — changed to grey
to match Integration and Manual layers. Only E2E is highlighted.

Co-Authored-By: Claude Opus 4.6 (1M context) <noreply@anthropic.com>
</commit_message>
<xml_diff>
--- a/docs/presentations/MBSE_Pipeline_Executive_Brief.pptx
+++ b/docs/presentations/MBSE_Pipeline_Executive_Brief.pptx
@@ -8111,7 +8111,7 @@
             <a:avLst/>
           </a:prstGeom>
           <a:solidFill>
-            <a:srgbClr val="003057"/>
+            <a:srgbClr val="888888"/>
           </a:solidFill>
           <a:ln>
             <a:noFill/>
@@ -8192,7 +8192,7 @@
             <a:avLst/>
           </a:prstGeom>
           <a:solidFill>
-            <a:srgbClr val="004A87"/>
+            <a:srgbClr val="888888"/>
           </a:solidFill>
           <a:ln>
             <a:noFill/>

</xml_diff>

<commit_message>
Add Cyber slide: SBOM & vulnerability scanning + compliance
Slide 10: Cyber: Supply Chain Security
- Left: Automated scanning pipeline (Container Image -> Syft SBOM ->
  Grype Scan -> Policy Gate) with artifact descriptions
- Right: Compliance value (EO 14028, NIST SP 800-218, supply chain
  transparency, audit-ready evidence, air-gapped compatible)
- Bottom callout: every build produces SBOM + vuln scan

Deck is now 12 slides.

Co-Authored-By: Claude Opus 4.6 (1M context) <noreply@anthropic.com>
</commit_message>
<xml_diff>
--- a/docs/presentations/MBSE_Pipeline_Executive_Brief.pptx
+++ b/docs/presentations/MBSE_Pipeline_Executive_Brief.pptx
@@ -16,6 +16,7 @@
     <p:sldId id="264" r:id="rId15"/>
     <p:sldId id="265" r:id="rId16"/>
     <p:sldId id="266" r:id="rId17"/>
+    <p:sldId id="267" r:id="rId18"/>
   </p:sldIdLst>
   <p:sldSz cx="12191695" cy="6858000" type="screen4x3"/>
   <p:notesSz cx="6858000" cy="9144000"/>
@@ -3207,7 +3208,7 @@
                   <a:srgbClr val="888888"/>
                 </a:solidFill>
               </a:rPr>
-              <a:t>1 / 11</a:t>
+              <a:t>1 / 12</a:t>
             </a:r>
           </a:p>
         </p:txBody>
@@ -3246,7 +3247,7 @@
         </p:nvSpPr>
         <p:spPr>
           <a:xfrm>
-            <a:off x="731520" y="457200"/>
+            <a:off x="731520" y="365760"/>
             <a:ext cx="10058400" cy="457200"/>
           </a:xfrm>
           <a:prstGeom prst="rect">
@@ -3271,7 +3272,7 @@
                   <a:srgbClr val="0D1B2A"/>
                 </a:solidFill>
               </a:rPr>
-              <a:t>Traceability &amp; Audit Evidence</a:t>
+              <a:t>Cyber: Supply Chain Security</a:t>
             </a:r>
           </a:p>
         </p:txBody>
@@ -3284,8 +3285,8 @@
         </p:nvSpPr>
         <p:spPr>
           <a:xfrm>
-            <a:off x="731520" y="960120"/>
-            <a:ext cx="10058400" cy="274320"/>
+            <a:off x="731520" y="868680"/>
+            <a:ext cx="9144000" cy="320040"/>
           </a:xfrm>
           <a:prstGeom prst="rect">
             <a:avLst/>
@@ -3309,27 +3310,65 @@
                   <a:srgbClr val="555555"/>
                 </a:solidFill>
               </a:rPr>
-              <a:t>Every pipeline run produces a complete, machine-generated evidence chain — no manual assembly required.</a:t>
-            </a:r>
-          </a:p>
-        </p:txBody>
-      </p:sp>
-      <p:sp>
-        <p:nvSpPr>
-          <p:cNvPr id="4" name="Rounded Rectangle 3"/>
+              <a:t>Every container image is scanned for known vulnerabilities before deployment. A full Software Bill of Materials is generated on every build.</a:t>
+            </a:r>
+          </a:p>
+        </p:txBody>
+      </p:sp>
+      <p:sp>
+        <p:nvSpPr>
+          <p:cNvPr id="4" name="TextBox 3"/>
+          <p:cNvSpPr txBox="1"/>
+          <p:nvPr/>
+        </p:nvSpPr>
+        <p:spPr>
+          <a:xfrm>
+            <a:off x="731520" y="1463040"/>
+            <a:ext cx="4572000" cy="274320"/>
+          </a:xfrm>
+          <a:prstGeom prst="rect">
+            <a:avLst/>
+          </a:prstGeom>
+          <a:noFill/>
+        </p:spPr>
+        <p:txBody>
+          <a:bodyPr wrap="square">
+            <a:spAutoFit/>
+          </a:bodyPr>
+          <a:lstStyle/>
+          <a:p>
+            <a:pPr algn="l">
+              <a:spcAft>
+                <a:spcPts val="0"/>
+              </a:spcAft>
+            </a:pPr>
+            <a:r>
+              <a:rPr sz="1600" b="1">
+                <a:solidFill>
+                  <a:srgbClr val="0D1B2A"/>
+                </a:solidFill>
+              </a:rPr>
+              <a:t>Automated Scanning Pipeline</a:t>
+            </a:r>
+          </a:p>
+        </p:txBody>
+      </p:sp>
+      <p:sp>
+        <p:nvSpPr>
+          <p:cNvPr id="5" name="Rounded Rectangle 4"/>
           <p:cNvSpPr/>
           <p:nvPr/>
         </p:nvSpPr>
         <p:spPr>
           <a:xfrm>
-            <a:off x="457200" y="1554480"/>
-            <a:ext cx="2011680" cy="777240"/>
+            <a:off x="457200" y="1920240"/>
+            <a:ext cx="2560320" cy="777240"/>
           </a:xfrm>
           <a:prstGeom prst="roundRect">
             <a:avLst/>
           </a:prstGeom>
           <a:solidFill>
-            <a:srgbClr val="003057"/>
+            <a:srgbClr val="888888"/>
           </a:solidFill>
           <a:ln>
             <a:noFill/>
@@ -3359,14 +3398,14 @@
       </p:sp>
       <p:sp>
         <p:nvSpPr>
-          <p:cNvPr id="5" name="TextBox 4"/>
-          <p:cNvSpPr txBox="1"/>
-          <p:nvPr/>
-        </p:nvSpPr>
-        <p:spPr>
-          <a:xfrm>
-            <a:off x="548640" y="1627632"/>
-            <a:ext cx="1828800" cy="685800"/>
+          <p:cNvPr id="6" name="TextBox 5"/>
+          <p:cNvSpPr txBox="1"/>
+          <p:nvPr/>
+        </p:nvSpPr>
+        <p:spPr>
+          <a:xfrm>
+            <a:off x="548640" y="1965960"/>
+            <a:ext cx="2377440" cy="685800"/>
           </a:xfrm>
           <a:prstGeom prst="rect">
             <a:avLst/>
@@ -3390,8 +3429,7 @@
                   <a:srgbClr val="FFFFFF"/>
                 </a:solidFill>
               </a:rPr>
-              <a:t>Requirement
-in Cameo</a:t>
+              <a:t>Container Image</a:t>
             </a:r>
           </a:p>
           <a:p>
@@ -3406,118 +3444,22 @@
                   <a:srgbClr val="BBBBBB"/>
                 </a:solidFill>
               </a:rPr>
-              <a:t/>
-            </a:r>
-          </a:p>
-        </p:txBody>
-      </p:sp>
-      <p:sp>
-        <p:nvSpPr>
-          <p:cNvPr id="6" name="Rounded Rectangle 5"/>
+              <a:t>Product containers
+built by CI/CD</a:t>
+            </a:r>
+          </a:p>
+        </p:txBody>
+      </p:sp>
+      <p:sp>
+        <p:nvSpPr>
+          <p:cNvPr id="7" name="Rounded Rectangle 6"/>
           <p:cNvSpPr/>
           <p:nvPr/>
         </p:nvSpPr>
         <p:spPr>
           <a:xfrm>
-            <a:off x="2651760" y="1554480"/>
-            <a:ext cx="2011680" cy="777240"/>
-          </a:xfrm>
-          <a:prstGeom prst="roundRect">
-            <a:avLst/>
-          </a:prstGeom>
-          <a:solidFill>
-            <a:srgbClr val="004A87"/>
-          </a:solidFill>
-          <a:ln>
-            <a:noFill/>
-          </a:ln>
-        </p:spPr>
-        <p:style>
-          <a:lnRef idx="1">
-            <a:schemeClr val="accent1"/>
-          </a:lnRef>
-          <a:fillRef idx="3">
-            <a:schemeClr val="accent1"/>
-          </a:fillRef>
-          <a:effectRef idx="2">
-            <a:schemeClr val="accent1"/>
-          </a:effectRef>
-          <a:fontRef idx="minor">
-            <a:schemeClr val="lt1"/>
-          </a:fontRef>
-        </p:style>
-        <p:txBody>
-          <a:bodyPr rtlCol="0" anchor="ctr"/>
-          <a:lstStyle/>
-          <a:p>
-            <a:pPr algn="ctr"/>
-          </a:p>
-        </p:txBody>
-      </p:sp>
-      <p:sp>
-        <p:nvSpPr>
-          <p:cNvPr id="7" name="TextBox 6"/>
-          <p:cNvSpPr txBox="1"/>
-          <p:nvPr/>
-        </p:nvSpPr>
-        <p:spPr>
-          <a:xfrm>
-            <a:off x="2743200" y="1627632"/>
-            <a:ext cx="1828800" cy="685800"/>
-          </a:xfrm>
-          <a:prstGeom prst="rect">
-            <a:avLst/>
-          </a:prstGeom>
-          <a:noFill/>
-        </p:spPr>
-        <p:txBody>
-          <a:bodyPr wrap="square">
-            <a:spAutoFit/>
-          </a:bodyPr>
-          <a:lstStyle/>
-          <a:p>
-            <a:pPr algn="l">
-              <a:spcAft>
-                <a:spcPts val="100"/>
-              </a:spcAft>
-            </a:pPr>
-            <a:r>
-              <a:rPr sz="900" b="1">
-                <a:solidFill>
-                  <a:srgbClr val="FFFFFF"/>
-                </a:solidFill>
-              </a:rPr>
-              <a:t>Verification
-Criteria (VC)</a:t>
-            </a:r>
-          </a:p>
-          <a:p>
-            <a:pPr algn="l">
-              <a:spcAft>
-                <a:spcPts val="0"/>
-              </a:spcAft>
-            </a:pPr>
-            <a:r>
-              <a:rPr sz="700" b="0">
-                <a:solidFill>
-                  <a:srgbClr val="BBBBBB"/>
-                </a:solidFill>
-              </a:rPr>
-              <a:t/>
-            </a:r>
-          </a:p>
-        </p:txBody>
-      </p:sp>
-      <p:sp>
-        <p:nvSpPr>
-          <p:cNvPr id="8" name="Rounded Rectangle 7"/>
-          <p:cNvSpPr/>
-          <p:nvPr/>
-        </p:nvSpPr>
-        <p:spPr>
-          <a:xfrm>
-            <a:off x="4846320" y="1554480"/>
-            <a:ext cx="2011680" cy="777240"/>
+            <a:off x="3108960" y="1920240"/>
+            <a:ext cx="2560320" cy="777240"/>
           </a:xfrm>
           <a:prstGeom prst="roundRect">
             <a:avLst/>
@@ -3553,14 +3495,14 @@
       </p:sp>
       <p:sp>
         <p:nvSpPr>
-          <p:cNvPr id="9" name="TextBox 8"/>
-          <p:cNvSpPr txBox="1"/>
-          <p:nvPr/>
-        </p:nvSpPr>
-        <p:spPr>
-          <a:xfrm>
-            <a:off x="4937760" y="1627632"/>
-            <a:ext cx="1828800" cy="685800"/>
+          <p:cNvPr id="8" name="TextBox 7"/>
+          <p:cNvSpPr txBox="1"/>
+          <p:nvPr/>
+        </p:nvSpPr>
+        <p:spPr>
+          <a:xfrm>
+            <a:off x="3200400" y="1965960"/>
+            <a:ext cx="2377440" cy="685800"/>
           </a:xfrm>
           <a:prstGeom prst="rect">
             <a:avLst/>
@@ -3584,8 +3526,7 @@
                   <a:srgbClr val="FFFFFF"/>
                 </a:solidFill>
               </a:rPr>
-              <a:t>Gherkin
-Scenario</a:t>
+              <a:t>→  Syft (SBOM)</a:t>
             </a:r>
           </a:p>
           <a:p>
@@ -3600,21 +3541,22 @@
                   <a:srgbClr val="BBBBBB"/>
                 </a:solidFill>
               </a:rPr>
-              <a:t/>
-            </a:r>
-          </a:p>
-        </p:txBody>
-      </p:sp>
-      <p:sp>
-        <p:nvSpPr>
-          <p:cNvPr id="10" name="Rounded Rectangle 9"/>
+              <a:t>Generates CycloneDX
+Software Bill of Materials</a:t>
+            </a:r>
+          </a:p>
+        </p:txBody>
+      </p:sp>
+      <p:sp>
+        <p:nvSpPr>
+          <p:cNvPr id="9" name="Rounded Rectangle 8"/>
           <p:cNvSpPr/>
           <p:nvPr/>
         </p:nvSpPr>
         <p:spPr>
           <a:xfrm>
-            <a:off x="7040880" y="1554480"/>
-            <a:ext cx="2011680" cy="777240"/>
+            <a:off x="5760720" y="1920240"/>
+            <a:ext cx="2560320" cy="777240"/>
           </a:xfrm>
           <a:prstGeom prst="roundRect">
             <a:avLst/>
@@ -3650,14 +3592,14 @@
       </p:sp>
       <p:sp>
         <p:nvSpPr>
-          <p:cNvPr id="11" name="TextBox 10"/>
-          <p:cNvSpPr txBox="1"/>
-          <p:nvPr/>
-        </p:nvSpPr>
-        <p:spPr>
-          <a:xfrm>
-            <a:off x="7132320" y="1627632"/>
-            <a:ext cx="1828800" cy="685800"/>
+          <p:cNvPr id="10" name="TextBox 9"/>
+          <p:cNvSpPr txBox="1"/>
+          <p:nvPr/>
+        </p:nvSpPr>
+        <p:spPr>
+          <a:xfrm>
+            <a:off x="5852160" y="1965960"/>
+            <a:ext cx="2377440" cy="685800"/>
           </a:xfrm>
           <a:prstGeom prst="rect">
             <a:avLst/>
@@ -3681,8 +3623,7 @@
                   <a:srgbClr val="FFFFFF"/>
                 </a:solidFill>
               </a:rPr>
-              <a:t>BDD Test
-Result</a:t>
+              <a:t>→  Grype (Scan)</a:t>
             </a:r>
           </a:p>
           <a:p>
@@ -3697,27 +3638,28 @@
                   <a:srgbClr val="BBBBBB"/>
                 </a:solidFill>
               </a:rPr>
-              <a:t/>
-            </a:r>
-          </a:p>
-        </p:txBody>
-      </p:sp>
-      <p:sp>
-        <p:nvSpPr>
-          <p:cNvPr id="12" name="Rounded Rectangle 11"/>
+              <a:t>Scans SBOM against
+known vulnerability DBs</a:t>
+            </a:r>
+          </a:p>
+        </p:txBody>
+      </p:sp>
+      <p:sp>
+        <p:nvSpPr>
+          <p:cNvPr id="11" name="Rounded Rectangle 10"/>
           <p:cNvSpPr/>
           <p:nvPr/>
         </p:nvSpPr>
         <p:spPr>
           <a:xfrm>
-            <a:off x="9235440" y="1554480"/>
-            <a:ext cx="2011680" cy="777240"/>
+            <a:off x="8412480" y="1920240"/>
+            <a:ext cx="2560320" cy="777240"/>
           </a:xfrm>
           <a:prstGeom prst="roundRect">
             <a:avLst/>
           </a:prstGeom>
           <a:solidFill>
-            <a:srgbClr val="0099D6"/>
+            <a:srgbClr val="B45309"/>
           </a:solidFill>
           <a:ln>
             <a:noFill/>
@@ -3747,54 +3689,92 @@
       </p:sp>
       <p:sp>
         <p:nvSpPr>
+          <p:cNvPr id="12" name="TextBox 11"/>
+          <p:cNvSpPr txBox="1"/>
+          <p:nvPr/>
+        </p:nvSpPr>
+        <p:spPr>
+          <a:xfrm>
+            <a:off x="8503920" y="1965960"/>
+            <a:ext cx="2377440" cy="685800"/>
+          </a:xfrm>
+          <a:prstGeom prst="rect">
+            <a:avLst/>
+          </a:prstGeom>
+          <a:noFill/>
+        </p:spPr>
+        <p:txBody>
+          <a:bodyPr wrap="square">
+            <a:spAutoFit/>
+          </a:bodyPr>
+          <a:lstStyle/>
+          <a:p>
+            <a:pPr algn="l">
+              <a:spcAft>
+                <a:spcPts val="100"/>
+              </a:spcAft>
+            </a:pPr>
+            <a:r>
+              <a:rPr sz="900" b="1">
+                <a:solidFill>
+                  <a:srgbClr val="FFFFFF"/>
+                </a:solidFill>
+              </a:rPr>
+              <a:t>→  Policy Gate</a:t>
+            </a:r>
+          </a:p>
+          <a:p>
+            <a:pPr algn="l">
+              <a:spcAft>
+                <a:spcPts val="0"/>
+              </a:spcAft>
+            </a:pPr>
+            <a:r>
+              <a:rPr sz="700" b="0">
+                <a:solidFill>
+                  <a:srgbClr val="BBBBBB"/>
+                </a:solidFill>
+              </a:rPr>
+              <a:t>Fail on Critical/High
+Pass with advisory</a:t>
+            </a:r>
+          </a:p>
+        </p:txBody>
+      </p:sp>
+      <p:sp>
+        <p:nvSpPr>
           <p:cNvPr id="13" name="TextBox 12"/>
           <p:cNvSpPr txBox="1"/>
           <p:nvPr/>
         </p:nvSpPr>
         <p:spPr>
           <a:xfrm>
-            <a:off x="9326880" y="1627632"/>
-            <a:ext cx="1828800" cy="685800"/>
-          </a:xfrm>
-          <a:prstGeom prst="rect">
-            <a:avLst/>
-          </a:prstGeom>
-          <a:noFill/>
-        </p:spPr>
-        <p:txBody>
-          <a:bodyPr wrap="square">
-            <a:spAutoFit/>
-          </a:bodyPr>
-          <a:lstStyle/>
-          <a:p>
-            <a:pPr algn="l">
-              <a:spcAft>
-                <a:spcPts val="100"/>
-              </a:spcAft>
-            </a:pPr>
-            <a:r>
-              <a:rPr sz="900" b="1">
-                <a:solidFill>
-                  <a:srgbClr val="FFFFFF"/>
-                </a:solidFill>
-              </a:rPr>
-              <a:t>Deployment
-Pipeline Report</a:t>
-            </a:r>
-          </a:p>
-          <a:p>
-            <a:pPr algn="l">
-              <a:spcAft>
-                <a:spcPts val="0"/>
-              </a:spcAft>
-            </a:pPr>
-            <a:r>
-              <a:rPr sz="700" b="0">
-                <a:solidFill>
-                  <a:srgbClr val="BBBBBB"/>
-                </a:solidFill>
-              </a:rPr>
-              <a:t/>
+            <a:off x="731520" y="3017520"/>
+            <a:ext cx="4572000" cy="274320"/>
+          </a:xfrm>
+          <a:prstGeom prst="rect">
+            <a:avLst/>
+          </a:prstGeom>
+          <a:noFill/>
+        </p:spPr>
+        <p:txBody>
+          <a:bodyPr wrap="square">
+            <a:spAutoFit/>
+          </a:bodyPr>
+          <a:lstStyle/>
+          <a:p>
+            <a:pPr algn="l">
+              <a:spcAft>
+                <a:spcPts val="0"/>
+              </a:spcAft>
+            </a:pPr>
+            <a:r>
+              <a:rPr sz="1400" b="1">
+                <a:solidFill>
+                  <a:srgbClr val="0D1B2A"/>
+                </a:solidFill>
+              </a:rPr>
+              <a:t>What Gets Produced</a:t>
             </a:r>
           </a:p>
         </p:txBody>
@@ -3807,8 +3787,265 @@
         </p:nvSpPr>
         <p:spPr>
           <a:xfrm>
-            <a:off x="731520" y="2743200"/>
-            <a:ext cx="4572000" cy="274320"/>
+            <a:off x="731520" y="3383280"/>
+            <a:ext cx="5029200" cy="548640"/>
+          </a:xfrm>
+          <a:prstGeom prst="rect">
+            <a:avLst/>
+          </a:prstGeom>
+          <a:noFill/>
+        </p:spPr>
+        <p:txBody>
+          <a:bodyPr wrap="square">
+            <a:spAutoFit/>
+          </a:bodyPr>
+          <a:lstStyle/>
+          <a:p>
+            <a:pPr algn="l">
+              <a:spcAft>
+                <a:spcPts val="200"/>
+              </a:spcAft>
+            </a:pPr>
+            <a:r>
+              <a:rPr sz="1100" b="1">
+                <a:solidFill>
+                  <a:srgbClr val="0069B0"/>
+                </a:solidFill>
+              </a:rPr>
+              <a:t>SBOM (CycloneDX)</a:t>
+            </a:r>
+          </a:p>
+          <a:p>
+            <a:pPr algn="l">
+              <a:spcAft>
+                <a:spcPts val="0"/>
+              </a:spcAft>
+            </a:pPr>
+            <a:r>
+              <a:rPr sz="900" b="0">
+                <a:solidFill>
+                  <a:srgbClr val="555555"/>
+                </a:solidFill>
+              </a:rPr>
+              <a:t>Complete inventory of every software component, version, and source in the deployed artifact.</a:t>
+            </a:r>
+          </a:p>
+        </p:txBody>
+      </p:sp>
+      <p:sp>
+        <p:nvSpPr>
+          <p:cNvPr id="15" name="TextBox 14"/>
+          <p:cNvSpPr txBox="1"/>
+          <p:nvPr/>
+        </p:nvSpPr>
+        <p:spPr>
+          <a:xfrm>
+            <a:off x="731520" y="3977640"/>
+            <a:ext cx="5029200" cy="548640"/>
+          </a:xfrm>
+          <a:prstGeom prst="rect">
+            <a:avLst/>
+          </a:prstGeom>
+          <a:noFill/>
+        </p:spPr>
+        <p:txBody>
+          <a:bodyPr wrap="square">
+            <a:spAutoFit/>
+          </a:bodyPr>
+          <a:lstStyle/>
+          <a:p>
+            <a:pPr algn="l">
+              <a:spcAft>
+                <a:spcPts val="200"/>
+              </a:spcAft>
+            </a:pPr>
+            <a:r>
+              <a:rPr sz="1100" b="1">
+                <a:solidFill>
+                  <a:srgbClr val="0069B0"/>
+                </a:solidFill>
+              </a:rPr>
+              <a:t>Vulnerability Report</a:t>
+            </a:r>
+          </a:p>
+          <a:p>
+            <a:pPr algn="l">
+              <a:spcAft>
+                <a:spcPts val="0"/>
+              </a:spcAft>
+            </a:pPr>
+            <a:r>
+              <a:rPr sz="900" b="0">
+                <a:solidFill>
+                  <a:srgbClr val="555555"/>
+                </a:solidFill>
+              </a:rPr>
+              <a:t>CVE-level findings with severity, affected package, version, and fix availability.</a:t>
+            </a:r>
+          </a:p>
+        </p:txBody>
+      </p:sp>
+      <p:sp>
+        <p:nvSpPr>
+          <p:cNvPr id="16" name="TextBox 15"/>
+          <p:cNvSpPr txBox="1"/>
+          <p:nvPr/>
+        </p:nvSpPr>
+        <p:spPr>
+          <a:xfrm>
+            <a:off x="731520" y="4572000"/>
+            <a:ext cx="5029200" cy="548640"/>
+          </a:xfrm>
+          <a:prstGeom prst="rect">
+            <a:avLst/>
+          </a:prstGeom>
+          <a:noFill/>
+        </p:spPr>
+        <p:txBody>
+          <a:bodyPr wrap="square">
+            <a:spAutoFit/>
+          </a:bodyPr>
+          <a:lstStyle/>
+          <a:p>
+            <a:pPr algn="l">
+              <a:spcAft>
+                <a:spcPts val="200"/>
+              </a:spcAft>
+            </a:pPr>
+            <a:r>
+              <a:rPr sz="1100" b="1">
+                <a:solidFill>
+                  <a:srgbClr val="0069B0"/>
+                </a:solidFill>
+              </a:rPr>
+              <a:t>Policy Verdict</a:t>
+            </a:r>
+          </a:p>
+          <a:p>
+            <a:pPr algn="l">
+              <a:spcAft>
+                <a:spcPts val="0"/>
+              </a:spcAft>
+            </a:pPr>
+            <a:r>
+              <a:rPr sz="900" b="0">
+                <a:solidFill>
+                  <a:srgbClr val="555555"/>
+                </a:solidFill>
+              </a:rPr>
+              <a:t>PASS / WARNING / FAIL based on configurable severity thresholds. Blocks deployment on Critical/High.</a:t>
+            </a:r>
+          </a:p>
+        </p:txBody>
+      </p:sp>
+      <p:sp>
+        <p:nvSpPr>
+          <p:cNvPr id="17" name="TextBox 16"/>
+          <p:cNvSpPr txBox="1"/>
+          <p:nvPr/>
+        </p:nvSpPr>
+        <p:spPr>
+          <a:xfrm>
+            <a:off x="731520" y="5166360"/>
+            <a:ext cx="5029200" cy="548640"/>
+          </a:xfrm>
+          <a:prstGeom prst="rect">
+            <a:avLst/>
+          </a:prstGeom>
+          <a:noFill/>
+        </p:spPr>
+        <p:txBody>
+          <a:bodyPr wrap="square">
+            <a:spAutoFit/>
+          </a:bodyPr>
+          <a:lstStyle/>
+          <a:p>
+            <a:pPr algn="l">
+              <a:spcAft>
+                <a:spcPts val="200"/>
+              </a:spcAft>
+            </a:pPr>
+            <a:r>
+              <a:rPr sz="1100" b="1">
+                <a:solidFill>
+                  <a:srgbClr val="0069B0"/>
+                </a:solidFill>
+              </a:rPr>
+              <a:t>Severity Dashboard</a:t>
+            </a:r>
+          </a:p>
+          <a:p>
+            <a:pPr algn="l">
+              <a:spcAft>
+                <a:spcPts val="0"/>
+              </a:spcAft>
+            </a:pPr>
+            <a:r>
+              <a:rPr sz="900" b="0">
+                <a:solidFill>
+                  <a:srgbClr val="555555"/>
+                </a:solidFill>
+              </a:rPr>
+              <a:t>Visual breakdown by severity level in the Deployment Pipeline Report — filterable, searchable, CSV-exportable.</a:t>
+            </a:r>
+          </a:p>
+        </p:txBody>
+      </p:sp>
+      <p:sp>
+        <p:nvSpPr>
+          <p:cNvPr id="18" name="Rounded Rectangle 17"/>
+          <p:cNvSpPr/>
+          <p:nvPr/>
+        </p:nvSpPr>
+        <p:spPr>
+          <a:xfrm>
+            <a:off x="6217920" y="1371600"/>
+            <a:ext cx="5303520" cy="4572000"/>
+          </a:xfrm>
+          <a:prstGeom prst="roundRect">
+            <a:avLst/>
+          </a:prstGeom>
+          <a:solidFill>
+            <a:srgbClr val="F4F7FA"/>
+          </a:solidFill>
+          <a:ln w="12700">
+            <a:solidFill>
+              <a:srgbClr val="D0E8F8"/>
+            </a:solidFill>
+          </a:ln>
+        </p:spPr>
+        <p:style>
+          <a:lnRef idx="1">
+            <a:schemeClr val="accent1"/>
+          </a:lnRef>
+          <a:fillRef idx="3">
+            <a:schemeClr val="accent1"/>
+          </a:fillRef>
+          <a:effectRef idx="2">
+            <a:schemeClr val="accent1"/>
+          </a:effectRef>
+          <a:fontRef idx="minor">
+            <a:schemeClr val="lt1"/>
+          </a:fontRef>
+        </p:style>
+        <p:txBody>
+          <a:bodyPr rtlCol="0" anchor="ctr"/>
+          <a:lstStyle/>
+          <a:p>
+            <a:pPr algn="ctr"/>
+          </a:p>
+        </p:txBody>
+      </p:sp>
+      <p:sp>
+        <p:nvSpPr>
+          <p:cNvPr id="19" name="TextBox 18"/>
+          <p:cNvSpPr txBox="1"/>
+          <p:nvPr/>
+        </p:nvSpPr>
+        <p:spPr>
+          <a:xfrm>
+            <a:off x="6400800" y="1554480"/>
+            <a:ext cx="4937760" cy="274320"/>
           </a:xfrm>
           <a:prstGeom prst="rect">
             <a:avLst/>
@@ -3832,21 +4069,21 @@
                   <a:srgbClr val="0D1B2A"/>
                 </a:solidFill>
               </a:rPr>
-              <a:t>What This Means for Compliance</a:t>
-            </a:r>
-          </a:p>
-        </p:txBody>
-      </p:sp>
-      <p:sp>
-        <p:nvSpPr>
-          <p:cNvPr id="15" name="TextBox 14"/>
-          <p:cNvSpPr txBox="1"/>
-          <p:nvPr/>
-        </p:nvSpPr>
-        <p:spPr>
-          <a:xfrm>
-            <a:off x="731520" y="3200400"/>
-            <a:ext cx="5029200" cy="822960"/>
+              <a:t>Why This Matters for Compliance</a:t>
+            </a:r>
+          </a:p>
+        </p:txBody>
+      </p:sp>
+      <p:sp>
+        <p:nvSpPr>
+          <p:cNvPr id="20" name="TextBox 19"/>
+          <p:cNvSpPr txBox="1"/>
+          <p:nvPr/>
+        </p:nvSpPr>
+        <p:spPr>
+          <a:xfrm>
+            <a:off x="6400800" y="2011680"/>
+            <a:ext cx="4937760" cy="731520"/>
           </a:xfrm>
           <a:prstGeom prst="rect">
             <a:avLst/>
@@ -3865,299 +4102,329 @@
               </a:spcAft>
             </a:pPr>
             <a:r>
-              <a:rPr sz="1200" b="1">
+              <a:rPr sz="1100" b="1">
+                <a:solidFill>
+                  <a:srgbClr val="0069B0"/>
+                </a:solidFill>
+              </a:rPr>
+              <a:t>Executive Order 14028</a:t>
+            </a:r>
+          </a:p>
+          <a:p>
+            <a:pPr algn="l">
+              <a:spcAft>
+                <a:spcPts val="0"/>
+              </a:spcAft>
+            </a:pPr>
+            <a:r>
+              <a:rPr sz="800" b="0">
+                <a:solidFill>
+                  <a:srgbClr val="555555"/>
+                </a:solidFill>
+              </a:rPr>
+              <a:t>Federal mandate requiring SBOMs for all software sold to the government. The pipeline generates CycloneDX SBOMs automatically on every build.</a:t>
+            </a:r>
+          </a:p>
+        </p:txBody>
+      </p:sp>
+      <p:sp>
+        <p:nvSpPr>
+          <p:cNvPr id="21" name="TextBox 20"/>
+          <p:cNvSpPr txBox="1"/>
+          <p:nvPr/>
+        </p:nvSpPr>
+        <p:spPr>
+          <a:xfrm>
+            <a:off x="6400800" y="2788920"/>
+            <a:ext cx="4937760" cy="731520"/>
+          </a:xfrm>
+          <a:prstGeom prst="rect">
+            <a:avLst/>
+          </a:prstGeom>
+          <a:noFill/>
+        </p:spPr>
+        <p:txBody>
+          <a:bodyPr wrap="square">
+            <a:spAutoFit/>
+          </a:bodyPr>
+          <a:lstStyle/>
+          <a:p>
+            <a:pPr algn="l">
+              <a:spcAft>
+                <a:spcPts val="200"/>
+              </a:spcAft>
+            </a:pPr>
+            <a:r>
+              <a:rPr sz="1100" b="1">
+                <a:solidFill>
+                  <a:srgbClr val="0069B0"/>
+                </a:solidFill>
+              </a:rPr>
+              <a:t>NIST SP 800-218 (SSDF)</a:t>
+            </a:r>
+          </a:p>
+          <a:p>
+            <a:pPr algn="l">
+              <a:spcAft>
+                <a:spcPts val="0"/>
+              </a:spcAft>
+            </a:pPr>
+            <a:r>
+              <a:rPr sz="800" b="0">
+                <a:solidFill>
+                  <a:srgbClr val="555555"/>
+                </a:solidFill>
+              </a:rPr>
+              <a:t>Secure Software Development Framework requires vulnerability scanning and remediation tracking. Grype scan results are stored per build as immutable CI artifacts.</a:t>
+            </a:r>
+          </a:p>
+        </p:txBody>
+      </p:sp>
+      <p:sp>
+        <p:nvSpPr>
+          <p:cNvPr id="22" name="TextBox 21"/>
+          <p:cNvSpPr txBox="1"/>
+          <p:nvPr/>
+        </p:nvSpPr>
+        <p:spPr>
+          <a:xfrm>
+            <a:off x="6400800" y="3566160"/>
+            <a:ext cx="4937760" cy="731520"/>
+          </a:xfrm>
+          <a:prstGeom prst="rect">
+            <a:avLst/>
+          </a:prstGeom>
+          <a:noFill/>
+        </p:spPr>
+        <p:txBody>
+          <a:bodyPr wrap="square">
+            <a:spAutoFit/>
+          </a:bodyPr>
+          <a:lstStyle/>
+          <a:p>
+            <a:pPr algn="l">
+              <a:spcAft>
+                <a:spcPts val="200"/>
+              </a:spcAft>
+            </a:pPr>
+            <a:r>
+              <a:rPr sz="1100" b="1">
+                <a:solidFill>
+                  <a:srgbClr val="0069B0"/>
+                </a:solidFill>
+              </a:rPr>
+              <a:t>Supply Chain Transparency</a:t>
+            </a:r>
+          </a:p>
+          <a:p>
+            <a:pPr algn="l">
+              <a:spcAft>
+                <a:spcPts val="0"/>
+              </a:spcAft>
+            </a:pPr>
+            <a:r>
+              <a:rPr sz="800" b="0">
+                <a:solidFill>
+                  <a:srgbClr val="555555"/>
+                </a:solidFill>
+              </a:rPr>
+              <a:t>Every component in the deployed product is inventoried with name, version, type, and package URL. No hidden dependencies.</a:t>
+            </a:r>
+          </a:p>
+        </p:txBody>
+      </p:sp>
+      <p:sp>
+        <p:nvSpPr>
+          <p:cNvPr id="23" name="TextBox 22"/>
+          <p:cNvSpPr txBox="1"/>
+          <p:nvPr/>
+        </p:nvSpPr>
+        <p:spPr>
+          <a:xfrm>
+            <a:off x="6400800" y="4343400"/>
+            <a:ext cx="4937760" cy="731520"/>
+          </a:xfrm>
+          <a:prstGeom prst="rect">
+            <a:avLst/>
+          </a:prstGeom>
+          <a:noFill/>
+        </p:spPr>
+        <p:txBody>
+          <a:bodyPr wrap="square">
+            <a:spAutoFit/>
+          </a:bodyPr>
+          <a:lstStyle/>
+          <a:p>
+            <a:pPr algn="l">
+              <a:spcAft>
+                <a:spcPts val="200"/>
+              </a:spcAft>
+            </a:pPr>
+            <a:r>
+              <a:rPr sz="1100" b="1">
+                <a:solidFill>
+                  <a:srgbClr val="0069B0"/>
+                </a:solidFill>
+              </a:rPr>
+              <a:t>Audit-Ready Evidence</a:t>
+            </a:r>
+          </a:p>
+          <a:p>
+            <a:pPr algn="l">
+              <a:spcAft>
+                <a:spcPts val="0"/>
+              </a:spcAft>
+            </a:pPr>
+            <a:r>
+              <a:rPr sz="800" b="0">
+                <a:solidFill>
+                  <a:srgbClr val="555555"/>
+                </a:solidFill>
+              </a:rPr>
+              <a:t>SBOM + vulnerability scan results are included in the deployment evidence bundle. No manual assembly — generated fresh on every pipeline run.</a:t>
+            </a:r>
+          </a:p>
+        </p:txBody>
+      </p:sp>
+      <p:sp>
+        <p:nvSpPr>
+          <p:cNvPr id="24" name="TextBox 23"/>
+          <p:cNvSpPr txBox="1"/>
+          <p:nvPr/>
+        </p:nvSpPr>
+        <p:spPr>
+          <a:xfrm>
+            <a:off x="6400800" y="5120640"/>
+            <a:ext cx="4937760" cy="731520"/>
+          </a:xfrm>
+          <a:prstGeom prst="rect">
+            <a:avLst/>
+          </a:prstGeom>
+          <a:noFill/>
+        </p:spPr>
+        <p:txBody>
+          <a:bodyPr wrap="square">
+            <a:spAutoFit/>
+          </a:bodyPr>
+          <a:lstStyle/>
+          <a:p>
+            <a:pPr algn="l">
+              <a:spcAft>
+                <a:spcPts val="200"/>
+              </a:spcAft>
+            </a:pPr>
+            <a:r>
+              <a:rPr sz="1100" b="1">
+                <a:solidFill>
+                  <a:srgbClr val="0069B0"/>
+                </a:solidFill>
+              </a:rPr>
+              <a:t>Air-Gapped Compatible</a:t>
+            </a:r>
+          </a:p>
+          <a:p>
+            <a:pPr algn="l">
+              <a:spcAft>
+                <a:spcPts val="0"/>
+              </a:spcAft>
+            </a:pPr>
+            <a:r>
+              <a:rPr sz="800" b="0">
+                <a:solidFill>
+                  <a:srgbClr val="555555"/>
+                </a:solidFill>
+              </a:rPr>
+              <a:t>Grype vulnerability database can be mirrored internally. Syft runs against local container images. No internet required at scan time.</a:t>
+            </a:r>
+          </a:p>
+        </p:txBody>
+      </p:sp>
+      <p:sp>
+        <p:nvSpPr>
+          <p:cNvPr id="25" name="Rounded Rectangle 24"/>
+          <p:cNvSpPr/>
+          <p:nvPr/>
+        </p:nvSpPr>
+        <p:spPr>
+          <a:xfrm>
+            <a:off x="457200" y="6035040"/>
+            <a:ext cx="11247120" cy="411480"/>
+          </a:xfrm>
+          <a:prstGeom prst="roundRect">
+            <a:avLst/>
+          </a:prstGeom>
+          <a:solidFill>
+            <a:srgbClr val="F4F7FA"/>
+          </a:solidFill>
+          <a:ln w="12700">
+            <a:solidFill>
+              <a:srgbClr val="0069B0"/>
+            </a:solidFill>
+          </a:ln>
+        </p:spPr>
+        <p:style>
+          <a:lnRef idx="1">
+            <a:schemeClr val="accent1"/>
+          </a:lnRef>
+          <a:fillRef idx="3">
+            <a:schemeClr val="accent1"/>
+          </a:fillRef>
+          <a:effectRef idx="2">
+            <a:schemeClr val="accent1"/>
+          </a:effectRef>
+          <a:fontRef idx="minor">
+            <a:schemeClr val="lt1"/>
+          </a:fontRef>
+        </p:style>
+        <p:txBody>
+          <a:bodyPr rtlCol="0" anchor="ctr"/>
+          <a:lstStyle/>
+          <a:p>
+            <a:pPr algn="ctr"/>
+          </a:p>
+        </p:txBody>
+      </p:sp>
+      <p:sp>
+        <p:nvSpPr>
+          <p:cNvPr id="26" name="TextBox 25"/>
+          <p:cNvSpPr txBox="1"/>
+          <p:nvPr/>
+        </p:nvSpPr>
+        <p:spPr>
+          <a:xfrm>
+            <a:off x="731520" y="6089904"/>
+            <a:ext cx="10789920" cy="320040"/>
+          </a:xfrm>
+          <a:prstGeom prst="rect">
+            <a:avLst/>
+          </a:prstGeom>
+          <a:noFill/>
+        </p:spPr>
+        <p:txBody>
+          <a:bodyPr wrap="square">
+            <a:spAutoFit/>
+          </a:bodyPr>
+          <a:lstStyle/>
+          <a:p>
+            <a:pPr algn="ctr">
+              <a:spcAft>
+                <a:spcPts val="0"/>
+              </a:spcAft>
+            </a:pPr>
+            <a:r>
+              <a:rPr sz="1100" b="1">
                 <a:solidFill>
                   <a:srgbClr val="0D1B2A"/>
                 </a:solidFill>
               </a:rPr>
-              <a:t>Minutes, Not Weeks</a:t>
-            </a:r>
-          </a:p>
-          <a:p>
-            <a:pPr algn="l">
-              <a:spcAft>
-                <a:spcPts val="0"/>
-              </a:spcAft>
-            </a:pPr>
-            <a:r>
-              <a:rPr sz="900" b="0">
-                <a:solidFill>
-                  <a:srgbClr val="555555"/>
-                </a:solidFill>
-              </a:rPr>
-              <a:t>Traceability report is generated on every commit — always current, always complete.</a:t>
-            </a:r>
-          </a:p>
-        </p:txBody>
-      </p:sp>
-      <p:sp>
-        <p:nvSpPr>
-          <p:cNvPr id="16" name="TextBox 15"/>
-          <p:cNvSpPr txBox="1"/>
-          <p:nvPr/>
-        </p:nvSpPr>
-        <p:spPr>
-          <a:xfrm>
-            <a:off x="731520" y="4114800"/>
-            <a:ext cx="5029200" cy="822960"/>
-          </a:xfrm>
-          <a:prstGeom prst="rect">
-            <a:avLst/>
-          </a:prstGeom>
-          <a:noFill/>
-        </p:spPr>
-        <p:txBody>
-          <a:bodyPr wrap="square">
-            <a:spAutoFit/>
-          </a:bodyPr>
-          <a:lstStyle/>
-          <a:p>
-            <a:pPr algn="l">
-              <a:spcAft>
-                <a:spcPts val="200"/>
-              </a:spcAft>
-            </a:pPr>
-            <a:r>
-              <a:rPr sz="1200" b="1">
-                <a:solidFill>
-                  <a:srgbClr val="0D1B2A"/>
-                </a:solidFill>
-              </a:rPr>
-              <a:t>Every Change Tracked</a:t>
-            </a:r>
-          </a:p>
-          <a:p>
-            <a:pPr algn="l">
-              <a:spcAft>
-                <a:spcPts val="0"/>
-              </a:spcAft>
-            </a:pPr>
-            <a:r>
-              <a:rPr sz="900" b="0">
-                <a:solidFill>
-                  <a:srgbClr val="555555"/>
-                </a:solidFill>
-              </a:rPr>
-              <a:t>Git history + baseline diffs show exactly when requirements changed and who acknowledged them.</a:t>
-            </a:r>
-          </a:p>
-        </p:txBody>
-      </p:sp>
-      <p:sp>
-        <p:nvSpPr>
-          <p:cNvPr id="17" name="TextBox 16"/>
-          <p:cNvSpPr txBox="1"/>
-          <p:nvPr/>
-        </p:nvSpPr>
-        <p:spPr>
-          <a:xfrm>
-            <a:off x="731520" y="5029200"/>
-            <a:ext cx="5029200" cy="822960"/>
-          </a:xfrm>
-          <a:prstGeom prst="rect">
-            <a:avLst/>
-          </a:prstGeom>
-          <a:noFill/>
-        </p:spPr>
-        <p:txBody>
-          <a:bodyPr wrap="square">
-            <a:spAutoFit/>
-          </a:bodyPr>
-          <a:lstStyle/>
-          <a:p>
-            <a:pPr algn="l">
-              <a:spcAft>
-                <a:spcPts val="200"/>
-              </a:spcAft>
-            </a:pPr>
-            <a:r>
-              <a:rPr sz="1200" b="1">
-                <a:solidFill>
-                  <a:srgbClr val="0D1B2A"/>
-                </a:solidFill>
-              </a:rPr>
-              <a:t>No Missing Tests</a:t>
-            </a:r>
-          </a:p>
-          <a:p>
-            <a:pPr algn="l">
-              <a:spcAft>
-                <a:spcPts val="0"/>
-              </a:spcAft>
-            </a:pPr>
-            <a:r>
-              <a:rPr sz="900" b="0">
-                <a:solidFill>
-                  <a:srgbClr val="555555"/>
-                </a:solidFill>
-              </a:rPr>
-              <a:t>Gate A ensures every verification criteria has coverage — gaps are caught before merge.</a:t>
-            </a:r>
-          </a:p>
-        </p:txBody>
-      </p:sp>
-      <p:sp>
-        <p:nvSpPr>
-          <p:cNvPr id="18" name="TextBox 17"/>
-          <p:cNvSpPr txBox="1"/>
-          <p:nvPr/>
-        </p:nvSpPr>
-        <p:spPr>
-          <a:xfrm>
-            <a:off x="6217920" y="3200400"/>
-            <a:ext cx="5029200" cy="822960"/>
-          </a:xfrm>
-          <a:prstGeom prst="rect">
-            <a:avLst/>
-          </a:prstGeom>
-          <a:noFill/>
-        </p:spPr>
-        <p:txBody>
-          <a:bodyPr wrap="square">
-            <a:spAutoFit/>
-          </a:bodyPr>
-          <a:lstStyle/>
-          <a:p>
-            <a:pPr algn="l">
-              <a:spcAft>
-                <a:spcPts val="200"/>
-              </a:spcAft>
-            </a:pPr>
-            <a:r>
-              <a:rPr sz="1200" b="1">
-                <a:solidFill>
-                  <a:srgbClr val="0D1B2A"/>
-                </a:solidFill>
-              </a:rPr>
-              <a:t>No Stale Tests</a:t>
-            </a:r>
-          </a:p>
-          <a:p>
-            <a:pPr algn="l">
-              <a:spcAft>
-                <a:spcPts val="0"/>
-              </a:spcAft>
-            </a:pPr>
-            <a:r>
-              <a:rPr sz="900" b="0">
-                <a:solidFill>
-                  <a:srgbClr val="555555"/>
-                </a:solidFill>
-              </a:rPr>
-              <a:t>Gate B detects criteria drift — existing tests are flagged for re-review when requirements change.</a:t>
-            </a:r>
-          </a:p>
-        </p:txBody>
-      </p:sp>
-      <p:sp>
-        <p:nvSpPr>
-          <p:cNvPr id="19" name="TextBox 18"/>
-          <p:cNvSpPr txBox="1"/>
-          <p:nvPr/>
-        </p:nvSpPr>
-        <p:spPr>
-          <a:xfrm>
-            <a:off x="6217920" y="4114800"/>
-            <a:ext cx="5029200" cy="822960"/>
-          </a:xfrm>
-          <a:prstGeom prst="rect">
-            <a:avLst/>
-          </a:prstGeom>
-          <a:noFill/>
-        </p:spPr>
-        <p:txBody>
-          <a:bodyPr wrap="square">
-            <a:spAutoFit/>
-          </a:bodyPr>
-          <a:lstStyle/>
-          <a:p>
-            <a:pPr algn="l">
-              <a:spcAft>
-                <a:spcPts val="200"/>
-              </a:spcAft>
-            </a:pPr>
-            <a:r>
-              <a:rPr sz="1200" b="1">
-                <a:solidFill>
-                  <a:srgbClr val="0D1B2A"/>
-                </a:solidFill>
-              </a:rPr>
-              <a:t>No Ghost Tests</a:t>
-            </a:r>
-          </a:p>
-          <a:p>
-            <a:pPr algn="l">
-              <a:spcAft>
-                <a:spcPts val="0"/>
-              </a:spcAft>
-            </a:pPr>
-            <a:r>
-              <a:rPr sz="900" b="0">
-                <a:solidFill>
-                  <a:srgbClr val="555555"/>
-                </a:solidFill>
-              </a:rPr>
-              <a:t>Gate C catches orphaned tests — scenarios for deleted requirements are flagged for removal.</a:t>
-            </a:r>
-          </a:p>
-        </p:txBody>
-      </p:sp>
-      <p:sp>
-        <p:nvSpPr>
-          <p:cNvPr id="20" name="TextBox 19"/>
-          <p:cNvSpPr txBox="1"/>
-          <p:nvPr/>
-        </p:nvSpPr>
-        <p:spPr>
-          <a:xfrm>
-            <a:off x="6217920" y="5029200"/>
-            <a:ext cx="5029200" cy="822960"/>
-          </a:xfrm>
-          <a:prstGeom prst="rect">
-            <a:avLst/>
-          </a:prstGeom>
-          <a:noFill/>
-        </p:spPr>
-        <p:txBody>
-          <a:bodyPr wrap="square">
-            <a:spAutoFit/>
-          </a:bodyPr>
-          <a:lstStyle/>
-          <a:p>
-            <a:pPr algn="l">
-              <a:spcAft>
-                <a:spcPts val="200"/>
-              </a:spcAft>
-            </a:pPr>
-            <a:r>
-              <a:rPr sz="1200" b="1">
-                <a:solidFill>
-                  <a:srgbClr val="0D1B2A"/>
-                </a:solidFill>
-              </a:rPr>
-              <a:t>Immutable Evidence</a:t>
-            </a:r>
-          </a:p>
-          <a:p>
-            <a:pPr algn="l">
-              <a:spcAft>
-                <a:spcPts val="0"/>
-              </a:spcAft>
-            </a:pPr>
-            <a:r>
-              <a:rPr sz="900" b="0">
-                <a:solidFill>
-                  <a:srgbClr val="555555"/>
-                </a:solidFill>
-              </a:rPr>
-              <a:t>CI artifacts (HTML + JSON reports) are stored per build — reproducible audit trail.</a:t>
-            </a:r>
-          </a:p>
-        </p:txBody>
-      </p:sp>
-      <p:sp>
-        <p:nvSpPr>
-          <p:cNvPr id="21" name="TextBox 20"/>
+              <a:t>Every build produces a complete SBOM and vulnerability scan — no manual steps, no gaps, always current.</a:t>
+            </a:r>
+          </a:p>
+        </p:txBody>
+      </p:sp>
+      <p:sp>
+        <p:nvSpPr>
+          <p:cNvPr id="27" name="TextBox 26"/>
           <p:cNvSpPr txBox="1"/>
           <p:nvPr/>
         </p:nvSpPr>
@@ -4188,7 +4455,7 @@
                   <a:srgbClr val="888888"/>
                 </a:solidFill>
               </a:rPr>
-              <a:t>10 / 11</a:t>
+              <a:t>10 / 12</a:t>
             </a:r>
           </a:p>
         </p:txBody>
@@ -4202,6 +4469,987 @@
 </file>
 
 <file path=ppt/slides/slide11.xml><?xml version="1.0" encoding="utf-8"?>
+<p:sld xmlns:a="http://schemas.openxmlformats.org/drawingml/2006/main" xmlns:p="http://schemas.openxmlformats.org/presentationml/2006/main" xmlns:r="http://schemas.openxmlformats.org/officeDocument/2006/relationships">
+  <p:cSld>
+    <p:bg>
+      <p:bgPr>
+        <a:solidFill>
+          <a:srgbClr val="FFFFFF"/>
+        </a:solidFill>
+        <a:effectLst/>
+      </p:bgPr>
+    </p:bg>
+    <p:spTree>
+      <p:nvGrpSpPr>
+        <p:cNvPr id="1" name=""/>
+        <p:cNvGrpSpPr/>
+        <p:nvPr/>
+      </p:nvGrpSpPr>
+      <p:grpSpPr/>
+      <p:sp>
+        <p:nvSpPr>
+          <p:cNvPr id="2" name="TextBox 1"/>
+          <p:cNvSpPr txBox="1"/>
+          <p:nvPr/>
+        </p:nvSpPr>
+        <p:spPr>
+          <a:xfrm>
+            <a:off x="731520" y="457200"/>
+            <a:ext cx="10058400" cy="457200"/>
+          </a:xfrm>
+          <a:prstGeom prst="rect">
+            <a:avLst/>
+          </a:prstGeom>
+          <a:noFill/>
+        </p:spPr>
+        <p:txBody>
+          <a:bodyPr wrap="square">
+            <a:spAutoFit/>
+          </a:bodyPr>
+          <a:lstStyle/>
+          <a:p>
+            <a:pPr algn="l">
+              <a:spcAft>
+                <a:spcPts val="0"/>
+              </a:spcAft>
+            </a:pPr>
+            <a:r>
+              <a:rPr sz="2800" b="1">
+                <a:solidFill>
+                  <a:srgbClr val="0D1B2A"/>
+                </a:solidFill>
+              </a:rPr>
+              <a:t>Traceability &amp; Audit Evidence</a:t>
+            </a:r>
+          </a:p>
+        </p:txBody>
+      </p:sp>
+      <p:sp>
+        <p:nvSpPr>
+          <p:cNvPr id="3" name="TextBox 2"/>
+          <p:cNvSpPr txBox="1"/>
+          <p:nvPr/>
+        </p:nvSpPr>
+        <p:spPr>
+          <a:xfrm>
+            <a:off x="731520" y="960120"/>
+            <a:ext cx="10058400" cy="274320"/>
+          </a:xfrm>
+          <a:prstGeom prst="rect">
+            <a:avLst/>
+          </a:prstGeom>
+          <a:noFill/>
+        </p:spPr>
+        <p:txBody>
+          <a:bodyPr wrap="square">
+            <a:spAutoFit/>
+          </a:bodyPr>
+          <a:lstStyle/>
+          <a:p>
+            <a:pPr algn="l">
+              <a:spcAft>
+                <a:spcPts val="0"/>
+              </a:spcAft>
+            </a:pPr>
+            <a:r>
+              <a:rPr sz="1100" b="0">
+                <a:solidFill>
+                  <a:srgbClr val="555555"/>
+                </a:solidFill>
+              </a:rPr>
+              <a:t>Every pipeline run produces a complete, machine-generated evidence chain — no manual assembly required.</a:t>
+            </a:r>
+          </a:p>
+        </p:txBody>
+      </p:sp>
+      <p:sp>
+        <p:nvSpPr>
+          <p:cNvPr id="4" name="Rounded Rectangle 3"/>
+          <p:cNvSpPr/>
+          <p:nvPr/>
+        </p:nvSpPr>
+        <p:spPr>
+          <a:xfrm>
+            <a:off x="457200" y="1554480"/>
+            <a:ext cx="2011680" cy="777240"/>
+          </a:xfrm>
+          <a:prstGeom prst="roundRect">
+            <a:avLst/>
+          </a:prstGeom>
+          <a:solidFill>
+            <a:srgbClr val="003057"/>
+          </a:solidFill>
+          <a:ln>
+            <a:noFill/>
+          </a:ln>
+        </p:spPr>
+        <p:style>
+          <a:lnRef idx="1">
+            <a:schemeClr val="accent1"/>
+          </a:lnRef>
+          <a:fillRef idx="3">
+            <a:schemeClr val="accent1"/>
+          </a:fillRef>
+          <a:effectRef idx="2">
+            <a:schemeClr val="accent1"/>
+          </a:effectRef>
+          <a:fontRef idx="minor">
+            <a:schemeClr val="lt1"/>
+          </a:fontRef>
+        </p:style>
+        <p:txBody>
+          <a:bodyPr rtlCol="0" anchor="ctr"/>
+          <a:lstStyle/>
+          <a:p>
+            <a:pPr algn="ctr"/>
+          </a:p>
+        </p:txBody>
+      </p:sp>
+      <p:sp>
+        <p:nvSpPr>
+          <p:cNvPr id="5" name="TextBox 4"/>
+          <p:cNvSpPr txBox="1"/>
+          <p:nvPr/>
+        </p:nvSpPr>
+        <p:spPr>
+          <a:xfrm>
+            <a:off x="548640" y="1627632"/>
+            <a:ext cx="1828800" cy="685800"/>
+          </a:xfrm>
+          <a:prstGeom prst="rect">
+            <a:avLst/>
+          </a:prstGeom>
+          <a:noFill/>
+        </p:spPr>
+        <p:txBody>
+          <a:bodyPr wrap="square">
+            <a:spAutoFit/>
+          </a:bodyPr>
+          <a:lstStyle/>
+          <a:p>
+            <a:pPr algn="l">
+              <a:spcAft>
+                <a:spcPts val="100"/>
+              </a:spcAft>
+            </a:pPr>
+            <a:r>
+              <a:rPr sz="900" b="1">
+                <a:solidFill>
+                  <a:srgbClr val="FFFFFF"/>
+                </a:solidFill>
+              </a:rPr>
+              <a:t>Requirement
+in Cameo</a:t>
+            </a:r>
+          </a:p>
+          <a:p>
+            <a:pPr algn="l">
+              <a:spcAft>
+                <a:spcPts val="0"/>
+              </a:spcAft>
+            </a:pPr>
+            <a:r>
+              <a:rPr sz="700" b="0">
+                <a:solidFill>
+                  <a:srgbClr val="BBBBBB"/>
+                </a:solidFill>
+              </a:rPr>
+              <a:t/>
+            </a:r>
+          </a:p>
+        </p:txBody>
+      </p:sp>
+      <p:sp>
+        <p:nvSpPr>
+          <p:cNvPr id="6" name="Rounded Rectangle 5"/>
+          <p:cNvSpPr/>
+          <p:nvPr/>
+        </p:nvSpPr>
+        <p:spPr>
+          <a:xfrm>
+            <a:off x="2651760" y="1554480"/>
+            <a:ext cx="2011680" cy="777240"/>
+          </a:xfrm>
+          <a:prstGeom prst="roundRect">
+            <a:avLst/>
+          </a:prstGeom>
+          <a:solidFill>
+            <a:srgbClr val="004A87"/>
+          </a:solidFill>
+          <a:ln>
+            <a:noFill/>
+          </a:ln>
+        </p:spPr>
+        <p:style>
+          <a:lnRef idx="1">
+            <a:schemeClr val="accent1"/>
+          </a:lnRef>
+          <a:fillRef idx="3">
+            <a:schemeClr val="accent1"/>
+          </a:fillRef>
+          <a:effectRef idx="2">
+            <a:schemeClr val="accent1"/>
+          </a:effectRef>
+          <a:fontRef idx="minor">
+            <a:schemeClr val="lt1"/>
+          </a:fontRef>
+        </p:style>
+        <p:txBody>
+          <a:bodyPr rtlCol="0" anchor="ctr"/>
+          <a:lstStyle/>
+          <a:p>
+            <a:pPr algn="ctr"/>
+          </a:p>
+        </p:txBody>
+      </p:sp>
+      <p:sp>
+        <p:nvSpPr>
+          <p:cNvPr id="7" name="TextBox 6"/>
+          <p:cNvSpPr txBox="1"/>
+          <p:nvPr/>
+        </p:nvSpPr>
+        <p:spPr>
+          <a:xfrm>
+            <a:off x="2743200" y="1627632"/>
+            <a:ext cx="1828800" cy="685800"/>
+          </a:xfrm>
+          <a:prstGeom prst="rect">
+            <a:avLst/>
+          </a:prstGeom>
+          <a:noFill/>
+        </p:spPr>
+        <p:txBody>
+          <a:bodyPr wrap="square">
+            <a:spAutoFit/>
+          </a:bodyPr>
+          <a:lstStyle/>
+          <a:p>
+            <a:pPr algn="l">
+              <a:spcAft>
+                <a:spcPts val="100"/>
+              </a:spcAft>
+            </a:pPr>
+            <a:r>
+              <a:rPr sz="900" b="1">
+                <a:solidFill>
+                  <a:srgbClr val="FFFFFF"/>
+                </a:solidFill>
+              </a:rPr>
+              <a:t>Verification
+Criteria (VC)</a:t>
+            </a:r>
+          </a:p>
+          <a:p>
+            <a:pPr algn="l">
+              <a:spcAft>
+                <a:spcPts val="0"/>
+              </a:spcAft>
+            </a:pPr>
+            <a:r>
+              <a:rPr sz="700" b="0">
+                <a:solidFill>
+                  <a:srgbClr val="BBBBBB"/>
+                </a:solidFill>
+              </a:rPr>
+              <a:t/>
+            </a:r>
+          </a:p>
+        </p:txBody>
+      </p:sp>
+      <p:sp>
+        <p:nvSpPr>
+          <p:cNvPr id="8" name="Rounded Rectangle 7"/>
+          <p:cNvSpPr/>
+          <p:nvPr/>
+        </p:nvSpPr>
+        <p:spPr>
+          <a:xfrm>
+            <a:off x="4846320" y="1554480"/>
+            <a:ext cx="2011680" cy="777240"/>
+          </a:xfrm>
+          <a:prstGeom prst="roundRect">
+            <a:avLst/>
+          </a:prstGeom>
+          <a:solidFill>
+            <a:srgbClr val="0069B0"/>
+          </a:solidFill>
+          <a:ln>
+            <a:noFill/>
+          </a:ln>
+        </p:spPr>
+        <p:style>
+          <a:lnRef idx="1">
+            <a:schemeClr val="accent1"/>
+          </a:lnRef>
+          <a:fillRef idx="3">
+            <a:schemeClr val="accent1"/>
+          </a:fillRef>
+          <a:effectRef idx="2">
+            <a:schemeClr val="accent1"/>
+          </a:effectRef>
+          <a:fontRef idx="minor">
+            <a:schemeClr val="lt1"/>
+          </a:fontRef>
+        </p:style>
+        <p:txBody>
+          <a:bodyPr rtlCol="0" anchor="ctr"/>
+          <a:lstStyle/>
+          <a:p>
+            <a:pPr algn="ctr"/>
+          </a:p>
+        </p:txBody>
+      </p:sp>
+      <p:sp>
+        <p:nvSpPr>
+          <p:cNvPr id="9" name="TextBox 8"/>
+          <p:cNvSpPr txBox="1"/>
+          <p:nvPr/>
+        </p:nvSpPr>
+        <p:spPr>
+          <a:xfrm>
+            <a:off x="4937760" y="1627632"/>
+            <a:ext cx="1828800" cy="685800"/>
+          </a:xfrm>
+          <a:prstGeom prst="rect">
+            <a:avLst/>
+          </a:prstGeom>
+          <a:noFill/>
+        </p:spPr>
+        <p:txBody>
+          <a:bodyPr wrap="square">
+            <a:spAutoFit/>
+          </a:bodyPr>
+          <a:lstStyle/>
+          <a:p>
+            <a:pPr algn="l">
+              <a:spcAft>
+                <a:spcPts val="100"/>
+              </a:spcAft>
+            </a:pPr>
+            <a:r>
+              <a:rPr sz="900" b="1">
+                <a:solidFill>
+                  <a:srgbClr val="FFFFFF"/>
+                </a:solidFill>
+              </a:rPr>
+              <a:t>Gherkin
+Scenario</a:t>
+            </a:r>
+          </a:p>
+          <a:p>
+            <a:pPr algn="l">
+              <a:spcAft>
+                <a:spcPts val="0"/>
+              </a:spcAft>
+            </a:pPr>
+            <a:r>
+              <a:rPr sz="700" b="0">
+                <a:solidFill>
+                  <a:srgbClr val="BBBBBB"/>
+                </a:solidFill>
+              </a:rPr>
+              <a:t/>
+            </a:r>
+          </a:p>
+        </p:txBody>
+      </p:sp>
+      <p:sp>
+        <p:nvSpPr>
+          <p:cNvPr id="10" name="Rounded Rectangle 9"/>
+          <p:cNvSpPr/>
+          <p:nvPr/>
+        </p:nvSpPr>
+        <p:spPr>
+          <a:xfrm>
+            <a:off x="7040880" y="1554480"/>
+            <a:ext cx="2011680" cy="777240"/>
+          </a:xfrm>
+          <a:prstGeom prst="roundRect">
+            <a:avLst/>
+          </a:prstGeom>
+          <a:solidFill>
+            <a:srgbClr val="0082CC"/>
+          </a:solidFill>
+          <a:ln>
+            <a:noFill/>
+          </a:ln>
+        </p:spPr>
+        <p:style>
+          <a:lnRef idx="1">
+            <a:schemeClr val="accent1"/>
+          </a:lnRef>
+          <a:fillRef idx="3">
+            <a:schemeClr val="accent1"/>
+          </a:fillRef>
+          <a:effectRef idx="2">
+            <a:schemeClr val="accent1"/>
+          </a:effectRef>
+          <a:fontRef idx="minor">
+            <a:schemeClr val="lt1"/>
+          </a:fontRef>
+        </p:style>
+        <p:txBody>
+          <a:bodyPr rtlCol="0" anchor="ctr"/>
+          <a:lstStyle/>
+          <a:p>
+            <a:pPr algn="ctr"/>
+          </a:p>
+        </p:txBody>
+      </p:sp>
+      <p:sp>
+        <p:nvSpPr>
+          <p:cNvPr id="11" name="TextBox 10"/>
+          <p:cNvSpPr txBox="1"/>
+          <p:nvPr/>
+        </p:nvSpPr>
+        <p:spPr>
+          <a:xfrm>
+            <a:off x="7132320" y="1627632"/>
+            <a:ext cx="1828800" cy="685800"/>
+          </a:xfrm>
+          <a:prstGeom prst="rect">
+            <a:avLst/>
+          </a:prstGeom>
+          <a:noFill/>
+        </p:spPr>
+        <p:txBody>
+          <a:bodyPr wrap="square">
+            <a:spAutoFit/>
+          </a:bodyPr>
+          <a:lstStyle/>
+          <a:p>
+            <a:pPr algn="l">
+              <a:spcAft>
+                <a:spcPts val="100"/>
+              </a:spcAft>
+            </a:pPr>
+            <a:r>
+              <a:rPr sz="900" b="1">
+                <a:solidFill>
+                  <a:srgbClr val="FFFFFF"/>
+                </a:solidFill>
+              </a:rPr>
+              <a:t>BDD Test
+Result</a:t>
+            </a:r>
+          </a:p>
+          <a:p>
+            <a:pPr algn="l">
+              <a:spcAft>
+                <a:spcPts val="0"/>
+              </a:spcAft>
+            </a:pPr>
+            <a:r>
+              <a:rPr sz="700" b="0">
+                <a:solidFill>
+                  <a:srgbClr val="BBBBBB"/>
+                </a:solidFill>
+              </a:rPr>
+              <a:t/>
+            </a:r>
+          </a:p>
+        </p:txBody>
+      </p:sp>
+      <p:sp>
+        <p:nvSpPr>
+          <p:cNvPr id="12" name="Rounded Rectangle 11"/>
+          <p:cNvSpPr/>
+          <p:nvPr/>
+        </p:nvSpPr>
+        <p:spPr>
+          <a:xfrm>
+            <a:off x="9235440" y="1554480"/>
+            <a:ext cx="2011680" cy="777240"/>
+          </a:xfrm>
+          <a:prstGeom prst="roundRect">
+            <a:avLst/>
+          </a:prstGeom>
+          <a:solidFill>
+            <a:srgbClr val="0099D6"/>
+          </a:solidFill>
+          <a:ln>
+            <a:noFill/>
+          </a:ln>
+        </p:spPr>
+        <p:style>
+          <a:lnRef idx="1">
+            <a:schemeClr val="accent1"/>
+          </a:lnRef>
+          <a:fillRef idx="3">
+            <a:schemeClr val="accent1"/>
+          </a:fillRef>
+          <a:effectRef idx="2">
+            <a:schemeClr val="accent1"/>
+          </a:effectRef>
+          <a:fontRef idx="minor">
+            <a:schemeClr val="lt1"/>
+          </a:fontRef>
+        </p:style>
+        <p:txBody>
+          <a:bodyPr rtlCol="0" anchor="ctr"/>
+          <a:lstStyle/>
+          <a:p>
+            <a:pPr algn="ctr"/>
+          </a:p>
+        </p:txBody>
+      </p:sp>
+      <p:sp>
+        <p:nvSpPr>
+          <p:cNvPr id="13" name="TextBox 12"/>
+          <p:cNvSpPr txBox="1"/>
+          <p:nvPr/>
+        </p:nvSpPr>
+        <p:spPr>
+          <a:xfrm>
+            <a:off x="9326880" y="1627632"/>
+            <a:ext cx="1828800" cy="685800"/>
+          </a:xfrm>
+          <a:prstGeom prst="rect">
+            <a:avLst/>
+          </a:prstGeom>
+          <a:noFill/>
+        </p:spPr>
+        <p:txBody>
+          <a:bodyPr wrap="square">
+            <a:spAutoFit/>
+          </a:bodyPr>
+          <a:lstStyle/>
+          <a:p>
+            <a:pPr algn="l">
+              <a:spcAft>
+                <a:spcPts val="100"/>
+              </a:spcAft>
+            </a:pPr>
+            <a:r>
+              <a:rPr sz="900" b="1">
+                <a:solidFill>
+                  <a:srgbClr val="FFFFFF"/>
+                </a:solidFill>
+              </a:rPr>
+              <a:t>Deployment
+Pipeline Report</a:t>
+            </a:r>
+          </a:p>
+          <a:p>
+            <a:pPr algn="l">
+              <a:spcAft>
+                <a:spcPts val="0"/>
+              </a:spcAft>
+            </a:pPr>
+            <a:r>
+              <a:rPr sz="700" b="0">
+                <a:solidFill>
+                  <a:srgbClr val="BBBBBB"/>
+                </a:solidFill>
+              </a:rPr>
+              <a:t/>
+            </a:r>
+          </a:p>
+        </p:txBody>
+      </p:sp>
+      <p:sp>
+        <p:nvSpPr>
+          <p:cNvPr id="14" name="TextBox 13"/>
+          <p:cNvSpPr txBox="1"/>
+          <p:nvPr/>
+        </p:nvSpPr>
+        <p:spPr>
+          <a:xfrm>
+            <a:off x="731520" y="2743200"/>
+            <a:ext cx="4572000" cy="274320"/>
+          </a:xfrm>
+          <a:prstGeom prst="rect">
+            <a:avLst/>
+          </a:prstGeom>
+          <a:noFill/>
+        </p:spPr>
+        <p:txBody>
+          <a:bodyPr wrap="square">
+            <a:spAutoFit/>
+          </a:bodyPr>
+          <a:lstStyle/>
+          <a:p>
+            <a:pPr algn="l">
+              <a:spcAft>
+                <a:spcPts val="0"/>
+              </a:spcAft>
+            </a:pPr>
+            <a:r>
+              <a:rPr sz="1600" b="1">
+                <a:solidFill>
+                  <a:srgbClr val="0D1B2A"/>
+                </a:solidFill>
+              </a:rPr>
+              <a:t>What This Means for Compliance</a:t>
+            </a:r>
+          </a:p>
+        </p:txBody>
+      </p:sp>
+      <p:sp>
+        <p:nvSpPr>
+          <p:cNvPr id="15" name="TextBox 14"/>
+          <p:cNvSpPr txBox="1"/>
+          <p:nvPr/>
+        </p:nvSpPr>
+        <p:spPr>
+          <a:xfrm>
+            <a:off x="731520" y="3200400"/>
+            <a:ext cx="5029200" cy="822960"/>
+          </a:xfrm>
+          <a:prstGeom prst="rect">
+            <a:avLst/>
+          </a:prstGeom>
+          <a:noFill/>
+        </p:spPr>
+        <p:txBody>
+          <a:bodyPr wrap="square">
+            <a:spAutoFit/>
+          </a:bodyPr>
+          <a:lstStyle/>
+          <a:p>
+            <a:pPr algn="l">
+              <a:spcAft>
+                <a:spcPts val="200"/>
+              </a:spcAft>
+            </a:pPr>
+            <a:r>
+              <a:rPr sz="1200" b="1">
+                <a:solidFill>
+                  <a:srgbClr val="0D1B2A"/>
+                </a:solidFill>
+              </a:rPr>
+              <a:t>Minutes, Not Weeks</a:t>
+            </a:r>
+          </a:p>
+          <a:p>
+            <a:pPr algn="l">
+              <a:spcAft>
+                <a:spcPts val="0"/>
+              </a:spcAft>
+            </a:pPr>
+            <a:r>
+              <a:rPr sz="900" b="0">
+                <a:solidFill>
+                  <a:srgbClr val="555555"/>
+                </a:solidFill>
+              </a:rPr>
+              <a:t>Traceability report is generated on every commit — always current, always complete.</a:t>
+            </a:r>
+          </a:p>
+        </p:txBody>
+      </p:sp>
+      <p:sp>
+        <p:nvSpPr>
+          <p:cNvPr id="16" name="TextBox 15"/>
+          <p:cNvSpPr txBox="1"/>
+          <p:nvPr/>
+        </p:nvSpPr>
+        <p:spPr>
+          <a:xfrm>
+            <a:off x="731520" y="4114800"/>
+            <a:ext cx="5029200" cy="822960"/>
+          </a:xfrm>
+          <a:prstGeom prst="rect">
+            <a:avLst/>
+          </a:prstGeom>
+          <a:noFill/>
+        </p:spPr>
+        <p:txBody>
+          <a:bodyPr wrap="square">
+            <a:spAutoFit/>
+          </a:bodyPr>
+          <a:lstStyle/>
+          <a:p>
+            <a:pPr algn="l">
+              <a:spcAft>
+                <a:spcPts val="200"/>
+              </a:spcAft>
+            </a:pPr>
+            <a:r>
+              <a:rPr sz="1200" b="1">
+                <a:solidFill>
+                  <a:srgbClr val="0D1B2A"/>
+                </a:solidFill>
+              </a:rPr>
+              <a:t>Every Change Tracked</a:t>
+            </a:r>
+          </a:p>
+          <a:p>
+            <a:pPr algn="l">
+              <a:spcAft>
+                <a:spcPts val="0"/>
+              </a:spcAft>
+            </a:pPr>
+            <a:r>
+              <a:rPr sz="900" b="0">
+                <a:solidFill>
+                  <a:srgbClr val="555555"/>
+                </a:solidFill>
+              </a:rPr>
+              <a:t>Git history + baseline diffs show exactly when requirements changed and who acknowledged them.</a:t>
+            </a:r>
+          </a:p>
+        </p:txBody>
+      </p:sp>
+      <p:sp>
+        <p:nvSpPr>
+          <p:cNvPr id="17" name="TextBox 16"/>
+          <p:cNvSpPr txBox="1"/>
+          <p:nvPr/>
+        </p:nvSpPr>
+        <p:spPr>
+          <a:xfrm>
+            <a:off x="731520" y="5029200"/>
+            <a:ext cx="5029200" cy="822960"/>
+          </a:xfrm>
+          <a:prstGeom prst="rect">
+            <a:avLst/>
+          </a:prstGeom>
+          <a:noFill/>
+        </p:spPr>
+        <p:txBody>
+          <a:bodyPr wrap="square">
+            <a:spAutoFit/>
+          </a:bodyPr>
+          <a:lstStyle/>
+          <a:p>
+            <a:pPr algn="l">
+              <a:spcAft>
+                <a:spcPts val="200"/>
+              </a:spcAft>
+            </a:pPr>
+            <a:r>
+              <a:rPr sz="1200" b="1">
+                <a:solidFill>
+                  <a:srgbClr val="0D1B2A"/>
+                </a:solidFill>
+              </a:rPr>
+              <a:t>No Missing Tests</a:t>
+            </a:r>
+          </a:p>
+          <a:p>
+            <a:pPr algn="l">
+              <a:spcAft>
+                <a:spcPts val="0"/>
+              </a:spcAft>
+            </a:pPr>
+            <a:r>
+              <a:rPr sz="900" b="0">
+                <a:solidFill>
+                  <a:srgbClr val="555555"/>
+                </a:solidFill>
+              </a:rPr>
+              <a:t>Gate A ensures every verification criteria has coverage — gaps are caught before merge.</a:t>
+            </a:r>
+          </a:p>
+        </p:txBody>
+      </p:sp>
+      <p:sp>
+        <p:nvSpPr>
+          <p:cNvPr id="18" name="TextBox 17"/>
+          <p:cNvSpPr txBox="1"/>
+          <p:nvPr/>
+        </p:nvSpPr>
+        <p:spPr>
+          <a:xfrm>
+            <a:off x="6217920" y="3200400"/>
+            <a:ext cx="5029200" cy="822960"/>
+          </a:xfrm>
+          <a:prstGeom prst="rect">
+            <a:avLst/>
+          </a:prstGeom>
+          <a:noFill/>
+        </p:spPr>
+        <p:txBody>
+          <a:bodyPr wrap="square">
+            <a:spAutoFit/>
+          </a:bodyPr>
+          <a:lstStyle/>
+          <a:p>
+            <a:pPr algn="l">
+              <a:spcAft>
+                <a:spcPts val="200"/>
+              </a:spcAft>
+            </a:pPr>
+            <a:r>
+              <a:rPr sz="1200" b="1">
+                <a:solidFill>
+                  <a:srgbClr val="0D1B2A"/>
+                </a:solidFill>
+              </a:rPr>
+              <a:t>No Stale Tests</a:t>
+            </a:r>
+          </a:p>
+          <a:p>
+            <a:pPr algn="l">
+              <a:spcAft>
+                <a:spcPts val="0"/>
+              </a:spcAft>
+            </a:pPr>
+            <a:r>
+              <a:rPr sz="900" b="0">
+                <a:solidFill>
+                  <a:srgbClr val="555555"/>
+                </a:solidFill>
+              </a:rPr>
+              <a:t>Gate B detects criteria drift — existing tests are flagged for re-review when requirements change.</a:t>
+            </a:r>
+          </a:p>
+        </p:txBody>
+      </p:sp>
+      <p:sp>
+        <p:nvSpPr>
+          <p:cNvPr id="19" name="TextBox 18"/>
+          <p:cNvSpPr txBox="1"/>
+          <p:nvPr/>
+        </p:nvSpPr>
+        <p:spPr>
+          <a:xfrm>
+            <a:off x="6217920" y="4114800"/>
+            <a:ext cx="5029200" cy="822960"/>
+          </a:xfrm>
+          <a:prstGeom prst="rect">
+            <a:avLst/>
+          </a:prstGeom>
+          <a:noFill/>
+        </p:spPr>
+        <p:txBody>
+          <a:bodyPr wrap="square">
+            <a:spAutoFit/>
+          </a:bodyPr>
+          <a:lstStyle/>
+          <a:p>
+            <a:pPr algn="l">
+              <a:spcAft>
+                <a:spcPts val="200"/>
+              </a:spcAft>
+            </a:pPr>
+            <a:r>
+              <a:rPr sz="1200" b="1">
+                <a:solidFill>
+                  <a:srgbClr val="0D1B2A"/>
+                </a:solidFill>
+              </a:rPr>
+              <a:t>No Ghost Tests</a:t>
+            </a:r>
+          </a:p>
+          <a:p>
+            <a:pPr algn="l">
+              <a:spcAft>
+                <a:spcPts val="0"/>
+              </a:spcAft>
+            </a:pPr>
+            <a:r>
+              <a:rPr sz="900" b="0">
+                <a:solidFill>
+                  <a:srgbClr val="555555"/>
+                </a:solidFill>
+              </a:rPr>
+              <a:t>Gate C catches orphaned tests — scenarios for deleted requirements are flagged for removal.</a:t>
+            </a:r>
+          </a:p>
+        </p:txBody>
+      </p:sp>
+      <p:sp>
+        <p:nvSpPr>
+          <p:cNvPr id="20" name="TextBox 19"/>
+          <p:cNvSpPr txBox="1"/>
+          <p:nvPr/>
+        </p:nvSpPr>
+        <p:spPr>
+          <a:xfrm>
+            <a:off x="6217920" y="5029200"/>
+            <a:ext cx="5029200" cy="822960"/>
+          </a:xfrm>
+          <a:prstGeom prst="rect">
+            <a:avLst/>
+          </a:prstGeom>
+          <a:noFill/>
+        </p:spPr>
+        <p:txBody>
+          <a:bodyPr wrap="square">
+            <a:spAutoFit/>
+          </a:bodyPr>
+          <a:lstStyle/>
+          <a:p>
+            <a:pPr algn="l">
+              <a:spcAft>
+                <a:spcPts val="200"/>
+              </a:spcAft>
+            </a:pPr>
+            <a:r>
+              <a:rPr sz="1200" b="1">
+                <a:solidFill>
+                  <a:srgbClr val="0D1B2A"/>
+                </a:solidFill>
+              </a:rPr>
+              <a:t>Immutable Evidence</a:t>
+            </a:r>
+          </a:p>
+          <a:p>
+            <a:pPr algn="l">
+              <a:spcAft>
+                <a:spcPts val="0"/>
+              </a:spcAft>
+            </a:pPr>
+            <a:r>
+              <a:rPr sz="900" b="0">
+                <a:solidFill>
+                  <a:srgbClr val="555555"/>
+                </a:solidFill>
+              </a:rPr>
+              <a:t>CI artifacts (HTML + JSON reports) are stored per build — reproducible audit trail.</a:t>
+            </a:r>
+          </a:p>
+        </p:txBody>
+      </p:sp>
+      <p:sp>
+        <p:nvSpPr>
+          <p:cNvPr id="21" name="TextBox 20"/>
+          <p:cNvSpPr txBox="1"/>
+          <p:nvPr/>
+        </p:nvSpPr>
+        <p:spPr>
+          <a:xfrm>
+            <a:off x="10972800" y="6400800"/>
+            <a:ext cx="914400" cy="274320"/>
+          </a:xfrm>
+          <a:prstGeom prst="rect">
+            <a:avLst/>
+          </a:prstGeom>
+          <a:noFill/>
+        </p:spPr>
+        <p:txBody>
+          <a:bodyPr wrap="square">
+            <a:spAutoFit/>
+          </a:bodyPr>
+          <a:lstStyle/>
+          <a:p>
+            <a:pPr algn="r">
+              <a:spcAft>
+                <a:spcPts val="0"/>
+              </a:spcAft>
+            </a:pPr>
+            <a:r>
+              <a:rPr sz="900" b="0">
+                <a:solidFill>
+                  <a:srgbClr val="888888"/>
+                </a:solidFill>
+              </a:rPr>
+              <a:t>11 / 12</a:t>
+            </a:r>
+          </a:p>
+        </p:txBody>
+      </p:sp>
+    </p:spTree>
+  </p:cSld>
+  <p:clrMapOvr>
+    <a:masterClrMapping/>
+  </p:clrMapOvr>
+</p:sld>
+</file>
+
+<file path=ppt/slides/slide12.xml><?xml version="1.0" encoding="utf-8"?>
 <p:sld xmlns:a="http://schemas.openxmlformats.org/drawingml/2006/main" xmlns:p="http://schemas.openxmlformats.org/presentationml/2006/main" xmlns:r="http://schemas.openxmlformats.org/officeDocument/2006/relationships">
   <p:cSld>
     <p:bg>
@@ -4525,7 +5773,7 @@
                   <a:srgbClr val="888888"/>
                 </a:solidFill>
               </a:rPr>
-              <a:t>11 / 11</a:t>
+              <a:t>12 / 12</a:t>
             </a:r>
           </a:p>
         </p:txBody>
@@ -5028,7 +6276,7 @@
                   <a:srgbClr val="888888"/>
                 </a:solidFill>
               </a:rPr>
-              <a:t>2 / 11</a:t>
+              <a:t>2 / 12</a:t>
             </a:r>
           </a:p>
         </p:txBody>
@@ -6357,7 +7605,7 @@
                   <a:srgbClr val="888888"/>
                 </a:solidFill>
               </a:rPr>
-              <a:t>3 / 11</a:t>
+              <a:t>3 / 12</a:t>
             </a:r>
           </a:p>
         </p:txBody>
@@ -7989,7 +9237,7 @@
                   <a:srgbClr val="888888"/>
                 </a:solidFill>
               </a:rPr>
-              <a:t>4 / 11</a:t>
+              <a:t>4 / 12</a:t>
             </a:r>
           </a:p>
         </p:txBody>
@@ -8992,7 +10240,7 @@
                   <a:srgbClr val="888888"/>
                 </a:solidFill>
               </a:rPr>
-              <a:t>5 / 11</a:t>
+              <a:t>5 / 12</a:t>
             </a:r>
           </a:p>
         </p:txBody>
@@ -9714,7 +10962,7 @@
                   <a:srgbClr val="888888"/>
                 </a:solidFill>
               </a:rPr>
-              <a:t>6 / 11</a:t>
+              <a:t>6 / 12</a:t>
             </a:r>
           </a:p>
         </p:txBody>
@@ -10340,7 +11588,7 @@
                   <a:srgbClr val="888888"/>
                 </a:solidFill>
               </a:rPr>
-              <a:t>7 / 11</a:t>
+              <a:t>7 / 12</a:t>
             </a:r>
           </a:p>
         </p:txBody>
@@ -11024,7 +12272,7 @@
                   <a:srgbClr val="888888"/>
                 </a:solidFill>
               </a:rPr>
-              <a:t>8 / 11</a:t>
+              <a:t>8 / 12</a:t>
             </a:r>
           </a:p>
         </p:txBody>
@@ -12307,7 +13555,7 @@
                   <a:srgbClr val="888888"/>
                 </a:solidFill>
               </a:rPr>
-              <a:t>9 / 11</a:t>
+              <a:t>9 / 12</a:t>
             </a:r>
           </a:p>
         </p:txBody>

</xml_diff>

<commit_message>
Fix Cyber slide layout — scan flow vertical, no overlap
Scanning pipeline boxes now stacked vertically (not horizontal)
to fit within the left column. Compliance panel on the right
no longer overlaps. Descriptions shortened to fit.

Co-Authored-By: Claude Opus 4.6 (1M context) <noreply@anthropic.com>
</commit_message>
<xml_diff>
--- a/docs/presentations/MBSE_Pipeline_Executive_Brief.pptx
+++ b/docs/presentations/MBSE_Pipeline_Executive_Brief.pptx
@@ -3343,7 +3343,7 @@
               </a:spcAft>
             </a:pPr>
             <a:r>
-              <a:rPr sz="1600" b="1">
+              <a:rPr sz="1400" b="1">
                 <a:solidFill>
                   <a:srgbClr val="0D1B2A"/>
                 </a:solidFill>
@@ -3361,8 +3361,8 @@
         </p:nvSpPr>
         <p:spPr>
           <a:xfrm>
-            <a:off x="457200" y="1920240"/>
-            <a:ext cx="2560320" cy="777240"/>
+            <a:off x="457200" y="1828800"/>
+            <a:ext cx="5303520" cy="502920"/>
           </a:xfrm>
           <a:prstGeom prst="roundRect">
             <a:avLst/>
@@ -3404,48 +3404,40 @@
         </p:nvSpPr>
         <p:spPr>
           <a:xfrm>
-            <a:off x="548640" y="1965960"/>
-            <a:ext cx="2377440" cy="685800"/>
-          </a:xfrm>
-          <a:prstGeom prst="rect">
-            <a:avLst/>
-          </a:prstGeom>
-          <a:noFill/>
-        </p:spPr>
-        <p:txBody>
-          <a:bodyPr wrap="square">
-            <a:spAutoFit/>
-          </a:bodyPr>
-          <a:lstStyle/>
-          <a:p>
-            <a:pPr algn="l">
-              <a:spcAft>
-                <a:spcPts val="100"/>
-              </a:spcAft>
-            </a:pPr>
-            <a:r>
-              <a:rPr sz="900" b="1">
+            <a:off x="548640" y="1874520"/>
+            <a:ext cx="5120640" cy="411480"/>
+          </a:xfrm>
+          <a:prstGeom prst="rect">
+            <a:avLst/>
+          </a:prstGeom>
+          <a:noFill/>
+        </p:spPr>
+        <p:txBody>
+          <a:bodyPr wrap="square">
+            <a:spAutoFit/>
+          </a:bodyPr>
+          <a:lstStyle/>
+          <a:p>
+            <a:pPr algn="l">
+              <a:spcAft>
+                <a:spcPts val="0"/>
+              </a:spcAft>
+            </a:pPr>
+            <a:r>
+              <a:rPr sz="1000" b="1">
                 <a:solidFill>
                   <a:srgbClr val="FFFFFF"/>
                 </a:solidFill>
               </a:rPr>
               <a:t>Container Image</a:t>
             </a:r>
-          </a:p>
-          <a:p>
-            <a:pPr algn="l">
-              <a:spcAft>
-                <a:spcPts val="0"/>
-              </a:spcAft>
-            </a:pPr>
-            <a:r>
-              <a:rPr sz="700" b="0">
+            <a:r>
+              <a:rPr sz="800" b="0">
                 <a:solidFill>
                   <a:srgbClr val="BBBBBB"/>
                 </a:solidFill>
               </a:rPr>
-              <a:t>Product containers
-built by CI/CD</a:t>
+              <a:t>  —  Product containers built by CI/CD</a:t>
             </a:r>
           </a:p>
         </p:txBody>
@@ -3458,8 +3450,8 @@
         </p:nvSpPr>
         <p:spPr>
           <a:xfrm>
-            <a:off x="3108960" y="1920240"/>
-            <a:ext cx="2560320" cy="777240"/>
+            <a:off x="457200" y="2395728"/>
+            <a:ext cx="5303520" cy="502920"/>
           </a:xfrm>
           <a:prstGeom prst="roundRect">
             <a:avLst/>
@@ -3501,48 +3493,40 @@
         </p:nvSpPr>
         <p:spPr>
           <a:xfrm>
-            <a:off x="3200400" y="1965960"/>
-            <a:ext cx="2377440" cy="685800"/>
-          </a:xfrm>
-          <a:prstGeom prst="rect">
-            <a:avLst/>
-          </a:prstGeom>
-          <a:noFill/>
-        </p:spPr>
-        <p:txBody>
-          <a:bodyPr wrap="square">
-            <a:spAutoFit/>
-          </a:bodyPr>
-          <a:lstStyle/>
-          <a:p>
-            <a:pPr algn="l">
-              <a:spcAft>
-                <a:spcPts val="100"/>
-              </a:spcAft>
-            </a:pPr>
-            <a:r>
-              <a:rPr sz="900" b="1">
+            <a:off x="548640" y="2441448"/>
+            <a:ext cx="5120640" cy="411480"/>
+          </a:xfrm>
+          <a:prstGeom prst="rect">
+            <a:avLst/>
+          </a:prstGeom>
+          <a:noFill/>
+        </p:spPr>
+        <p:txBody>
+          <a:bodyPr wrap="square">
+            <a:spAutoFit/>
+          </a:bodyPr>
+          <a:lstStyle/>
+          <a:p>
+            <a:pPr algn="l">
+              <a:spcAft>
+                <a:spcPts val="0"/>
+              </a:spcAft>
+            </a:pPr>
+            <a:r>
+              <a:rPr sz="1000" b="1">
                 <a:solidFill>
                   <a:srgbClr val="FFFFFF"/>
                 </a:solidFill>
               </a:rPr>
-              <a:t>→  Syft (SBOM)</a:t>
-            </a:r>
-          </a:p>
-          <a:p>
-            <a:pPr algn="l">
-              <a:spcAft>
-                <a:spcPts val="0"/>
-              </a:spcAft>
-            </a:pPr>
-            <a:r>
-              <a:rPr sz="700" b="0">
+              <a:t>Syft → SBOM</a:t>
+            </a:r>
+            <a:r>
+              <a:rPr sz="800" b="0">
                 <a:solidFill>
                   <a:srgbClr val="BBBBBB"/>
                 </a:solidFill>
               </a:rPr>
-              <a:t>Generates CycloneDX
-Software Bill of Materials</a:t>
+              <a:t>  —  Generates CycloneDX Software Bill of Materials</a:t>
             </a:r>
           </a:p>
         </p:txBody>
@@ -3555,8 +3539,8 @@
         </p:nvSpPr>
         <p:spPr>
           <a:xfrm>
-            <a:off x="5760720" y="1920240"/>
-            <a:ext cx="2560320" cy="777240"/>
+            <a:off x="457200" y="2962656"/>
+            <a:ext cx="5303520" cy="502920"/>
           </a:xfrm>
           <a:prstGeom prst="roundRect">
             <a:avLst/>
@@ -3598,48 +3582,40 @@
         </p:nvSpPr>
         <p:spPr>
           <a:xfrm>
-            <a:off x="5852160" y="1965960"/>
-            <a:ext cx="2377440" cy="685800"/>
-          </a:xfrm>
-          <a:prstGeom prst="rect">
-            <a:avLst/>
-          </a:prstGeom>
-          <a:noFill/>
-        </p:spPr>
-        <p:txBody>
-          <a:bodyPr wrap="square">
-            <a:spAutoFit/>
-          </a:bodyPr>
-          <a:lstStyle/>
-          <a:p>
-            <a:pPr algn="l">
-              <a:spcAft>
-                <a:spcPts val="100"/>
-              </a:spcAft>
-            </a:pPr>
-            <a:r>
-              <a:rPr sz="900" b="1">
+            <a:off x="548640" y="3008376"/>
+            <a:ext cx="5120640" cy="411480"/>
+          </a:xfrm>
+          <a:prstGeom prst="rect">
+            <a:avLst/>
+          </a:prstGeom>
+          <a:noFill/>
+        </p:spPr>
+        <p:txBody>
+          <a:bodyPr wrap="square">
+            <a:spAutoFit/>
+          </a:bodyPr>
+          <a:lstStyle/>
+          <a:p>
+            <a:pPr algn="l">
+              <a:spcAft>
+                <a:spcPts val="0"/>
+              </a:spcAft>
+            </a:pPr>
+            <a:r>
+              <a:rPr sz="1000" b="1">
                 <a:solidFill>
                   <a:srgbClr val="FFFFFF"/>
                 </a:solidFill>
               </a:rPr>
-              <a:t>→  Grype (Scan)</a:t>
-            </a:r>
-          </a:p>
-          <a:p>
-            <a:pPr algn="l">
-              <a:spcAft>
-                <a:spcPts val="0"/>
-              </a:spcAft>
-            </a:pPr>
-            <a:r>
-              <a:rPr sz="700" b="0">
+              <a:t>Grype → Scan</a:t>
+            </a:r>
+            <a:r>
+              <a:rPr sz="800" b="0">
                 <a:solidFill>
                   <a:srgbClr val="BBBBBB"/>
                 </a:solidFill>
               </a:rPr>
-              <a:t>Scans SBOM against
-known vulnerability DBs</a:t>
+              <a:t>  —  Scans SBOM against known vulnerability databases</a:t>
             </a:r>
           </a:p>
         </p:txBody>
@@ -3652,8 +3628,8 @@
         </p:nvSpPr>
         <p:spPr>
           <a:xfrm>
-            <a:off x="8412480" y="1920240"/>
-            <a:ext cx="2560320" cy="777240"/>
+            <a:off x="457200" y="3529584"/>
+            <a:ext cx="5303520" cy="502920"/>
           </a:xfrm>
           <a:prstGeom prst="roundRect">
             <a:avLst/>
@@ -3695,48 +3671,40 @@
         </p:nvSpPr>
         <p:spPr>
           <a:xfrm>
-            <a:off x="8503920" y="1965960"/>
-            <a:ext cx="2377440" cy="685800"/>
-          </a:xfrm>
-          <a:prstGeom prst="rect">
-            <a:avLst/>
-          </a:prstGeom>
-          <a:noFill/>
-        </p:spPr>
-        <p:txBody>
-          <a:bodyPr wrap="square">
-            <a:spAutoFit/>
-          </a:bodyPr>
-          <a:lstStyle/>
-          <a:p>
-            <a:pPr algn="l">
-              <a:spcAft>
-                <a:spcPts val="100"/>
-              </a:spcAft>
-            </a:pPr>
-            <a:r>
-              <a:rPr sz="900" b="1">
+            <a:off x="548640" y="3575304"/>
+            <a:ext cx="5120640" cy="411480"/>
+          </a:xfrm>
+          <a:prstGeom prst="rect">
+            <a:avLst/>
+          </a:prstGeom>
+          <a:noFill/>
+        </p:spPr>
+        <p:txBody>
+          <a:bodyPr wrap="square">
+            <a:spAutoFit/>
+          </a:bodyPr>
+          <a:lstStyle/>
+          <a:p>
+            <a:pPr algn="l">
+              <a:spcAft>
+                <a:spcPts val="0"/>
+              </a:spcAft>
+            </a:pPr>
+            <a:r>
+              <a:rPr sz="1000" b="1">
                 <a:solidFill>
                   <a:srgbClr val="FFFFFF"/>
                 </a:solidFill>
               </a:rPr>
-              <a:t>→  Policy Gate</a:t>
-            </a:r>
-          </a:p>
-          <a:p>
-            <a:pPr algn="l">
-              <a:spcAft>
-                <a:spcPts val="0"/>
-              </a:spcAft>
-            </a:pPr>
-            <a:r>
-              <a:rPr sz="700" b="0">
+              <a:t>Policy Gate</a:t>
+            </a:r>
+            <a:r>
+              <a:rPr sz="800" b="0">
                 <a:solidFill>
                   <a:srgbClr val="BBBBBB"/>
                 </a:solidFill>
               </a:rPr>
-              <a:t>Fail on Critical/High
-Pass with advisory</a:t>
+              <a:t>  —  PASS / WARNING / FAIL based on severity thresholds</a:t>
             </a:r>
           </a:p>
         </p:txBody>
@@ -3749,8 +3717,8 @@
         </p:nvSpPr>
         <p:spPr>
           <a:xfrm>
-            <a:off x="731520" y="3017520"/>
-            <a:ext cx="4572000" cy="274320"/>
+            <a:off x="731520" y="4206240"/>
+            <a:ext cx="5029200" cy="274320"/>
           </a:xfrm>
           <a:prstGeom prst="rect">
             <a:avLst/>
@@ -3787,47 +3755,40 @@
         </p:nvSpPr>
         <p:spPr>
           <a:xfrm>
-            <a:off x="731520" y="3383280"/>
-            <a:ext cx="5029200" cy="548640"/>
-          </a:xfrm>
-          <a:prstGeom prst="rect">
-            <a:avLst/>
-          </a:prstGeom>
-          <a:noFill/>
-        </p:spPr>
-        <p:txBody>
-          <a:bodyPr wrap="square">
-            <a:spAutoFit/>
-          </a:bodyPr>
-          <a:lstStyle/>
-          <a:p>
-            <a:pPr algn="l">
-              <a:spcAft>
-                <a:spcPts val="200"/>
-              </a:spcAft>
-            </a:pPr>
-            <a:r>
-              <a:rPr sz="1100" b="1">
+            <a:off x="731520" y="4572000"/>
+            <a:ext cx="5029200" cy="320040"/>
+          </a:xfrm>
+          <a:prstGeom prst="rect">
+            <a:avLst/>
+          </a:prstGeom>
+          <a:noFill/>
+        </p:spPr>
+        <p:txBody>
+          <a:bodyPr wrap="square">
+            <a:spAutoFit/>
+          </a:bodyPr>
+          <a:lstStyle/>
+          <a:p>
+            <a:pPr algn="l">
+              <a:spcAft>
+                <a:spcPts val="0"/>
+              </a:spcAft>
+            </a:pPr>
+            <a:r>
+              <a:rPr sz="1000" b="1">
                 <a:solidFill>
                   <a:srgbClr val="0069B0"/>
                 </a:solidFill>
               </a:rPr>
               <a:t>SBOM (CycloneDX)</a:t>
             </a:r>
-          </a:p>
-          <a:p>
-            <a:pPr algn="l">
-              <a:spcAft>
-                <a:spcPts val="0"/>
-              </a:spcAft>
-            </a:pPr>
             <a:r>
               <a:rPr sz="900" b="0">
                 <a:solidFill>
                   <a:srgbClr val="555555"/>
                 </a:solidFill>
               </a:rPr>
-              <a:t>Complete inventory of every software component, version, and source in the deployed artifact.</a:t>
+              <a:t>  —  Complete component inventory with versions and sources.</a:t>
             </a:r>
           </a:p>
         </p:txBody>
@@ -3840,47 +3801,40 @@
         </p:nvSpPr>
         <p:spPr>
           <a:xfrm>
-            <a:off x="731520" y="3977640"/>
-            <a:ext cx="5029200" cy="548640"/>
-          </a:xfrm>
-          <a:prstGeom prst="rect">
-            <a:avLst/>
-          </a:prstGeom>
-          <a:noFill/>
-        </p:spPr>
-        <p:txBody>
-          <a:bodyPr wrap="square">
-            <a:spAutoFit/>
-          </a:bodyPr>
-          <a:lstStyle/>
-          <a:p>
-            <a:pPr algn="l">
-              <a:spcAft>
-                <a:spcPts val="200"/>
-              </a:spcAft>
-            </a:pPr>
-            <a:r>
-              <a:rPr sz="1100" b="1">
+            <a:off x="731520" y="4919472"/>
+            <a:ext cx="5029200" cy="320040"/>
+          </a:xfrm>
+          <a:prstGeom prst="rect">
+            <a:avLst/>
+          </a:prstGeom>
+          <a:noFill/>
+        </p:spPr>
+        <p:txBody>
+          <a:bodyPr wrap="square">
+            <a:spAutoFit/>
+          </a:bodyPr>
+          <a:lstStyle/>
+          <a:p>
+            <a:pPr algn="l">
+              <a:spcAft>
+                <a:spcPts val="0"/>
+              </a:spcAft>
+            </a:pPr>
+            <a:r>
+              <a:rPr sz="1000" b="1">
                 <a:solidFill>
                   <a:srgbClr val="0069B0"/>
                 </a:solidFill>
               </a:rPr>
               <a:t>Vulnerability Report</a:t>
             </a:r>
-          </a:p>
-          <a:p>
-            <a:pPr algn="l">
-              <a:spcAft>
-                <a:spcPts val="0"/>
-              </a:spcAft>
-            </a:pPr>
             <a:r>
               <a:rPr sz="900" b="0">
                 <a:solidFill>
                   <a:srgbClr val="555555"/>
                 </a:solidFill>
               </a:rPr>
-              <a:t>CVE-level findings with severity, affected package, version, and fix availability.</a:t>
+              <a:t>  —  CVE-level findings with severity and fix availability.</a:t>
             </a:r>
           </a:p>
         </p:txBody>
@@ -3893,47 +3847,40 @@
         </p:nvSpPr>
         <p:spPr>
           <a:xfrm>
-            <a:off x="731520" y="4572000"/>
-            <a:ext cx="5029200" cy="548640"/>
-          </a:xfrm>
-          <a:prstGeom prst="rect">
-            <a:avLst/>
-          </a:prstGeom>
-          <a:noFill/>
-        </p:spPr>
-        <p:txBody>
-          <a:bodyPr wrap="square">
-            <a:spAutoFit/>
-          </a:bodyPr>
-          <a:lstStyle/>
-          <a:p>
-            <a:pPr algn="l">
-              <a:spcAft>
-                <a:spcPts val="200"/>
-              </a:spcAft>
-            </a:pPr>
-            <a:r>
-              <a:rPr sz="1100" b="1">
+            <a:off x="731520" y="5266944"/>
+            <a:ext cx="5029200" cy="320040"/>
+          </a:xfrm>
+          <a:prstGeom prst="rect">
+            <a:avLst/>
+          </a:prstGeom>
+          <a:noFill/>
+        </p:spPr>
+        <p:txBody>
+          <a:bodyPr wrap="square">
+            <a:spAutoFit/>
+          </a:bodyPr>
+          <a:lstStyle/>
+          <a:p>
+            <a:pPr algn="l">
+              <a:spcAft>
+                <a:spcPts val="0"/>
+              </a:spcAft>
+            </a:pPr>
+            <a:r>
+              <a:rPr sz="1000" b="1">
                 <a:solidFill>
                   <a:srgbClr val="0069B0"/>
                 </a:solidFill>
               </a:rPr>
               <a:t>Policy Verdict</a:t>
             </a:r>
-          </a:p>
-          <a:p>
-            <a:pPr algn="l">
-              <a:spcAft>
-                <a:spcPts val="0"/>
-              </a:spcAft>
-            </a:pPr>
             <a:r>
               <a:rPr sz="900" b="0">
                 <a:solidFill>
                   <a:srgbClr val="555555"/>
                 </a:solidFill>
               </a:rPr>
-              <a:t>PASS / WARNING / FAIL based on configurable severity thresholds. Blocks deployment on Critical/High.</a:t>
+              <a:t>  —  Blocks deployment on Critical/High findings.</a:t>
             </a:r>
           </a:p>
         </p:txBody>
@@ -3946,47 +3893,40 @@
         </p:nvSpPr>
         <p:spPr>
           <a:xfrm>
-            <a:off x="731520" y="5166360"/>
-            <a:ext cx="5029200" cy="548640"/>
-          </a:xfrm>
-          <a:prstGeom prst="rect">
-            <a:avLst/>
-          </a:prstGeom>
-          <a:noFill/>
-        </p:spPr>
-        <p:txBody>
-          <a:bodyPr wrap="square">
-            <a:spAutoFit/>
-          </a:bodyPr>
-          <a:lstStyle/>
-          <a:p>
-            <a:pPr algn="l">
-              <a:spcAft>
-                <a:spcPts val="200"/>
-              </a:spcAft>
-            </a:pPr>
-            <a:r>
-              <a:rPr sz="1100" b="1">
+            <a:off x="731520" y="5614416"/>
+            <a:ext cx="5029200" cy="320040"/>
+          </a:xfrm>
+          <a:prstGeom prst="rect">
+            <a:avLst/>
+          </a:prstGeom>
+          <a:noFill/>
+        </p:spPr>
+        <p:txBody>
+          <a:bodyPr wrap="square">
+            <a:spAutoFit/>
+          </a:bodyPr>
+          <a:lstStyle/>
+          <a:p>
+            <a:pPr algn="l">
+              <a:spcAft>
+                <a:spcPts val="0"/>
+              </a:spcAft>
+            </a:pPr>
+            <a:r>
+              <a:rPr sz="1000" b="1">
                 <a:solidFill>
                   <a:srgbClr val="0069B0"/>
                 </a:solidFill>
               </a:rPr>
               <a:t>Severity Dashboard</a:t>
             </a:r>
-          </a:p>
-          <a:p>
-            <a:pPr algn="l">
-              <a:spcAft>
-                <a:spcPts val="0"/>
-              </a:spcAft>
-            </a:pPr>
             <a:r>
               <a:rPr sz="900" b="0">
                 <a:solidFill>
                   <a:srgbClr val="555555"/>
                 </a:solidFill>
               </a:rPr>
-              <a:t>Visual breakdown by severity level in the Deployment Pipeline Report — filterable, searchable, CSV-exportable.</a:t>
+              <a:t>  —  Visual breakdown in the Deployment Pipeline Report.</a:t>
             </a:r>
           </a:p>
         </p:txBody>
@@ -4000,7 +3940,7 @@
         <p:spPr>
           <a:xfrm>
             <a:off x="6217920" y="1371600"/>
-            <a:ext cx="5303520" cy="4572000"/>
+            <a:ext cx="5486400" cy="4572000"/>
           </a:xfrm>
           <a:prstGeom prst="roundRect">
             <a:avLst/>
@@ -4044,27 +3984,27 @@
         </p:nvSpPr>
         <p:spPr>
           <a:xfrm>
-            <a:off x="6400800" y="1554480"/>
-            <a:ext cx="4937760" cy="274320"/>
-          </a:xfrm>
-          <a:prstGeom prst="rect">
-            <a:avLst/>
-          </a:prstGeom>
-          <a:noFill/>
-        </p:spPr>
-        <p:txBody>
-          <a:bodyPr wrap="square">
-            <a:spAutoFit/>
-          </a:bodyPr>
-          <a:lstStyle/>
-          <a:p>
-            <a:pPr algn="l">
-              <a:spcAft>
-                <a:spcPts val="0"/>
-              </a:spcAft>
-            </a:pPr>
-            <a:r>
-              <a:rPr sz="1600" b="1">
+            <a:off x="6400800" y="1508760"/>
+            <a:ext cx="5120640" cy="274320"/>
+          </a:xfrm>
+          <a:prstGeom prst="rect">
+            <a:avLst/>
+          </a:prstGeom>
+          <a:noFill/>
+        </p:spPr>
+        <p:txBody>
+          <a:bodyPr wrap="square">
+            <a:spAutoFit/>
+          </a:bodyPr>
+          <a:lstStyle/>
+          <a:p>
+            <a:pPr algn="l">
+              <a:spcAft>
+                <a:spcPts val="0"/>
+              </a:spcAft>
+            </a:pPr>
+            <a:r>
+              <a:rPr sz="1400" b="1">
                 <a:solidFill>
                   <a:srgbClr val="0D1B2A"/>
                 </a:solidFill>
@@ -4082,8 +4022,8 @@
         </p:nvSpPr>
         <p:spPr>
           <a:xfrm>
-            <a:off x="6400800" y="2011680"/>
-            <a:ext cx="4937760" cy="731520"/>
+            <a:off x="6400800" y="1965960"/>
+            <a:ext cx="5120640" cy="640080"/>
           </a:xfrm>
           <a:prstGeom prst="rect">
             <a:avLst/>
@@ -4117,12 +4057,12 @@
               </a:spcAft>
             </a:pPr>
             <a:r>
-              <a:rPr sz="800" b="0">
+              <a:rPr sz="900" b="0">
                 <a:solidFill>
                   <a:srgbClr val="555555"/>
                 </a:solidFill>
               </a:rPr>
-              <a:t>Federal mandate requiring SBOMs for all software sold to the government. The pipeline generates CycloneDX SBOMs automatically on every build.</a:t>
+              <a:t>Federal mandate requiring SBOMs for all software sold to the government.</a:t>
             </a:r>
           </a:p>
         </p:txBody>
@@ -4135,8 +4075,8 @@
         </p:nvSpPr>
         <p:spPr>
           <a:xfrm>
-            <a:off x="6400800" y="2788920"/>
-            <a:ext cx="4937760" cy="731520"/>
+            <a:off x="6400800" y="2606040"/>
+            <a:ext cx="5120640" cy="640080"/>
           </a:xfrm>
           <a:prstGeom prst="rect">
             <a:avLst/>
@@ -4170,12 +4110,12 @@
               </a:spcAft>
             </a:pPr>
             <a:r>
-              <a:rPr sz="800" b="0">
+              <a:rPr sz="900" b="0">
                 <a:solidFill>
                   <a:srgbClr val="555555"/>
                 </a:solidFill>
               </a:rPr>
-              <a:t>Secure Software Development Framework requires vulnerability scanning and remediation tracking. Grype scan results are stored per build as immutable CI artifacts.</a:t>
+              <a:t>Requires vulnerability scanning and remediation tracking per build.</a:t>
             </a:r>
           </a:p>
         </p:txBody>
@@ -4188,8 +4128,8 @@
         </p:nvSpPr>
         <p:spPr>
           <a:xfrm>
-            <a:off x="6400800" y="3566160"/>
-            <a:ext cx="4937760" cy="731520"/>
+            <a:off x="6400800" y="3246120"/>
+            <a:ext cx="5120640" cy="640080"/>
           </a:xfrm>
           <a:prstGeom prst="rect">
             <a:avLst/>
@@ -4223,12 +4163,12 @@
               </a:spcAft>
             </a:pPr>
             <a:r>
-              <a:rPr sz="800" b="0">
+              <a:rPr sz="900" b="0">
                 <a:solidFill>
                   <a:srgbClr val="555555"/>
                 </a:solidFill>
               </a:rPr>
-              <a:t>Every component in the deployed product is inventoried with name, version, type, and package URL. No hidden dependencies.</a:t>
+              <a:t>Every component inventoried with name, version, type, and package URL.</a:t>
             </a:r>
           </a:p>
         </p:txBody>
@@ -4241,8 +4181,8 @@
         </p:nvSpPr>
         <p:spPr>
           <a:xfrm>
-            <a:off x="6400800" y="4343400"/>
-            <a:ext cx="4937760" cy="731520"/>
+            <a:off x="6400800" y="3886200"/>
+            <a:ext cx="5120640" cy="640080"/>
           </a:xfrm>
           <a:prstGeom prst="rect">
             <a:avLst/>
@@ -4276,12 +4216,12 @@
               </a:spcAft>
             </a:pPr>
             <a:r>
-              <a:rPr sz="800" b="0">
+              <a:rPr sz="900" b="0">
                 <a:solidFill>
                   <a:srgbClr val="555555"/>
                 </a:solidFill>
               </a:rPr>
-              <a:t>SBOM + vulnerability scan results are included in the deployment evidence bundle. No manual assembly — generated fresh on every pipeline run.</a:t>
+              <a:t>SBOM + scan results included in evidence bundle. No manual assembly.</a:t>
             </a:r>
           </a:p>
         </p:txBody>
@@ -4294,8 +4234,8 @@
         </p:nvSpPr>
         <p:spPr>
           <a:xfrm>
-            <a:off x="6400800" y="5120640"/>
-            <a:ext cx="4937760" cy="731520"/>
+            <a:off x="6400800" y="4526280"/>
+            <a:ext cx="5120640" cy="640080"/>
           </a:xfrm>
           <a:prstGeom prst="rect">
             <a:avLst/>
@@ -4329,12 +4269,12 @@
               </a:spcAft>
             </a:pPr>
             <a:r>
-              <a:rPr sz="800" b="0">
+              <a:rPr sz="900" b="0">
                 <a:solidFill>
                   <a:srgbClr val="555555"/>
                 </a:solidFill>
               </a:rPr>
-              <a:t>Grype vulnerability database can be mirrored internally. Syft runs against local container images. No internet required at scan time.</a:t>
+              <a:t>Grype DB mirrored internally. Syft runs against local images. No internet.</a:t>
             </a:r>
           </a:p>
         </p:txBody>
@@ -4347,8 +4287,8 @@
         </p:nvSpPr>
         <p:spPr>
           <a:xfrm>
-            <a:off x="457200" y="6035040"/>
-            <a:ext cx="11247120" cy="411480"/>
+            <a:off x="457200" y="6126480"/>
+            <a:ext cx="11247120" cy="365760"/>
           </a:xfrm>
           <a:prstGeom prst="roundRect">
             <a:avLst/>
@@ -4392,8 +4332,8 @@
         </p:nvSpPr>
         <p:spPr>
           <a:xfrm>
-            <a:off x="731520" y="6089904"/>
-            <a:ext cx="10789920" cy="320040"/>
+            <a:off x="731520" y="6172200"/>
+            <a:ext cx="10789920" cy="274320"/>
           </a:xfrm>
           <a:prstGeom prst="rect">
             <a:avLst/>
@@ -4412,7 +4352,7 @@
               </a:spcAft>
             </a:pPr>
             <a:r>
-              <a:rPr sz="1100" b="1">
+              <a:rPr sz="1000" b="1">
                 <a:solidFill>
                   <a:srgbClr val="0D1B2A"/>
                 </a:solidFill>

</xml_diff>

<commit_message>
Consistent blue colors across all pipeline stages — no orange
Quality Gates and Policy Gate now use NAVY_2 (same blue family)
instead of AMBER. All pipeline stages use the graduated blue
palette: NAVY_1 -> NAVY_2 -> BLUE_NG -> BLUE_4.

Co-Authored-By: Claude Opus 4.6 (1M context) <noreply@anthropic.com>
</commit_message>
<xml_diff>
--- a/docs/presentations/MBSE_Pipeline_Executive_Brief.pptx
+++ b/docs/presentations/MBSE_Pipeline_Executive_Brief.pptx
@@ -3635,7 +3635,7 @@
             <a:avLst/>
           </a:prstGeom>
           <a:solidFill>
-            <a:srgbClr val="B45309"/>
+            <a:srgbClr val="004A87"/>
           </a:solidFill>
           <a:ln>
             <a:noFill/>
@@ -7115,7 +7115,7 @@
             <a:avLst/>
           </a:prstGeom>
           <a:solidFill>
-            <a:srgbClr val="B45309"/>
+            <a:srgbClr val="004A87"/>
           </a:solidFill>
           <a:ln>
             <a:noFill/>
@@ -12954,7 +12954,7 @@
             <a:avLst/>
           </a:prstGeom>
           <a:solidFill>
-            <a:srgbClr val="B45309"/>
+            <a:srgbClr val="004A87"/>
           </a:solidFill>
           <a:ln>
             <a:noFill/>
@@ -13051,7 +13051,7 @@
             <a:avLst/>
           </a:prstGeom>
           <a:solidFill>
-            <a:srgbClr val="B45309"/>
+            <a:srgbClr val="004A87"/>
           </a:solidFill>
           <a:ln>
             <a:noFill/>
@@ -13148,7 +13148,7 @@
             <a:avLst/>
           </a:prstGeom>
           <a:solidFill>
-            <a:srgbClr val="B45309"/>
+            <a:srgbClr val="004A87"/>
           </a:solidFill>
           <a:ln>
             <a:noFill/>

</xml_diff>

<commit_message>
Rebuild slide 3: Gherkin as the Common Language
Centerpiece is the Gherkin bridge between SEs (Cameo Model) and
Developers (Automated Tests). Three columns show:
- Left: what SEs own (requirements, criteria, model changes)
- Center: Gherkin spec (co-authored, with code example)
- Right: what devs own (step defs, log analysis, CI/CD)

Compact pipeline lanes below. Key points on the right: readable
by both sides, machine-traceable via tags, pipeline-enforced.

Co-Authored-By: Claude Opus 4.6 (1M context) <noreply@anthropic.com>
</commit_message>
<xml_diff>
--- a/docs/presentations/MBSE_Pipeline_Executive_Brief.pptx
+++ b/docs/presentations/MBSE_Pipeline_Executive_Brief.pptx
@@ -6280,7 +6280,7 @@
                   <a:srgbClr val="0D1B2A"/>
                 </a:solidFill>
               </a:rPr>
-              <a:t>The Solution: Two Pipelines, One Thread</a:t>
+              <a:t>The Solution: Gherkin as the Common Language</a:t>
             </a:r>
           </a:p>
         </p:txBody>
@@ -6294,7 +6294,7 @@
         <p:spPr>
           <a:xfrm>
             <a:off x="731520" y="868680"/>
-            <a:ext cx="9144000" cy="320040"/>
+            <a:ext cx="10058400" cy="320040"/>
           </a:xfrm>
           <a:prstGeom prst="rect">
             <a:avLst/>
@@ -6318,7 +6318,7 @@
                   <a:srgbClr val="555555"/>
                 </a:solidFill>
               </a:rPr>
-              <a:t>A single automated thread connects the Cameo model to the deployed product — with quality gates enforcing traceability at every stage.</a:t>
+              <a:t>Systems Engineers and developers communicate through executable specifications — Gherkin scenarios that trace directly to Cameo requirements and run as automated tests.</a:t>
             </a:r>
           </a:p>
         </p:txBody>
@@ -6332,7 +6332,7 @@
         <p:spPr>
           <a:xfrm>
             <a:off x="457200" y="1554480"/>
-            <a:ext cx="11247120" cy="1645920"/>
+            <a:ext cx="3200400" cy="2560320"/>
           </a:xfrm>
           <a:prstGeom prst="roundRect">
             <a:avLst/>
@@ -6376,46 +6376,69 @@
         </p:nvSpPr>
         <p:spPr>
           <a:xfrm>
-            <a:off x="640080" y="1627632"/>
-            <a:ext cx="3657600" cy="457200"/>
-          </a:xfrm>
-          <a:prstGeom prst="rect">
-            <a:avLst/>
-          </a:prstGeom>
-          <a:noFill/>
-        </p:spPr>
-        <p:txBody>
-          <a:bodyPr wrap="square">
-            <a:spAutoFit/>
-          </a:bodyPr>
-          <a:lstStyle/>
-          <a:p>
-            <a:pPr algn="l">
-              <a:spcAft>
-                <a:spcPts val="100"/>
-              </a:spcAft>
-            </a:pPr>
-            <a:r>
-              <a:rPr sz="900" b="1">
+            <a:off x="640080" y="1645920"/>
+            <a:ext cx="2834640" cy="274320"/>
+          </a:xfrm>
+          <a:prstGeom prst="rect">
+            <a:avLst/>
+          </a:prstGeom>
+          <a:noFill/>
+        </p:spPr>
+        <p:txBody>
+          <a:bodyPr wrap="square">
+            <a:spAutoFit/>
+          </a:bodyPr>
+          <a:lstStyle/>
+          <a:p>
+            <a:pPr algn="l">
+              <a:spcAft>
+                <a:spcPts val="0"/>
+              </a:spcAft>
+            </a:pPr>
+            <a:r>
+              <a:rPr sz="1400" b="1">
+                <a:solidFill>
+                  <a:srgbClr val="0D1B2A"/>
+                </a:solidFill>
+              </a:rPr>
+              <a:t>Cameo Model</a:t>
+            </a:r>
+          </a:p>
+        </p:txBody>
+      </p:sp>
+      <p:sp>
+        <p:nvSpPr>
+          <p:cNvPr id="6" name="TextBox 5"/>
+          <p:cNvSpPr txBox="1"/>
+          <p:nvPr/>
+        </p:nvSpPr>
+        <p:spPr>
+          <a:xfrm>
+            <a:off x="640080" y="1965960"/>
+            <a:ext cx="2834640" cy="228600"/>
+          </a:xfrm>
+          <a:prstGeom prst="rect">
+            <a:avLst/>
+          </a:prstGeom>
+          <a:noFill/>
+        </p:spPr>
+        <p:txBody>
+          <a:bodyPr wrap="square">
+            <a:spAutoFit/>
+          </a:bodyPr>
+          <a:lstStyle/>
+          <a:p>
+            <a:pPr algn="l">
+              <a:spcAft>
+                <a:spcPts val="0"/>
+              </a:spcAft>
+            </a:pPr>
+            <a:r>
+              <a:rPr sz="900" b="0">
                 <a:solidFill>
                   <a:srgbClr val="0099D6"/>
                 </a:solidFill>
               </a:rPr>
-              <a:t>MODEL PIPELINE  •  cameo-model-pipeline</a:t>
-            </a:r>
-          </a:p>
-          <a:p>
-            <a:pPr algn="l">
-              <a:spcAft>
-                <a:spcPts val="0"/>
-              </a:spcAft>
-            </a:pPr>
-            <a:r>
-              <a:rPr sz="800" b="0">
-                <a:solidFill>
-                  <a:srgbClr val="888888"/>
-                </a:solidFill>
-              </a:rPr>
               <a:t>Owned by Systems Engineers</a:t>
             </a:r>
           </a:p>
@@ -6423,97 +6446,83 @@
       </p:sp>
       <p:sp>
         <p:nvSpPr>
-          <p:cNvPr id="6" name="Rounded Rectangle 5"/>
-          <p:cNvSpPr/>
-          <p:nvPr/>
-        </p:nvSpPr>
-        <p:spPr>
-          <a:xfrm>
-            <a:off x="640080" y="2194560"/>
-            <a:ext cx="2103120" cy="731520"/>
-          </a:xfrm>
-          <a:prstGeom prst="roundRect">
-            <a:avLst/>
-          </a:prstGeom>
-          <a:solidFill>
-            <a:srgbClr val="003057"/>
-          </a:solidFill>
-          <a:ln>
-            <a:noFill/>
-          </a:ln>
-        </p:spPr>
-        <p:style>
-          <a:lnRef idx="1">
-            <a:schemeClr val="accent1"/>
-          </a:lnRef>
-          <a:fillRef idx="3">
-            <a:schemeClr val="accent1"/>
-          </a:fillRef>
-          <a:effectRef idx="2">
-            <a:schemeClr val="accent1"/>
-          </a:effectRef>
-          <a:fontRef idx="minor">
-            <a:schemeClr val="lt1"/>
-          </a:fontRef>
-        </p:style>
-        <p:txBody>
-          <a:bodyPr rtlCol="0" anchor="ctr"/>
-          <a:lstStyle/>
-          <a:p>
-            <a:pPr algn="ctr"/>
-          </a:p>
-        </p:txBody>
-      </p:sp>
-      <p:sp>
-        <p:nvSpPr>
           <p:cNvPr id="7" name="TextBox 6"/>
           <p:cNvSpPr txBox="1"/>
           <p:nvPr/>
         </p:nvSpPr>
         <p:spPr>
           <a:xfrm>
-            <a:off x="731520" y="2267712"/>
-            <a:ext cx="1920240" cy="640080"/>
-          </a:xfrm>
-          <a:prstGeom prst="rect">
-            <a:avLst/>
-          </a:prstGeom>
-          <a:noFill/>
-        </p:spPr>
-        <p:txBody>
-          <a:bodyPr wrap="square">
-            <a:spAutoFit/>
-          </a:bodyPr>
-          <a:lstStyle/>
-          <a:p>
-            <a:pPr algn="l">
-              <a:spcAft>
-                <a:spcPts val="100"/>
-              </a:spcAft>
-            </a:pPr>
-            <a:r>
-              <a:rPr sz="900" b="1">
-                <a:solidFill>
-                  <a:srgbClr val="FFFFFF"/>
-                </a:solidFill>
-              </a:rPr>
-              <a:t>Cameo Model</a:t>
-            </a:r>
-          </a:p>
-          <a:p>
-            <a:pPr algn="l">
-              <a:spcAft>
-                <a:spcPts val="0"/>
-              </a:spcAft>
-            </a:pPr>
-            <a:r>
-              <a:rPr sz="700" b="0">
-                <a:solidFill>
-                  <a:srgbClr val="BBBBBB"/>
-                </a:solidFill>
-              </a:rPr>
-              <a:t>Author requirements
-&amp; ICD in the model</a:t>
+            <a:off x="640080" y="2331720"/>
+            <a:ext cx="2834640" cy="1645920"/>
+          </a:xfrm>
+          <a:prstGeom prst="rect">
+            <a:avLst/>
+          </a:prstGeom>
+          <a:noFill/>
+        </p:spPr>
+        <p:txBody>
+          <a:bodyPr wrap="square">
+            <a:spAutoFit/>
+          </a:bodyPr>
+          <a:lstStyle/>
+          <a:p>
+            <a:pPr algn="l">
+              <a:spcAft>
+                <a:spcPts val="500"/>
+              </a:spcAft>
+            </a:pPr>
+            <a:r>
+              <a:rPr sz="900" b="0">
+                <a:solidFill>
+                  <a:srgbClr val="555555"/>
+                </a:solidFill>
+              </a:rPr>
+              <a:t>•  Requirements with verification criteria</a:t>
+            </a:r>
+          </a:p>
+          <a:p>
+            <a:pPr algn="l">
+              <a:spcAft>
+                <a:spcPts val="500"/>
+              </a:spcAft>
+            </a:pPr>
+            <a:r>
+              <a:rPr sz="900" b="0">
+                <a:solidFill>
+                  <a:srgbClr val="555555"/>
+                </a:solidFill>
+              </a:rPr>
+              <a:t>•  ICD definitions and message types</a:t>
+            </a:r>
+          </a:p>
+          <a:p>
+            <a:pPr algn="l">
+              <a:spcAft>
+                <a:spcPts val="500"/>
+              </a:spcAft>
+            </a:pPr>
+            <a:r>
+              <a:rPr sz="900" b="0">
+                <a:solidFill>
+                  <a:srgbClr val="555555"/>
+                </a:solidFill>
+              </a:rPr>
+              <a:t>•  Criteria text drives test intent</a:t>
+            </a:r>
+          </a:p>
+          <a:p>
+            <a:pPr algn="l">
+              <a:spcAft>
+                <a:spcPts val="500"/>
+              </a:spcAft>
+            </a:pPr>
+            <a:r>
+              <a:rPr sz="900" b="0">
+                <a:solidFill>
+                  <a:srgbClr val="555555"/>
+                </a:solidFill>
+              </a:rPr>
+              <a:t>•  Model changes trigger drift detection</a:t>
             </a:r>
           </a:p>
         </p:txBody>
@@ -6526,105 +6535,8 @@
         </p:nvSpPr>
         <p:spPr>
           <a:xfrm>
-            <a:off x="2880360" y="2194560"/>
-            <a:ext cx="2103120" cy="731520"/>
-          </a:xfrm>
-          <a:prstGeom prst="roundRect">
-            <a:avLst/>
-          </a:prstGeom>
-          <a:solidFill>
-            <a:srgbClr val="004A87"/>
-          </a:solidFill>
-          <a:ln>
-            <a:noFill/>
-          </a:ln>
-        </p:spPr>
-        <p:style>
-          <a:lnRef idx="1">
-            <a:schemeClr val="accent1"/>
-          </a:lnRef>
-          <a:fillRef idx="3">
-            <a:schemeClr val="accent1"/>
-          </a:fillRef>
-          <a:effectRef idx="2">
-            <a:schemeClr val="accent1"/>
-          </a:effectRef>
-          <a:fontRef idx="minor">
-            <a:schemeClr val="lt1"/>
-          </a:fontRef>
-        </p:style>
-        <p:txBody>
-          <a:bodyPr rtlCol="0" anchor="ctr"/>
-          <a:lstStyle/>
-          <a:p>
-            <a:pPr algn="ctr"/>
-          </a:p>
-        </p:txBody>
-      </p:sp>
-      <p:sp>
-        <p:nvSpPr>
-          <p:cNvPr id="9" name="TextBox 8"/>
-          <p:cNvSpPr txBox="1"/>
-          <p:nvPr/>
-        </p:nvSpPr>
-        <p:spPr>
-          <a:xfrm>
-            <a:off x="2971800" y="2267712"/>
-            <a:ext cx="1920240" cy="640080"/>
-          </a:xfrm>
-          <a:prstGeom prst="rect">
-            <a:avLst/>
-          </a:prstGeom>
-          <a:noFill/>
-        </p:spPr>
-        <p:txBody>
-          <a:bodyPr wrap="square">
-            <a:spAutoFit/>
-          </a:bodyPr>
-          <a:lstStyle/>
-          <a:p>
-            <a:pPr algn="l">
-              <a:spcAft>
-                <a:spcPts val="100"/>
-              </a:spcAft>
-            </a:pPr>
-            <a:r>
-              <a:rPr sz="900" b="1">
-                <a:solidFill>
-                  <a:srgbClr val="FFFFFF"/>
-                </a:solidFill>
-              </a:rPr>
-              <a:t>→  Export &amp; Validate</a:t>
-            </a:r>
-          </a:p>
-          <a:p>
-            <a:pPr algn="l">
-              <a:spcAft>
-                <a:spcPts val="0"/>
-              </a:spcAft>
-            </a:pPr>
-            <a:r>
-              <a:rPr sz="700" b="0">
-                <a:solidFill>
-                  <a:srgbClr val="BBBBBB"/>
-                </a:solidFill>
-              </a:rPr>
-              <a:t>Schema validation
-of JSON exports</a:t>
-            </a:r>
-          </a:p>
-        </p:txBody>
-      </p:sp>
-      <p:sp>
-        <p:nvSpPr>
-          <p:cNvPr id="10" name="Rounded Rectangle 9"/>
-          <p:cNvSpPr/>
-          <p:nvPr/>
-        </p:nvSpPr>
-        <p:spPr>
-          <a:xfrm>
-            <a:off x="5120640" y="2194560"/>
-            <a:ext cx="2103120" cy="731520"/>
+            <a:off x="4023360" y="1371600"/>
+            <a:ext cx="4114800" cy="2926080"/>
           </a:xfrm>
           <a:prstGeom prst="roundRect">
             <a:avLst/>
@@ -6660,14 +6572,90 @@
       </p:sp>
       <p:sp>
         <p:nvSpPr>
+          <p:cNvPr id="9" name="TextBox 8"/>
+          <p:cNvSpPr txBox="1"/>
+          <p:nvPr/>
+        </p:nvSpPr>
+        <p:spPr>
+          <a:xfrm>
+            <a:off x="4206240" y="1463040"/>
+            <a:ext cx="3749039" cy="274320"/>
+          </a:xfrm>
+          <a:prstGeom prst="rect">
+            <a:avLst/>
+          </a:prstGeom>
+          <a:noFill/>
+        </p:spPr>
+        <p:txBody>
+          <a:bodyPr wrap="square">
+            <a:spAutoFit/>
+          </a:bodyPr>
+          <a:lstStyle/>
+          <a:p>
+            <a:pPr algn="ctr">
+              <a:spcAft>
+                <a:spcPts val="0"/>
+              </a:spcAft>
+            </a:pPr>
+            <a:r>
+              <a:rPr sz="1600" b="1">
+                <a:solidFill>
+                  <a:srgbClr val="FFFFFF"/>
+                </a:solidFill>
+              </a:rPr>
+              <a:t>Gherkin Specifications</a:t>
+            </a:r>
+          </a:p>
+        </p:txBody>
+      </p:sp>
+      <p:sp>
+        <p:nvSpPr>
+          <p:cNvPr id="10" name="TextBox 9"/>
+          <p:cNvSpPr txBox="1"/>
+          <p:nvPr/>
+        </p:nvSpPr>
+        <p:spPr>
+          <a:xfrm>
+            <a:off x="4206240" y="1783080"/>
+            <a:ext cx="3749039" cy="228600"/>
+          </a:xfrm>
+          <a:prstGeom prst="rect">
+            <a:avLst/>
+          </a:prstGeom>
+          <a:noFill/>
+        </p:spPr>
+        <p:txBody>
+          <a:bodyPr wrap="square">
+            <a:spAutoFit/>
+          </a:bodyPr>
+          <a:lstStyle/>
+          <a:p>
+            <a:pPr algn="ctr">
+              <a:spcAft>
+                <a:spcPts val="0"/>
+              </a:spcAft>
+            </a:pPr>
+            <a:r>
+              <a:rPr sz="900" b="0">
+                <a:solidFill>
+                  <a:srgbClr val="BBBBBB"/>
+                </a:solidFill>
+              </a:rPr>
+              <a:t>Co-authored by SEs + Developers</a:t>
+            </a:r>
+          </a:p>
+        </p:txBody>
+      </p:sp>
+      <p:sp>
+        <p:nvSpPr>
           <p:cNvPr id="11" name="TextBox 10"/>
           <p:cNvSpPr txBox="1"/>
           <p:nvPr/>
         </p:nvSpPr>
         <p:spPr>
           <a:xfrm>
-            <a:off x="5212080" y="2267712"/>
-            <a:ext cx="1920240" cy="640080"/>
+            <a:off x="4297680" y="2194560"/>
+            <a:ext cx="3566160" cy="1920240"/>
           </a:xfrm>
           <a:prstGeom prst="rect">
             <a:avLst/>
@@ -6686,28 +6674,117 @@
               </a:spcAft>
             </a:pPr>
             <a:r>
-              <a:rPr sz="900" b="1">
+              <a:rPr sz="800" b="1">
                 <a:solidFill>
                   <a:srgbClr val="FFFFFF"/>
                 </a:solidFill>
               </a:rPr>
-              <a:t>→  Package &amp; Version</a:t>
-            </a:r>
-          </a:p>
-          <a:p>
-            <a:pPr algn="l">
-              <a:spcAft>
-                <a:spcPts val="0"/>
-              </a:spcAft>
-            </a:pPr>
-            <a:r>
-              <a:rPr sz="700" b="0">
+              <a:t>@REQ:SYS-REQ-001</a:t>
+            </a:r>
+          </a:p>
+          <a:p>
+            <a:pPr algn="l">
+              <a:spcAft>
+                <a:spcPts val="100"/>
+              </a:spcAft>
+            </a:pPr>
+            <a:r>
+              <a:rPr sz="800" b="1">
+                <a:solidFill>
+                  <a:srgbClr val="FFFFFF"/>
+                </a:solidFill>
+              </a:rPr>
+              <a:t>Feature: Basic ICD Communications</a:t>
+            </a:r>
+          </a:p>
+          <a:p>
+            <a:pPr algn="l">
+              <a:spcAft>
+                <a:spcPts val="100"/>
+              </a:spcAft>
+            </a:pPr>
+            <a:r>
+              <a:rPr sz="800" b="0">
                 <a:solidFill>
                   <a:srgbClr val="BBBBBB"/>
                 </a:solidFill>
               </a:rPr>
-              <a:t>Semantic versioning
-&amp; artifact assembly</a:t>
+              <a:t> </a:t>
+            </a:r>
+          </a:p>
+          <a:p>
+            <a:pPr algn="l">
+              <a:spcAft>
+                <a:spcPts val="100"/>
+              </a:spcAft>
+            </a:pPr>
+            <a:r>
+              <a:rPr sz="800" b="1">
+                <a:solidFill>
+                  <a:srgbClr val="FFFFFF"/>
+                </a:solidFill>
+              </a:rPr>
+              <a:t>  @VC:SYS-REQ-001-VC-01 @VER:Test</a:t>
+            </a:r>
+          </a:p>
+          <a:p>
+            <a:pPr algn="l">
+              <a:spcAft>
+                <a:spcPts val="100"/>
+              </a:spcAft>
+            </a:pPr>
+            <a:r>
+              <a:rPr sz="800" b="0">
+                <a:solidFill>
+                  <a:srgbClr val="BBBBBB"/>
+                </a:solidFill>
+              </a:rPr>
+              <a:t>  Scenario: Valid ICD response</a:t>
+            </a:r>
+          </a:p>
+          <a:p>
+            <a:pPr algn="l">
+              <a:spcAft>
+                <a:spcPts val="100"/>
+              </a:spcAft>
+            </a:pPr>
+            <a:r>
+              <a:rPr sz="800" b="0">
+                <a:solidFill>
+                  <a:srgbClr val="BBBBBB"/>
+                </a:solidFill>
+              </a:rPr>
+              <a:t>    Given the simulation logs are loaded</a:t>
+            </a:r>
+          </a:p>
+          <a:p>
+            <a:pPr algn="l">
+              <a:spcAft>
+                <a:spcPts val="100"/>
+              </a:spcAft>
+            </a:pPr>
+            <a:r>
+              <a:rPr sz="800" b="0">
+                <a:solidFill>
+                  <a:srgbClr val="BBBBBB"/>
+                </a:solidFill>
+              </a:rPr>
+              <a:t>    Then the logs should contain</a:t>
+            </a:r>
+          </a:p>
+          <a:p>
+            <a:pPr algn="l">
+              <a:spcAft>
+                <a:spcPts val="100"/>
+              </a:spcAft>
+            </a:pPr>
+            <a:r>
+              <a:rPr sz="800" b="0">
+                <a:solidFill>
+                  <a:srgbClr val="BBBBBB"/>
+                </a:solidFill>
+              </a:rPr>
+              <a:t>         "IcdResponse: status=OK"</a:t>
             </a:r>
           </a:p>
         </p:txBody>
@@ -6720,201 +6797,8 @@
         </p:nvSpPr>
         <p:spPr>
           <a:xfrm>
-            <a:off x="7360920" y="2194560"/>
-            <a:ext cx="2103120" cy="731520"/>
-          </a:xfrm>
-          <a:prstGeom prst="roundRect">
-            <a:avLst/>
-          </a:prstGeom>
-          <a:solidFill>
-            <a:srgbClr val="0082CC"/>
-          </a:solidFill>
-          <a:ln>
-            <a:noFill/>
-          </a:ln>
-        </p:spPr>
-        <p:style>
-          <a:lnRef idx="1">
-            <a:schemeClr val="accent1"/>
-          </a:lnRef>
-          <a:fillRef idx="3">
-            <a:schemeClr val="accent1"/>
-          </a:fillRef>
-          <a:effectRef idx="2">
-            <a:schemeClr val="accent1"/>
-          </a:effectRef>
-          <a:fontRef idx="minor">
-            <a:schemeClr val="lt1"/>
-          </a:fontRef>
-        </p:style>
-        <p:txBody>
-          <a:bodyPr rtlCol="0" anchor="ctr"/>
-          <a:lstStyle/>
-          <a:p>
-            <a:pPr algn="ctr"/>
-          </a:p>
-        </p:txBody>
-      </p:sp>
-      <p:sp>
-        <p:nvSpPr>
-          <p:cNvPr id="13" name="TextBox 12"/>
-          <p:cNvSpPr txBox="1"/>
-          <p:nvPr/>
-        </p:nvSpPr>
-        <p:spPr>
-          <a:xfrm>
-            <a:off x="7452360" y="2267712"/>
-            <a:ext cx="1920240" cy="640080"/>
-          </a:xfrm>
-          <a:prstGeom prst="rect">
-            <a:avLst/>
-          </a:prstGeom>
-          <a:noFill/>
-        </p:spPr>
-        <p:txBody>
-          <a:bodyPr wrap="square">
-            <a:spAutoFit/>
-          </a:bodyPr>
-          <a:lstStyle/>
-          <a:p>
-            <a:pPr algn="l">
-              <a:spcAft>
-                <a:spcPts val="100"/>
-              </a:spcAft>
-            </a:pPr>
-            <a:r>
-              <a:rPr sz="900" b="1">
-                <a:solidFill>
-                  <a:srgbClr val="FFFFFF"/>
-                </a:solidFill>
-              </a:rPr>
-              <a:t>→  Publish Artifact</a:t>
-            </a:r>
-          </a:p>
-          <a:p>
-            <a:pPr algn="l">
-              <a:spcAft>
-                <a:spcPts val="0"/>
-              </a:spcAft>
-            </a:pPr>
-            <a:r>
-              <a:rPr sz="700" b="0">
-                <a:solidFill>
-                  <a:srgbClr val="BBBBBB"/>
-                </a:solidFill>
-              </a:rPr>
-              <a:t>Versioned ZIP to
-GitHub Releases</a:t>
-            </a:r>
-          </a:p>
-        </p:txBody>
-      </p:sp>
-      <p:sp>
-        <p:nvSpPr>
-          <p:cNvPr id="14" name="Down Arrow 13"/>
-          <p:cNvSpPr/>
-          <p:nvPr/>
-        </p:nvSpPr>
-        <p:spPr>
-          <a:xfrm>
-            <a:off x="5303520" y="3246120"/>
-            <a:ext cx="457200" cy="457200"/>
-          </a:xfrm>
-          <a:prstGeom prst="downArrow">
-            <a:avLst/>
-          </a:prstGeom>
-          <a:solidFill>
-            <a:srgbClr val="0069B0"/>
-          </a:solidFill>
-          <a:ln>
-            <a:noFill/>
-          </a:ln>
-        </p:spPr>
-        <p:style>
-          <a:lnRef idx="1">
-            <a:schemeClr val="accent1"/>
-          </a:lnRef>
-          <a:fillRef idx="3">
-            <a:schemeClr val="accent1"/>
-          </a:fillRef>
-          <a:effectRef idx="2">
-            <a:schemeClr val="accent1"/>
-          </a:effectRef>
-          <a:fontRef idx="minor">
-            <a:schemeClr val="lt1"/>
-          </a:fontRef>
-        </p:style>
-        <p:txBody>
-          <a:bodyPr rtlCol="0" anchor="ctr"/>
-          <a:lstStyle/>
-          <a:p>
-            <a:pPr algn="ctr"/>
-          </a:p>
-        </p:txBody>
-      </p:sp>
-      <p:sp>
-        <p:nvSpPr>
-          <p:cNvPr id="15" name="TextBox 14"/>
-          <p:cNvSpPr txBox="1"/>
-          <p:nvPr/>
-        </p:nvSpPr>
-        <p:spPr>
-          <a:xfrm>
-            <a:off x="5852160" y="3264408"/>
-            <a:ext cx="2286000" cy="365760"/>
-          </a:xfrm>
-          <a:prstGeom prst="rect">
-            <a:avLst/>
-          </a:prstGeom>
-          <a:noFill/>
-        </p:spPr>
-        <p:txBody>
-          <a:bodyPr wrap="square">
-            <a:spAutoFit/>
-          </a:bodyPr>
-          <a:lstStyle/>
-          <a:p>
-            <a:pPr algn="l">
-              <a:spcAft>
-                <a:spcPts val="100"/>
-              </a:spcAft>
-            </a:pPr>
-            <a:r>
-              <a:rPr sz="900" b="1">
-                <a:solidFill>
-                  <a:srgbClr val="0099D6"/>
-                </a:solidFill>
-              </a:rPr>
-              <a:t>Versioned Artifact</a:t>
-            </a:r>
-          </a:p>
-          <a:p>
-            <a:pPr algn="l">
-              <a:spcAft>
-                <a:spcPts val="0"/>
-              </a:spcAft>
-            </a:pPr>
-            <a:r>
-              <a:rPr sz="700" b="0">
-                <a:solidFill>
-                  <a:srgbClr val="888888"/>
-                </a:solidFill>
-              </a:rPr>
-              <a:t>requirements.json + proto files</a:t>
-            </a:r>
-          </a:p>
-        </p:txBody>
-      </p:sp>
-      <p:sp>
-        <p:nvSpPr>
-          <p:cNvPr id="16" name="Rounded Rectangle 15"/>
-          <p:cNvSpPr/>
-          <p:nvPr/>
-        </p:nvSpPr>
-        <p:spPr>
-          <a:xfrm>
-            <a:off x="457200" y="3794760"/>
-            <a:ext cx="11247120" cy="1645920"/>
+            <a:off x="8503920" y="1554480"/>
+            <a:ext cx="3200400" cy="2560320"/>
           </a:xfrm>
           <a:prstGeom prst="roundRect">
             <a:avLst/>
@@ -6952,263 +6836,175 @@
       </p:sp>
       <p:sp>
         <p:nvSpPr>
-          <p:cNvPr id="17" name="TextBox 16"/>
-          <p:cNvSpPr txBox="1"/>
-          <p:nvPr/>
-        </p:nvSpPr>
-        <p:spPr>
-          <a:xfrm>
-            <a:off x="640080" y="3867912"/>
-            <a:ext cx="4572000" cy="457200"/>
-          </a:xfrm>
-          <a:prstGeom prst="rect">
-            <a:avLst/>
-          </a:prstGeom>
-          <a:noFill/>
-        </p:spPr>
-        <p:txBody>
-          <a:bodyPr wrap="square">
-            <a:spAutoFit/>
-          </a:bodyPr>
-          <a:lstStyle/>
-          <a:p>
-            <a:pPr algn="l">
-              <a:spcAft>
-                <a:spcPts val="100"/>
-              </a:spcAft>
-            </a:pPr>
-            <a:r>
-              <a:rPr sz="900" b="1">
+          <p:cNvPr id="13" name="TextBox 12"/>
+          <p:cNvSpPr txBox="1"/>
+          <p:nvPr/>
+        </p:nvSpPr>
+        <p:spPr>
+          <a:xfrm>
+            <a:off x="8686800" y="1645920"/>
+            <a:ext cx="2834640" cy="274320"/>
+          </a:xfrm>
+          <a:prstGeom prst="rect">
+            <a:avLst/>
+          </a:prstGeom>
+          <a:noFill/>
+        </p:spPr>
+        <p:txBody>
+          <a:bodyPr wrap="square">
+            <a:spAutoFit/>
+          </a:bodyPr>
+          <a:lstStyle/>
+          <a:p>
+            <a:pPr algn="l">
+              <a:spcAft>
+                <a:spcPts val="0"/>
+              </a:spcAft>
+            </a:pPr>
+            <a:r>
+              <a:rPr sz="1400" b="1">
+                <a:solidFill>
+                  <a:srgbClr val="0D1B2A"/>
+                </a:solidFill>
+              </a:rPr>
+              <a:t>Automated Tests</a:t>
+            </a:r>
+          </a:p>
+        </p:txBody>
+      </p:sp>
+      <p:sp>
+        <p:nvSpPr>
+          <p:cNvPr id="14" name="TextBox 13"/>
+          <p:cNvSpPr txBox="1"/>
+          <p:nvPr/>
+        </p:nvSpPr>
+        <p:spPr>
+          <a:xfrm>
+            <a:off x="8686800" y="1965960"/>
+            <a:ext cx="2834640" cy="228600"/>
+          </a:xfrm>
+          <a:prstGeom prst="rect">
+            <a:avLst/>
+          </a:prstGeom>
+          <a:noFill/>
+        </p:spPr>
+        <p:txBody>
+          <a:bodyPr wrap="square">
+            <a:spAutoFit/>
+          </a:bodyPr>
+          <a:lstStyle/>
+          <a:p>
+            <a:pPr algn="l">
+              <a:spcAft>
+                <a:spcPts val="0"/>
+              </a:spcAft>
+            </a:pPr>
+            <a:r>
+              <a:rPr sz="900" b="0">
                 <a:solidFill>
                   <a:srgbClr val="0099D6"/>
                 </a:solidFill>
               </a:rPr>
-              <a:t>PRODUCT PIPELINE  •  product-pipeline</a:t>
-            </a:r>
-          </a:p>
-          <a:p>
-            <a:pPr algn="l">
-              <a:spcAft>
-                <a:spcPts val="0"/>
-              </a:spcAft>
-            </a:pPr>
-            <a:r>
-              <a:rPr sz="800" b="0">
-                <a:solidFill>
-                  <a:srgbClr val="888888"/>
-                </a:solidFill>
-              </a:rPr>
-              <a:t>Owned by Developers + Systems Engineers</a:t>
-            </a:r>
-          </a:p>
-        </p:txBody>
-      </p:sp>
-      <p:sp>
-        <p:nvSpPr>
-          <p:cNvPr id="18" name="Rounded Rectangle 17"/>
+              <a:t>Owned by Developers</a:t>
+            </a:r>
+          </a:p>
+        </p:txBody>
+      </p:sp>
+      <p:sp>
+        <p:nvSpPr>
+          <p:cNvPr id="15" name="TextBox 14"/>
+          <p:cNvSpPr txBox="1"/>
+          <p:nvPr/>
+        </p:nvSpPr>
+        <p:spPr>
+          <a:xfrm>
+            <a:off x="8686800" y="2331720"/>
+            <a:ext cx="2834640" cy="1645920"/>
+          </a:xfrm>
+          <a:prstGeom prst="rect">
+            <a:avLst/>
+          </a:prstGeom>
+          <a:noFill/>
+        </p:spPr>
+        <p:txBody>
+          <a:bodyPr wrap="square">
+            <a:spAutoFit/>
+          </a:bodyPr>
+          <a:lstStyle/>
+          <a:p>
+            <a:pPr algn="l">
+              <a:spcAft>
+                <a:spcPts val="500"/>
+              </a:spcAft>
+            </a:pPr>
+            <a:r>
+              <a:rPr sz="900" b="0">
+                <a:solidFill>
+                  <a:srgbClr val="555555"/>
+                </a:solidFill>
+              </a:rPr>
+              <a:t>•  Step definitions implement the HOW</a:t>
+            </a:r>
+          </a:p>
+          <a:p>
+            <a:pPr algn="l">
+              <a:spcAft>
+                <a:spcPts val="500"/>
+              </a:spcAft>
+            </a:pPr>
+            <a:r>
+              <a:rPr sz="900" b="0">
+                <a:solidFill>
+                  <a:srgbClr val="555555"/>
+                </a:solidFill>
+              </a:rPr>
+              <a:t>•  Log analysis against deployed product</a:t>
+            </a:r>
+          </a:p>
+          <a:p>
+            <a:pPr algn="l">
+              <a:spcAft>
+                <a:spcPts val="500"/>
+              </a:spcAft>
+            </a:pPr>
+            <a:r>
+              <a:rPr sz="900" b="0">
+                <a:solidFill>
+                  <a:srgbClr val="555555"/>
+                </a:solidFill>
+              </a:rPr>
+              <a:t>•  Results feed the pipeline report</a:t>
+            </a:r>
+          </a:p>
+          <a:p>
+            <a:pPr algn="l">
+              <a:spcAft>
+                <a:spcPts val="500"/>
+              </a:spcAft>
+            </a:pPr>
+            <a:r>
+              <a:rPr sz="900" b="0">
+                <a:solidFill>
+                  <a:srgbClr val="555555"/>
+                </a:solidFill>
+              </a:rPr>
+              <a:t>•  CI/CD runs on every commit</a:t>
+            </a:r>
+          </a:p>
+        </p:txBody>
+      </p:sp>
+      <p:sp>
+        <p:nvSpPr>
+          <p:cNvPr id="16" name="Right Arrow 15"/>
           <p:cNvSpPr/>
           <p:nvPr/>
         </p:nvSpPr>
         <p:spPr>
           <a:xfrm>
-            <a:off x="640080" y="4434840"/>
-            <a:ext cx="2103120" cy="731520"/>
-          </a:xfrm>
-          <a:prstGeom prst="roundRect">
-            <a:avLst/>
-          </a:prstGeom>
-          <a:solidFill>
-            <a:srgbClr val="003057"/>
-          </a:solidFill>
-          <a:ln>
-            <a:noFill/>
-          </a:ln>
-        </p:spPr>
-        <p:style>
-          <a:lnRef idx="1">
-            <a:schemeClr val="accent1"/>
-          </a:lnRef>
-          <a:fillRef idx="3">
-            <a:schemeClr val="accent1"/>
-          </a:fillRef>
-          <a:effectRef idx="2">
-            <a:schemeClr val="accent1"/>
-          </a:effectRef>
-          <a:fontRef idx="minor">
-            <a:schemeClr val="lt1"/>
-          </a:fontRef>
-        </p:style>
-        <p:txBody>
-          <a:bodyPr rtlCol="0" anchor="ctr"/>
-          <a:lstStyle/>
-          <a:p>
-            <a:pPr algn="ctr"/>
-          </a:p>
-        </p:txBody>
-      </p:sp>
-      <p:sp>
-        <p:nvSpPr>
-          <p:cNvPr id="19" name="TextBox 18"/>
-          <p:cNvSpPr txBox="1"/>
-          <p:nvPr/>
-        </p:nvSpPr>
-        <p:spPr>
-          <a:xfrm>
-            <a:off x="731520" y="4507992"/>
-            <a:ext cx="1920240" cy="640080"/>
-          </a:xfrm>
-          <a:prstGeom prst="rect">
-            <a:avLst/>
-          </a:prstGeom>
-          <a:noFill/>
-        </p:spPr>
-        <p:txBody>
-          <a:bodyPr wrap="square">
-            <a:spAutoFit/>
-          </a:bodyPr>
-          <a:lstStyle/>
-          <a:p>
-            <a:pPr algn="l">
-              <a:spcAft>
-                <a:spcPts val="100"/>
-              </a:spcAft>
-            </a:pPr>
-            <a:r>
-              <a:rPr sz="900" b="1">
-                <a:solidFill>
-                  <a:srgbClr val="FFFFFF"/>
-                </a:solidFill>
-              </a:rPr>
-              <a:t>Fetch Model</a:t>
-            </a:r>
-          </a:p>
-          <a:p>
-            <a:pPr algn="l">
-              <a:spcAft>
-                <a:spcPts val="0"/>
-              </a:spcAft>
-            </a:pPr>
-            <a:r>
-              <a:rPr sz="700" b="0">
-                <a:solidFill>
-                  <a:srgbClr val="BBBBBB"/>
-                </a:solidFill>
-              </a:rPr>
-              <a:t>Download versioned
-artifact from release</a:t>
-            </a:r>
-          </a:p>
-        </p:txBody>
-      </p:sp>
-      <p:sp>
-        <p:nvSpPr>
-          <p:cNvPr id="20" name="Rounded Rectangle 19"/>
-          <p:cNvSpPr/>
-          <p:nvPr/>
-        </p:nvSpPr>
-        <p:spPr>
-          <a:xfrm>
-            <a:off x="2880360" y="4434840"/>
-            <a:ext cx="2103120" cy="731520"/>
-          </a:xfrm>
-          <a:prstGeom prst="roundRect">
-            <a:avLst/>
-          </a:prstGeom>
-          <a:solidFill>
-            <a:srgbClr val="004A87"/>
-          </a:solidFill>
-          <a:ln>
-            <a:noFill/>
-          </a:ln>
-        </p:spPr>
-        <p:style>
-          <a:lnRef idx="1">
-            <a:schemeClr val="accent1"/>
-          </a:lnRef>
-          <a:fillRef idx="3">
-            <a:schemeClr val="accent1"/>
-          </a:fillRef>
-          <a:effectRef idx="2">
-            <a:schemeClr val="accent1"/>
-          </a:effectRef>
-          <a:fontRef idx="minor">
-            <a:schemeClr val="lt1"/>
-          </a:fontRef>
-        </p:style>
-        <p:txBody>
-          <a:bodyPr rtlCol="0" anchor="ctr"/>
-          <a:lstStyle/>
-          <a:p>
-            <a:pPr algn="ctr"/>
-          </a:p>
-        </p:txBody>
-      </p:sp>
-      <p:sp>
-        <p:nvSpPr>
-          <p:cNvPr id="21" name="TextBox 20"/>
-          <p:cNvSpPr txBox="1"/>
-          <p:nvPr/>
-        </p:nvSpPr>
-        <p:spPr>
-          <a:xfrm>
-            <a:off x="2971800" y="4507992"/>
-            <a:ext cx="1920240" cy="640080"/>
-          </a:xfrm>
-          <a:prstGeom prst="rect">
-            <a:avLst/>
-          </a:prstGeom>
-          <a:noFill/>
-        </p:spPr>
-        <p:txBody>
-          <a:bodyPr wrap="square">
-            <a:spAutoFit/>
-          </a:bodyPr>
-          <a:lstStyle/>
-          <a:p>
-            <a:pPr algn="l">
-              <a:spcAft>
-                <a:spcPts val="100"/>
-              </a:spcAft>
-            </a:pPr>
-            <a:r>
-              <a:rPr sz="900" b="1">
-                <a:solidFill>
-                  <a:srgbClr val="FFFFFF"/>
-                </a:solidFill>
-              </a:rPr>
-              <a:t>→  Quality Gates</a:t>
-            </a:r>
-          </a:p>
-          <a:p>
-            <a:pPr algn="l">
-              <a:spcAft>
-                <a:spcPts val="0"/>
-              </a:spcAft>
-            </a:pPr>
-            <a:r>
-              <a:rPr sz="700" b="0">
-                <a:solidFill>
-                  <a:srgbClr val="BBBBBB"/>
-                </a:solidFill>
-              </a:rPr>
-              <a:t>Coverage, drift &amp;
-orphan detection</a:t>
-            </a:r>
-          </a:p>
-        </p:txBody>
-      </p:sp>
-      <p:sp>
-        <p:nvSpPr>
-          <p:cNvPr id="22" name="Rounded Rectangle 21"/>
-          <p:cNvSpPr/>
-          <p:nvPr/>
-        </p:nvSpPr>
-        <p:spPr>
-          <a:xfrm>
-            <a:off x="5120640" y="4434840"/>
-            <a:ext cx="2103120" cy="731520"/>
-          </a:xfrm>
-          <a:prstGeom prst="roundRect">
+            <a:off x="3703320" y="2651760"/>
+            <a:ext cx="274320" cy="274320"/>
+          </a:xfrm>
+          <a:prstGeom prst="rightArrow">
             <a:avLst/>
           </a:prstGeom>
           <a:solidFill>
@@ -7242,74 +7038,20 @@
       </p:sp>
       <p:sp>
         <p:nvSpPr>
-          <p:cNvPr id="23" name="TextBox 22"/>
-          <p:cNvSpPr txBox="1"/>
-          <p:nvPr/>
-        </p:nvSpPr>
-        <p:spPr>
-          <a:xfrm>
-            <a:off x="5212080" y="4507992"/>
-            <a:ext cx="1920240" cy="640080"/>
-          </a:xfrm>
-          <a:prstGeom prst="rect">
-            <a:avLst/>
-          </a:prstGeom>
-          <a:noFill/>
-        </p:spPr>
-        <p:txBody>
-          <a:bodyPr wrap="square">
-            <a:spAutoFit/>
-          </a:bodyPr>
-          <a:lstStyle/>
-          <a:p>
-            <a:pPr algn="l">
-              <a:spcAft>
-                <a:spcPts val="100"/>
-              </a:spcAft>
-            </a:pPr>
-            <a:r>
-              <a:rPr sz="900" b="1">
-                <a:solidFill>
-                  <a:srgbClr val="FFFFFF"/>
-                </a:solidFill>
-              </a:rPr>
-              <a:t>→  BDD Verification</a:t>
-            </a:r>
-          </a:p>
-          <a:p>
-            <a:pPr algn="l">
-              <a:spcAft>
-                <a:spcPts val="0"/>
-              </a:spcAft>
-            </a:pPr>
-            <a:r>
-              <a:rPr sz="700" b="0">
-                <a:solidFill>
-                  <a:srgbClr val="BBBBBB"/>
-                </a:solidFill>
-              </a:rPr>
-              <a:t>Automated Gherkin
-log-analysis tests</a:t>
-            </a:r>
-          </a:p>
-        </p:txBody>
-      </p:sp>
-      <p:sp>
-        <p:nvSpPr>
-          <p:cNvPr id="24" name="Rounded Rectangle 23"/>
+          <p:cNvPr id="17" name="Right Arrow 16"/>
           <p:cNvSpPr/>
           <p:nvPr/>
         </p:nvSpPr>
         <p:spPr>
           <a:xfrm>
-            <a:off x="7360920" y="4434840"/>
-            <a:ext cx="2103120" cy="731520"/>
-          </a:xfrm>
-          <a:prstGeom prst="roundRect">
+            <a:off x="8183879" y="2651760"/>
+            <a:ext cx="274320" cy="274320"/>
+          </a:xfrm>
+          <a:prstGeom prst="rightArrow">
             <a:avLst/>
           </a:prstGeom>
           <a:solidFill>
-            <a:srgbClr val="0082CC"/>
+            <a:srgbClr val="0069B0"/>
           </a:solidFill>
           <a:ln>
             <a:noFill/>
@@ -7339,68 +7081,415 @@
       </p:sp>
       <p:sp>
         <p:nvSpPr>
+          <p:cNvPr id="18" name="TextBox 17"/>
+          <p:cNvSpPr txBox="1"/>
+          <p:nvPr/>
+        </p:nvSpPr>
+        <p:spPr>
+          <a:xfrm>
+            <a:off x="731520" y="4480560"/>
+            <a:ext cx="4572000" cy="274320"/>
+          </a:xfrm>
+          <a:prstGeom prst="rect">
+            <a:avLst/>
+          </a:prstGeom>
+          <a:noFill/>
+        </p:spPr>
+        <p:txBody>
+          <a:bodyPr wrap="square">
+            <a:spAutoFit/>
+          </a:bodyPr>
+          <a:lstStyle/>
+          <a:p>
+            <a:pPr algn="l">
+              <a:spcAft>
+                <a:spcPts val="0"/>
+              </a:spcAft>
+            </a:pPr>
+            <a:r>
+              <a:rPr sz="1400" b="1">
+                <a:solidFill>
+                  <a:srgbClr val="0D1B2A"/>
+                </a:solidFill>
+              </a:rPr>
+              <a:t>How It Flows Through the Pipelines</a:t>
+            </a:r>
+          </a:p>
+        </p:txBody>
+      </p:sp>
+      <p:sp>
+        <p:nvSpPr>
+          <p:cNvPr id="19" name="Rounded Rectangle 18"/>
+          <p:cNvSpPr/>
+          <p:nvPr/>
+        </p:nvSpPr>
+        <p:spPr>
+          <a:xfrm>
+            <a:off x="457200" y="4846320"/>
+            <a:ext cx="5486400" cy="457200"/>
+          </a:xfrm>
+          <a:prstGeom prst="roundRect">
+            <a:avLst/>
+          </a:prstGeom>
+          <a:solidFill>
+            <a:srgbClr val="F4F7FA"/>
+          </a:solidFill>
+          <a:ln w="12700">
+            <a:solidFill>
+              <a:srgbClr val="D0E8F8"/>
+            </a:solidFill>
+          </a:ln>
+        </p:spPr>
+        <p:style>
+          <a:lnRef idx="1">
+            <a:schemeClr val="accent1"/>
+          </a:lnRef>
+          <a:fillRef idx="3">
+            <a:schemeClr val="accent1"/>
+          </a:fillRef>
+          <a:effectRef idx="2">
+            <a:schemeClr val="accent1"/>
+          </a:effectRef>
+          <a:fontRef idx="minor">
+            <a:schemeClr val="lt1"/>
+          </a:fontRef>
+        </p:style>
+        <p:txBody>
+          <a:bodyPr rtlCol="0" anchor="ctr"/>
+          <a:lstStyle/>
+          <a:p>
+            <a:pPr algn="ctr"/>
+          </a:p>
+        </p:txBody>
+      </p:sp>
+      <p:sp>
+        <p:nvSpPr>
+          <p:cNvPr id="20" name="TextBox 19"/>
+          <p:cNvSpPr txBox="1"/>
+          <p:nvPr/>
+        </p:nvSpPr>
+        <p:spPr>
+          <a:xfrm>
+            <a:off x="548640" y="4873752"/>
+            <a:ext cx="5303520" cy="365760"/>
+          </a:xfrm>
+          <a:prstGeom prst="rect">
+            <a:avLst/>
+          </a:prstGeom>
+          <a:noFill/>
+        </p:spPr>
+        <p:txBody>
+          <a:bodyPr wrap="square">
+            <a:spAutoFit/>
+          </a:bodyPr>
+          <a:lstStyle/>
+          <a:p>
+            <a:pPr algn="l">
+              <a:spcAft>
+                <a:spcPts val="0"/>
+              </a:spcAft>
+            </a:pPr>
+            <a:r>
+              <a:rPr sz="800" b="1">
+                <a:solidFill>
+                  <a:srgbClr val="0099D6"/>
+                </a:solidFill>
+              </a:rPr>
+              <a:t>MODEL PIPELINE</a:t>
+            </a:r>
+            <a:r>
+              <a:rPr sz="800" b="0">
+                <a:solidFill>
+                  <a:srgbClr val="555555"/>
+                </a:solidFill>
+              </a:rPr>
+              <a:t>    Cameo  →  Export  →  Package  →  Publish Artifact</a:t>
+            </a:r>
+          </a:p>
+        </p:txBody>
+      </p:sp>
+      <p:sp>
+        <p:nvSpPr>
+          <p:cNvPr id="21" name="Down Arrow 20"/>
+          <p:cNvSpPr/>
+          <p:nvPr/>
+        </p:nvSpPr>
+        <p:spPr>
+          <a:xfrm>
+            <a:off x="2743200" y="5349240"/>
+            <a:ext cx="274320" cy="228600"/>
+          </a:xfrm>
+          <a:prstGeom prst="downArrow">
+            <a:avLst/>
+          </a:prstGeom>
+          <a:solidFill>
+            <a:srgbClr val="0069B0"/>
+          </a:solidFill>
+          <a:ln>
+            <a:noFill/>
+          </a:ln>
+        </p:spPr>
+        <p:style>
+          <a:lnRef idx="1">
+            <a:schemeClr val="accent1"/>
+          </a:lnRef>
+          <a:fillRef idx="3">
+            <a:schemeClr val="accent1"/>
+          </a:fillRef>
+          <a:effectRef idx="2">
+            <a:schemeClr val="accent1"/>
+          </a:effectRef>
+          <a:fontRef idx="minor">
+            <a:schemeClr val="lt1"/>
+          </a:fontRef>
+        </p:style>
+        <p:txBody>
+          <a:bodyPr rtlCol="0" anchor="ctr"/>
+          <a:lstStyle/>
+          <a:p>
+            <a:pPr algn="ctr"/>
+          </a:p>
+        </p:txBody>
+      </p:sp>
+      <p:sp>
+        <p:nvSpPr>
+          <p:cNvPr id="22" name="Rounded Rectangle 21"/>
+          <p:cNvSpPr/>
+          <p:nvPr/>
+        </p:nvSpPr>
+        <p:spPr>
+          <a:xfrm>
+            <a:off x="457200" y="5623560"/>
+            <a:ext cx="5486400" cy="457200"/>
+          </a:xfrm>
+          <a:prstGeom prst="roundRect">
+            <a:avLst/>
+          </a:prstGeom>
+          <a:solidFill>
+            <a:srgbClr val="F4F7FA"/>
+          </a:solidFill>
+          <a:ln w="12700">
+            <a:solidFill>
+              <a:srgbClr val="D0E8F8"/>
+            </a:solidFill>
+          </a:ln>
+        </p:spPr>
+        <p:style>
+          <a:lnRef idx="1">
+            <a:schemeClr val="accent1"/>
+          </a:lnRef>
+          <a:fillRef idx="3">
+            <a:schemeClr val="accent1"/>
+          </a:fillRef>
+          <a:effectRef idx="2">
+            <a:schemeClr val="accent1"/>
+          </a:effectRef>
+          <a:fontRef idx="minor">
+            <a:schemeClr val="lt1"/>
+          </a:fontRef>
+        </p:style>
+        <p:txBody>
+          <a:bodyPr rtlCol="0" anchor="ctr"/>
+          <a:lstStyle/>
+          <a:p>
+            <a:pPr algn="ctr"/>
+          </a:p>
+        </p:txBody>
+      </p:sp>
+      <p:sp>
+        <p:nvSpPr>
+          <p:cNvPr id="23" name="TextBox 22"/>
+          <p:cNvSpPr txBox="1"/>
+          <p:nvPr/>
+        </p:nvSpPr>
+        <p:spPr>
+          <a:xfrm>
+            <a:off x="548640" y="5650992"/>
+            <a:ext cx="5303520" cy="365760"/>
+          </a:xfrm>
+          <a:prstGeom prst="rect">
+            <a:avLst/>
+          </a:prstGeom>
+          <a:noFill/>
+        </p:spPr>
+        <p:txBody>
+          <a:bodyPr wrap="square">
+            <a:spAutoFit/>
+          </a:bodyPr>
+          <a:lstStyle/>
+          <a:p>
+            <a:pPr algn="l">
+              <a:spcAft>
+                <a:spcPts val="0"/>
+              </a:spcAft>
+            </a:pPr>
+            <a:r>
+              <a:rPr sz="800" b="1">
+                <a:solidFill>
+                  <a:srgbClr val="0099D6"/>
+                </a:solidFill>
+              </a:rPr>
+              <a:t>PRODUCT PIPELINE</a:t>
+            </a:r>
+            <a:r>
+              <a:rPr sz="800" b="0">
+                <a:solidFill>
+                  <a:srgbClr val="555555"/>
+                </a:solidFill>
+              </a:rPr>
+              <a:t>    Fetch  →  Quality Gates  →  BDD Tests  →  Deploy + Report</a:t>
+            </a:r>
+          </a:p>
+        </p:txBody>
+      </p:sp>
+      <p:sp>
+        <p:nvSpPr>
+          <p:cNvPr id="24" name="TextBox 23"/>
+          <p:cNvSpPr txBox="1"/>
+          <p:nvPr/>
+        </p:nvSpPr>
+        <p:spPr>
+          <a:xfrm>
+            <a:off x="6400800" y="4709160"/>
+            <a:ext cx="5029200" cy="411480"/>
+          </a:xfrm>
+          <a:prstGeom prst="rect">
+            <a:avLst/>
+          </a:prstGeom>
+          <a:noFill/>
+        </p:spPr>
+        <p:txBody>
+          <a:bodyPr wrap="square">
+            <a:spAutoFit/>
+          </a:bodyPr>
+          <a:lstStyle/>
+          <a:p>
+            <a:pPr algn="l">
+              <a:spcAft>
+                <a:spcPts val="0"/>
+              </a:spcAft>
+            </a:pPr>
+            <a:r>
+              <a:rPr sz="1000" b="1">
+                <a:solidFill>
+                  <a:srgbClr val="0069B0"/>
+                </a:solidFill>
+              </a:rPr>
+              <a:t>Readable by both sides</a:t>
+            </a:r>
+            <a:r>
+              <a:rPr sz="900" b="0">
+                <a:solidFill>
+                  <a:srgbClr val="555555"/>
+                </a:solidFill>
+              </a:rPr>
+              <a:t>  —  SEs validate intent, developers implement steps.</a:t>
+            </a:r>
+          </a:p>
+        </p:txBody>
+      </p:sp>
+      <p:sp>
+        <p:nvSpPr>
           <p:cNvPr id="25" name="TextBox 24"/>
           <p:cNvSpPr txBox="1"/>
           <p:nvPr/>
         </p:nvSpPr>
         <p:spPr>
           <a:xfrm>
-            <a:off x="7452360" y="4507992"/>
-            <a:ext cx="1920240" cy="640080"/>
-          </a:xfrm>
-          <a:prstGeom prst="rect">
-            <a:avLst/>
-          </a:prstGeom>
-          <a:noFill/>
-        </p:spPr>
-        <p:txBody>
-          <a:bodyPr wrap="square">
-            <a:spAutoFit/>
-          </a:bodyPr>
-          <a:lstStyle/>
-          <a:p>
-            <a:pPr algn="l">
-              <a:spcAft>
-                <a:spcPts val="100"/>
-              </a:spcAft>
-            </a:pPr>
-            <a:r>
-              <a:rPr sz="900" b="1">
-                <a:solidFill>
-                  <a:srgbClr val="FFFFFF"/>
-                </a:solidFill>
-              </a:rPr>
-              <a:t>→  Deploy + Report</a:t>
-            </a:r>
-          </a:p>
-          <a:p>
-            <a:pPr algn="l">
-              <a:spcAft>
-                <a:spcPts val="0"/>
-              </a:spcAft>
-            </a:pPr>
-            <a:r>
-              <a:rPr sz="700" b="0">
-                <a:solidFill>
-                  <a:srgbClr val="BBBBBB"/>
-                </a:solidFill>
-              </a:rPr>
-              <a:t>Helm deploy with
-evidence bundle</a:t>
-            </a:r>
-          </a:p>
-        </p:txBody>
-      </p:sp>
-      <p:sp>
-        <p:nvSpPr>
-          <p:cNvPr id="26" name="Rounded Rectangle 25"/>
+            <a:off x="6400800" y="5166360"/>
+            <a:ext cx="5029200" cy="411480"/>
+          </a:xfrm>
+          <a:prstGeom prst="rect">
+            <a:avLst/>
+          </a:prstGeom>
+          <a:noFill/>
+        </p:spPr>
+        <p:txBody>
+          <a:bodyPr wrap="square">
+            <a:spAutoFit/>
+          </a:bodyPr>
+          <a:lstStyle/>
+          <a:p>
+            <a:pPr algn="l">
+              <a:spcAft>
+                <a:spcPts val="0"/>
+              </a:spcAft>
+            </a:pPr>
+            <a:r>
+              <a:rPr sz="1000" b="1">
+                <a:solidFill>
+                  <a:srgbClr val="0069B0"/>
+                </a:solidFill>
+              </a:rPr>
+              <a:t>Machine-traceable</a:t>
+            </a:r>
+            <a:r>
+              <a:rPr sz="900" b="0">
+                <a:solidFill>
+                  <a:srgbClr val="555555"/>
+                </a:solidFill>
+              </a:rPr>
+              <a:t>  —  Tags (@REQ, @VC) create the link to requirements.</a:t>
+            </a:r>
+          </a:p>
+        </p:txBody>
+      </p:sp>
+      <p:sp>
+        <p:nvSpPr>
+          <p:cNvPr id="26" name="TextBox 25"/>
+          <p:cNvSpPr txBox="1"/>
+          <p:nvPr/>
+        </p:nvSpPr>
+        <p:spPr>
+          <a:xfrm>
+            <a:off x="6400800" y="5623560"/>
+            <a:ext cx="5029200" cy="411480"/>
+          </a:xfrm>
+          <a:prstGeom prst="rect">
+            <a:avLst/>
+          </a:prstGeom>
+          <a:noFill/>
+        </p:spPr>
+        <p:txBody>
+          <a:bodyPr wrap="square">
+            <a:spAutoFit/>
+          </a:bodyPr>
+          <a:lstStyle/>
+          <a:p>
+            <a:pPr algn="l">
+              <a:spcAft>
+                <a:spcPts val="0"/>
+              </a:spcAft>
+            </a:pPr>
+            <a:r>
+              <a:rPr sz="1000" b="1">
+                <a:solidFill>
+                  <a:srgbClr val="0069B0"/>
+                </a:solidFill>
+              </a:rPr>
+              <a:t>Pipeline-enforced</a:t>
+            </a:r>
+            <a:r>
+              <a:rPr sz="900" b="0">
+                <a:solidFill>
+                  <a:srgbClr val="555555"/>
+                </a:solidFill>
+              </a:rPr>
+              <a:t>  —  Quality gates ensure every VC has a scenario.</a:t>
+            </a:r>
+          </a:p>
+        </p:txBody>
+      </p:sp>
+      <p:sp>
+        <p:nvSpPr>
+          <p:cNvPr id="27" name="Rounded Rectangle 26"/>
           <p:cNvSpPr/>
           <p:nvPr/>
         </p:nvSpPr>
         <p:spPr>
           <a:xfrm>
-            <a:off x="457200" y="5532120"/>
-            <a:ext cx="11247120" cy="411480"/>
+            <a:off x="6400800" y="6126480"/>
+            <a:ext cx="5303520" cy="365760"/>
           </a:xfrm>
           <a:prstGeom prst="roundRect">
             <a:avLst/>
@@ -7438,14 +7527,14 @@
       </p:sp>
       <p:sp>
         <p:nvSpPr>
-          <p:cNvPr id="27" name="TextBox 26"/>
-          <p:cNvSpPr txBox="1"/>
-          <p:nvPr/>
-        </p:nvSpPr>
-        <p:spPr>
-          <a:xfrm>
-            <a:off x="731520" y="5586984"/>
-            <a:ext cx="10789920" cy="320040"/>
+          <p:cNvPr id="28" name="TextBox 27"/>
+          <p:cNvSpPr txBox="1"/>
+          <p:nvPr/>
+        </p:nvSpPr>
+        <p:spPr>
+          <a:xfrm>
+            <a:off x="6583680" y="6163056"/>
+            <a:ext cx="4937760" cy="274320"/>
           </a:xfrm>
           <a:prstGeom prst="rect">
             <a:avLst/>
@@ -7464,50 +7553,12 @@
               </a:spcAft>
             </a:pPr>
             <a:r>
-              <a:rPr sz="1100" b="1">
+              <a:rPr sz="1000" b="1">
                 <a:solidFill>
                   <a:srgbClr val="FFFFFF"/>
                 </a:solidFill>
               </a:rPr>
-              <a:t>Every requirement is automatically traced from model to test to deployment. No manual assembly. No gaps. No drift.</a:t>
-            </a:r>
-          </a:p>
-        </p:txBody>
-      </p:sp>
-      <p:sp>
-        <p:nvSpPr>
-          <p:cNvPr id="28" name="TextBox 27"/>
-          <p:cNvSpPr txBox="1"/>
-          <p:nvPr/>
-        </p:nvSpPr>
-        <p:spPr>
-          <a:xfrm>
-            <a:off x="8686800" y="365760"/>
-            <a:ext cx="3017520" cy="274320"/>
-          </a:xfrm>
-          <a:prstGeom prst="rect">
-            <a:avLst/>
-          </a:prstGeom>
-          <a:noFill/>
-        </p:spPr>
-        <p:txBody>
-          <a:bodyPr wrap="square">
-            <a:spAutoFit/>
-          </a:bodyPr>
-          <a:lstStyle/>
-          <a:p>
-            <a:pPr algn="r">
-              <a:spcAft>
-                <a:spcPts val="0"/>
-              </a:spcAft>
-            </a:pPr>
-            <a:r>
-              <a:rPr sz="700" b="0">
-                <a:solidFill>
-                  <a:srgbClr val="888888"/>
-                </a:solidFill>
-              </a:rPr>
-              <a:t>Cameo • Python • Behave • Gherkin • Helm • GitHub Actions</a:t>
+              <a:t>One language. Model to deployment. Both sides own the spec.</a:t>
             </a:r>
           </a:p>
         </p:txBody>

</xml_diff>

<commit_message>
Rename right column to System Verification to match test pyramid
Aligns slide 3 with the layered testing slide — the pipeline
operates at the E2E / System Verification layer.

Co-Authored-By: Claude Opus 4.6 (1M context) <noreply@anthropic.com>
</commit_message>
<xml_diff>
--- a/docs/presentations/MBSE_Pipeline_Executive_Brief.pptx
+++ b/docs/presentations/MBSE_Pipeline_Executive_Brief.pptx
@@ -6867,7 +6867,7 @@
                   <a:srgbClr val="0D1B2A"/>
                 </a:solidFill>
               </a:rPr>
-              <a:t>Automated Tests</a:t>
+              <a:t>System Verification</a:t>
             </a:r>
           </a:p>
         </p:txBody>
@@ -6905,7 +6905,7 @@
                   <a:srgbClr val="0099D6"/>
                 </a:solidFill>
               </a:rPr>
-              <a:t>Owned by Developers</a:t>
+              <a:t>Implemented by Developers</a:t>
             </a:r>
           </a:p>
         </p:txBody>
@@ -6958,7 +6958,7 @@
                   <a:srgbClr val="555555"/>
                 </a:solidFill>
               </a:rPr>
-              <a:t>•  Log analysis against deployed product</a:t>
+              <a:t>•  Log analysis against the deployed product</a:t>
             </a:r>
           </a:p>
           <a:p>
@@ -6973,22 +6973,22 @@
                   <a:srgbClr val="555555"/>
                 </a:solidFill>
               </a:rPr>
+              <a:t>•  E2E verification on every build</a:t>
+            </a:r>
+          </a:p>
+          <a:p>
+            <a:pPr algn="l">
+              <a:spcAft>
+                <a:spcPts val="500"/>
+              </a:spcAft>
+            </a:pPr>
+            <a:r>
+              <a:rPr sz="900" b="0">
+                <a:solidFill>
+                  <a:srgbClr val="555555"/>
+                </a:solidFill>
+              </a:rPr>
               <a:t>•  Results feed the pipeline report</a:t>
-            </a:r>
-          </a:p>
-          <a:p>
-            <a:pPr algn="l">
-              <a:spcAft>
-                <a:spcPts val="500"/>
-              </a:spcAft>
-            </a:pPr>
-            <a:r>
-              <a:rPr sz="900" b="0">
-                <a:solidFill>
-                  <a:srgbClr val="555555"/>
-                </a:solidFill>
-              </a:rPr>
-              <a:t>•  CI/CD runs on every commit</a:t>
             </a:r>
           </a:p>
         </p:txBody>

</xml_diff>

<commit_message>
Simplify demo to 3 releases and align to new requirements schema
- Remove releases 1.1.0 and 2.1.0 (and REQ-005, REQ-009, REQ-010)
  to reduce demo content: now 3 releases, 8 requirements, 10 VCs
- Align all field names to updated JSON schema:
  title→name, verificationCriteriaId→verificationId,
  method→verificationMethod, criteria→verificationDescription
- Remove priority/satisfiedBy/tracesTo fields, add requirementType
- Update slide deck: 3 release cards, Gherkin tag takeaway, banner text
- Update all tests (226 passing), docs, and CI sample data

Co-Authored-By: Claude Opus 4.6 (1M context) <noreply@anthropic.com>
</commit_message>
<xml_diff>
--- a/docs/presentations/MBSE_Pipeline_Executive_Brief.pptx
+++ b/docs/presentations/MBSE_Pipeline_Executive_Brief.pptx
@@ -5466,8 +5466,76 @@
         </p:nvSpPr>
         <p:spPr>
           <a:xfrm>
-            <a:off x="4297680" y="2194560"/>
-            <a:ext cx="3566160" cy="1920240"/>
+            <a:off x="4297680" y="2103120"/>
+            <a:ext cx="3566160" cy="822960"/>
+          </a:xfrm>
+          <a:prstGeom prst="rect">
+            <a:avLst/>
+          </a:prstGeom>
+          <a:noFill/>
+        </p:spPr>
+        <p:txBody>
+          <a:bodyPr wrap="square">
+            <a:spAutoFit/>
+          </a:bodyPr>
+          <a:lstStyle/>
+          <a:p>
+            <a:pPr algn="l">
+              <a:spcAft>
+                <a:spcPts val="300"/>
+              </a:spcAft>
+            </a:pPr>
+            <a:r>
+              <a:rPr sz="800" b="0">
+                <a:solidFill>
+                  <a:srgbClr val="FFFFFF"/>
+                </a:solidFill>
+              </a:rPr>
+              <a:t>•  Plain English that both sides can read and validate</a:t>
+            </a:r>
+          </a:p>
+          <a:p>
+            <a:pPr algn="l">
+              <a:spcAft>
+                <a:spcPts val="300"/>
+              </a:spcAft>
+            </a:pPr>
+            <a:r>
+              <a:rPr sz="800" b="0">
+                <a:solidFill>
+                  <a:srgbClr val="FFFFFF"/>
+                </a:solidFill>
+              </a:rPr>
+              <a:t>•  Machine-executable — runs as automated tests on every build</a:t>
+            </a:r>
+          </a:p>
+          <a:p>
+            <a:pPr algn="l">
+              <a:spcAft>
+                <a:spcPts val="300"/>
+              </a:spcAft>
+            </a:pPr>
+            <a:r>
+              <a:rPr sz="800" b="0">
+                <a:solidFill>
+                  <a:srgbClr val="FFFFFF"/>
+                </a:solidFill>
+              </a:rPr>
+              <a:t>•  Tagged to requirements — creates the traceability link</a:t>
+            </a:r>
+          </a:p>
+        </p:txBody>
+      </p:sp>
+      <p:sp>
+        <p:nvSpPr>
+          <p:cNvPr id="12" name="TextBox 11"/>
+          <p:cNvSpPr txBox="1"/>
+          <p:nvPr/>
+        </p:nvSpPr>
+        <p:spPr>
+          <a:xfrm>
+            <a:off x="4297680" y="2926080"/>
+            <a:ext cx="3566160" cy="1188720"/>
           </a:xfrm>
           <a:prstGeom prst="rect">
             <a:avLst/>
@@ -5486,7 +5554,7 @@
               </a:spcAft>
             </a:pPr>
             <a:r>
-              <a:rPr sz="800" b="1">
+              <a:rPr sz="700" b="1">
                 <a:solidFill>
                   <a:srgbClr val="FFFFFF"/>
                 </a:solidFill>
@@ -5501,7 +5569,7 @@
               </a:spcAft>
             </a:pPr>
             <a:r>
-              <a:rPr sz="800" b="1">
+              <a:rPr sz="700" b="1">
                 <a:solidFill>
                   <a:srgbClr val="FFFFFF"/>
                 </a:solidFill>
@@ -5516,12 +5584,27 @@
               </a:spcAft>
             </a:pPr>
             <a:r>
-              <a:rPr sz="800" b="0">
+              <a:rPr sz="700" b="1">
+                <a:solidFill>
+                  <a:srgbClr val="FFFFFF"/>
+                </a:solidFill>
+              </a:rPr>
+              <a:t>  @VC:SYS-REQ-001-VC-01 @VER:Test</a:t>
+            </a:r>
+          </a:p>
+          <a:p>
+            <a:pPr algn="l">
+              <a:spcAft>
+                <a:spcPts val="100"/>
+              </a:spcAft>
+            </a:pPr>
+            <a:r>
+              <a:rPr sz="700" b="0">
                 <a:solidFill>
                   <a:srgbClr val="BBBBBB"/>
                 </a:solidFill>
               </a:rPr>
-              <a:t> </a:t>
+              <a:t>  Scenario: Valid ICD response</a:t>
             </a:r>
           </a:p>
           <a:p>
@@ -5531,12 +5614,12 @@
               </a:spcAft>
             </a:pPr>
             <a:r>
-              <a:rPr sz="800" b="1">
-                <a:solidFill>
-                  <a:srgbClr val="FFFFFF"/>
-                </a:solidFill>
-              </a:rPr>
-              <a:t>  @VC:SYS-REQ-001-VC-01 @VER:Test</a:t>
+              <a:rPr sz="700" b="0">
+                <a:solidFill>
+                  <a:srgbClr val="BBBBBB"/>
+                </a:solidFill>
+              </a:rPr>
+              <a:t>    Given the simulation logs are loaded</a:t>
             </a:r>
           </a:p>
           <a:p>
@@ -5546,12 +5629,12 @@
               </a:spcAft>
             </a:pPr>
             <a:r>
-              <a:rPr sz="800" b="0">
+              <a:rPr sz="700" b="0">
                 <a:solidFill>
                   <a:srgbClr val="BBBBBB"/>
                 </a:solidFill>
               </a:rPr>
-              <a:t>  Scenario: Valid ICD response</a:t>
+              <a:t>    Then the logs should contain</a:t>
             </a:r>
           </a:p>
           <a:p>
@@ -5561,41 +5644,11 @@
               </a:spcAft>
             </a:pPr>
             <a:r>
-              <a:rPr sz="800" b="0">
+              <a:rPr sz="700" b="0">
                 <a:solidFill>
                   <a:srgbClr val="BBBBBB"/>
                 </a:solidFill>
               </a:rPr>
-              <a:t>    Given the simulation logs are loaded</a:t>
-            </a:r>
-          </a:p>
-          <a:p>
-            <a:pPr algn="l">
-              <a:spcAft>
-                <a:spcPts val="100"/>
-              </a:spcAft>
-            </a:pPr>
-            <a:r>
-              <a:rPr sz="800" b="0">
-                <a:solidFill>
-                  <a:srgbClr val="BBBBBB"/>
-                </a:solidFill>
-              </a:rPr>
-              <a:t>    Then the logs should contain</a:t>
-            </a:r>
-          </a:p>
-          <a:p>
-            <a:pPr algn="l">
-              <a:spcAft>
-                <a:spcPts val="100"/>
-              </a:spcAft>
-            </a:pPr>
-            <a:r>
-              <a:rPr sz="800" b="0">
-                <a:solidFill>
-                  <a:srgbClr val="BBBBBB"/>
-                </a:solidFill>
-              </a:rPr>
               <a:t>         "IcdResponse: status=OK"</a:t>
             </a:r>
           </a:p>
@@ -5603,7 +5656,7 @@
       </p:sp>
       <p:sp>
         <p:nvSpPr>
-          <p:cNvPr id="12" name="Rounded Rectangle 11"/>
+          <p:cNvPr id="13" name="Rounded Rectangle 12"/>
           <p:cNvSpPr/>
           <p:nvPr/>
         </p:nvSpPr>
@@ -5648,7 +5701,7 @@
       </p:sp>
       <p:sp>
         <p:nvSpPr>
-          <p:cNvPr id="13" name="TextBox 12"/>
+          <p:cNvPr id="14" name="TextBox 13"/>
           <p:cNvSpPr txBox="1"/>
           <p:nvPr/>
         </p:nvSpPr>
@@ -5686,7 +5739,7 @@
       </p:sp>
       <p:sp>
         <p:nvSpPr>
-          <p:cNvPr id="14" name="TextBox 13"/>
+          <p:cNvPr id="15" name="TextBox 14"/>
           <p:cNvSpPr txBox="1"/>
           <p:nvPr/>
         </p:nvSpPr>
@@ -5724,7 +5777,7 @@
       </p:sp>
       <p:sp>
         <p:nvSpPr>
-          <p:cNvPr id="15" name="TextBox 14"/>
+          <p:cNvPr id="16" name="TextBox 15"/>
           <p:cNvSpPr txBox="1"/>
           <p:nvPr/>
         </p:nvSpPr>
@@ -5807,7 +5860,7 @@
       </p:sp>
       <p:sp>
         <p:nvSpPr>
-          <p:cNvPr id="16" name="Right Arrow 15"/>
+          <p:cNvPr id="17" name="Right Arrow 16"/>
           <p:cNvSpPr/>
           <p:nvPr/>
         </p:nvSpPr>
@@ -5850,7 +5903,7 @@
       </p:sp>
       <p:sp>
         <p:nvSpPr>
-          <p:cNvPr id="17" name="Right Arrow 16"/>
+          <p:cNvPr id="18" name="Right Arrow 17"/>
           <p:cNvSpPr/>
           <p:nvPr/>
         </p:nvSpPr>
@@ -5893,7 +5946,7 @@
       </p:sp>
       <p:sp>
         <p:nvSpPr>
-          <p:cNvPr id="18" name="TextBox 17"/>
+          <p:cNvPr id="19" name="TextBox 18"/>
           <p:cNvSpPr txBox="1"/>
           <p:nvPr/>
         </p:nvSpPr>
@@ -5931,7 +5984,7 @@
       </p:sp>
       <p:sp>
         <p:nvSpPr>
-          <p:cNvPr id="19" name="Rounded Rectangle 18"/>
+          <p:cNvPr id="20" name="Rounded Rectangle 19"/>
           <p:cNvSpPr/>
           <p:nvPr/>
         </p:nvSpPr>
@@ -5976,7 +6029,7 @@
       </p:sp>
       <p:sp>
         <p:nvSpPr>
-          <p:cNvPr id="20" name="TextBox 19"/>
+          <p:cNvPr id="21" name="TextBox 20"/>
           <p:cNvSpPr txBox="1"/>
           <p:nvPr/>
         </p:nvSpPr>
@@ -6022,7 +6075,7 @@
       </p:sp>
       <p:sp>
         <p:nvSpPr>
-          <p:cNvPr id="21" name="Down Arrow 20"/>
+          <p:cNvPr id="22" name="Down Arrow 21"/>
           <p:cNvSpPr/>
           <p:nvPr/>
         </p:nvSpPr>
@@ -6065,7 +6118,7 @@
       </p:sp>
       <p:sp>
         <p:nvSpPr>
-          <p:cNvPr id="22" name="Rounded Rectangle 21"/>
+          <p:cNvPr id="23" name="Rounded Rectangle 22"/>
           <p:cNvSpPr/>
           <p:nvPr/>
         </p:nvSpPr>
@@ -6110,7 +6163,7 @@
       </p:sp>
       <p:sp>
         <p:nvSpPr>
-          <p:cNvPr id="23" name="TextBox 22"/>
+          <p:cNvPr id="24" name="TextBox 23"/>
           <p:cNvSpPr txBox="1"/>
           <p:nvPr/>
         </p:nvSpPr>
@@ -6156,7 +6209,7 @@
       </p:sp>
       <p:sp>
         <p:nvSpPr>
-          <p:cNvPr id="24" name="TextBox 23"/>
+          <p:cNvPr id="25" name="TextBox 24"/>
           <p:cNvSpPr txBox="1"/>
           <p:nvPr/>
         </p:nvSpPr>
@@ -6202,7 +6255,7 @@
       </p:sp>
       <p:sp>
         <p:nvSpPr>
-          <p:cNvPr id="25" name="TextBox 24"/>
+          <p:cNvPr id="26" name="TextBox 25"/>
           <p:cNvSpPr txBox="1"/>
           <p:nvPr/>
         </p:nvSpPr>
@@ -6248,7 +6301,7 @@
       </p:sp>
       <p:sp>
         <p:nvSpPr>
-          <p:cNvPr id="26" name="TextBox 25"/>
+          <p:cNvPr id="27" name="TextBox 26"/>
           <p:cNvSpPr txBox="1"/>
           <p:nvPr/>
         </p:nvSpPr>
@@ -6294,7 +6347,7 @@
       </p:sp>
       <p:sp>
         <p:nvSpPr>
-          <p:cNvPr id="27" name="Rounded Rectangle 26"/>
+          <p:cNvPr id="28" name="Rounded Rectangle 27"/>
           <p:cNvSpPr/>
           <p:nvPr/>
         </p:nvSpPr>
@@ -6339,7 +6392,7 @@
       </p:sp>
       <p:sp>
         <p:nvSpPr>
-          <p:cNvPr id="28" name="TextBox 27"/>
+          <p:cNvPr id="29" name="TextBox 28"/>
           <p:cNvSpPr txBox="1"/>
           <p:nvPr/>
         </p:nvSpPr>
@@ -6377,7 +6430,7 @@
       </p:sp>
       <p:sp>
         <p:nvSpPr>
-          <p:cNvPr id="29" name="TextBox 28"/>
+          <p:cNvPr id="30" name="TextBox 29"/>
           <p:cNvSpPr txBox="1"/>
           <p:nvPr/>
         </p:nvSpPr>

</xml_diff>

<commit_message>
Redesign slide 2: full-width gap cards with disconnected silos diagram
Title changed to "One Pipeline. Model to Deployment." so the slide
stands alone. Three gap cards on the left, stacked silo diagram on
the right showing Cameo/Tests/Deployment with no connection between them.

Co-Authored-By: Claude Opus 4.6 (1M context) <noreply@anthropic.com>
</commit_message>
<xml_diff>
--- a/docs/presentations/MBSE_Pipeline_Executive_Brief.pptx
+++ b/docs/presentations/MBSE_Pipeline_Executive_Brief.pptx
@@ -4584,223 +4584,26 @@
               </a:spcAft>
             </a:pPr>
             <a:r>
-              <a:rPr sz="3000" b="1">
+              <a:rPr sz="3200" b="1">
                 <a:solidFill>
                   <a:srgbClr val="0D1B2A"/>
                 </a:solidFill>
               </a:rPr>
-              <a:t>Built for Program Velocity</a:t>
-            </a:r>
-          </a:p>
-        </p:txBody>
-      </p:sp>
-      <p:sp>
-        <p:nvSpPr>
-          <p:cNvPr id="3" name="TextBox 2"/>
-          <p:cNvSpPr txBox="1"/>
-          <p:nvPr/>
-        </p:nvSpPr>
-        <p:spPr>
-          <a:xfrm>
-            <a:off x="731520" y="1280160"/>
-            <a:ext cx="5029200" cy="274320"/>
-          </a:xfrm>
-          <a:prstGeom prst="rect">
-            <a:avLst/>
-          </a:prstGeom>
-          <a:noFill/>
-        </p:spPr>
-        <p:txBody>
-          <a:bodyPr wrap="square">
-            <a:spAutoFit/>
-          </a:bodyPr>
-          <a:lstStyle/>
-          <a:p>
-            <a:pPr algn="l">
-              <a:spcAft>
-                <a:spcPts val="0"/>
-              </a:spcAft>
-            </a:pPr>
-            <a:r>
-              <a:rPr sz="1600" b="1">
-                <a:solidFill>
-                  <a:srgbClr val="0D1B2A"/>
-                </a:solidFill>
-              </a:rPr>
-              <a:t>The Structural Gaps</a:t>
-            </a:r>
-          </a:p>
-        </p:txBody>
-      </p:sp>
-      <p:sp>
-        <p:nvSpPr>
-          <p:cNvPr id="4" name="TextBox 3"/>
-          <p:cNvSpPr txBox="1"/>
-          <p:nvPr/>
-        </p:nvSpPr>
-        <p:spPr>
-          <a:xfrm>
-            <a:off x="731520" y="1737360"/>
-            <a:ext cx="5029200" cy="685800"/>
-          </a:xfrm>
-          <a:prstGeom prst="rect">
-            <a:avLst/>
-          </a:prstGeom>
-          <a:noFill/>
-        </p:spPr>
-        <p:txBody>
-          <a:bodyPr wrap="square">
-            <a:spAutoFit/>
-          </a:bodyPr>
-          <a:lstStyle/>
-          <a:p>
-            <a:pPr algn="l">
-              <a:spcAft>
-                <a:spcPts val="200"/>
-              </a:spcAft>
-            </a:pPr>
-            <a:r>
-              <a:rPr sz="1300" b="1">
-                <a:solidFill>
-                  <a:srgbClr val="0099D6"/>
-                </a:solidFill>
-              </a:rPr>
-              <a:t>No Shared Language</a:t>
-            </a:r>
-          </a:p>
-          <a:p>
-            <a:pPr algn="l">
-              <a:spcAft>
-                <a:spcPts val="0"/>
-              </a:spcAft>
-            </a:pPr>
-            <a:r>
-              <a:rPr sz="1000" b="0">
-                <a:solidFill>
-                  <a:srgbClr val="555555"/>
-                </a:solidFill>
-              </a:rPr>
-              <a:t>SEs work in the model, developers work in code. Without a bridge, intent gets lost in translation at every handoff.</a:t>
-            </a:r>
-          </a:p>
-        </p:txBody>
-      </p:sp>
-      <p:sp>
-        <p:nvSpPr>
-          <p:cNvPr id="5" name="TextBox 4"/>
-          <p:cNvSpPr txBox="1"/>
-          <p:nvPr/>
-        </p:nvSpPr>
-        <p:spPr>
-          <a:xfrm>
-            <a:off x="731520" y="2514600"/>
-            <a:ext cx="5029200" cy="685800"/>
-          </a:xfrm>
-          <a:prstGeom prst="rect">
-            <a:avLst/>
-          </a:prstGeom>
-          <a:noFill/>
-        </p:spPr>
-        <p:txBody>
-          <a:bodyPr wrap="square">
-            <a:spAutoFit/>
-          </a:bodyPr>
-          <a:lstStyle/>
-          <a:p>
-            <a:pPr algn="l">
-              <a:spcAft>
-                <a:spcPts val="200"/>
-              </a:spcAft>
-            </a:pPr>
-            <a:r>
-              <a:rPr sz="1300" b="1">
-                <a:solidFill>
-                  <a:srgbClr val="0099D6"/>
-                </a:solidFill>
-              </a:rPr>
-              <a:t>No Reliable Handoff</a:t>
-            </a:r>
-          </a:p>
-          <a:p>
-            <a:pPr algn="l">
-              <a:spcAft>
-                <a:spcPts val="0"/>
-              </a:spcAft>
-            </a:pPr>
-            <a:r>
-              <a:rPr sz="1000" b="0">
-                <a:solidFill>
-                  <a:srgbClr val="555555"/>
-                </a:solidFill>
-              </a:rPr>
-              <a:t>Artifacts shared over email or SharePoint have no version control, no change awareness, and no enforcement.</a:t>
-            </a:r>
-          </a:p>
-        </p:txBody>
-      </p:sp>
-      <p:sp>
-        <p:nvSpPr>
-          <p:cNvPr id="6" name="TextBox 5"/>
-          <p:cNvSpPr txBox="1"/>
-          <p:nvPr/>
-        </p:nvSpPr>
-        <p:spPr>
-          <a:xfrm>
-            <a:off x="731520" y="3291840"/>
-            <a:ext cx="5029200" cy="685800"/>
-          </a:xfrm>
-          <a:prstGeom prst="rect">
-            <a:avLst/>
-          </a:prstGeom>
-          <a:noFill/>
-        </p:spPr>
-        <p:txBody>
-          <a:bodyPr wrap="square">
-            <a:spAutoFit/>
-          </a:bodyPr>
-          <a:lstStyle/>
-          <a:p>
-            <a:pPr algn="l">
-              <a:spcAft>
-                <a:spcPts val="200"/>
-              </a:spcAft>
-            </a:pPr>
-            <a:r>
-              <a:rPr sz="1300" b="1">
-                <a:solidFill>
-                  <a:srgbClr val="0099D6"/>
-                </a:solidFill>
-              </a:rPr>
-              <a:t>No Connected Toolchain</a:t>
-            </a:r>
-          </a:p>
-          <a:p>
-            <a:pPr algn="l">
-              <a:spcAft>
-                <a:spcPts val="0"/>
-              </a:spcAft>
-            </a:pPr>
-            <a:r>
-              <a:rPr sz="1000" b="0">
-                <a:solidFill>
-                  <a:srgbClr val="555555"/>
-                </a:solidFill>
-              </a:rPr>
-              <a:t>Requirements, tests, and deployment are maintained in separate tools with no automated thread between them.</a:t>
-            </a:r>
-          </a:p>
-        </p:txBody>
-      </p:sp>
-      <p:sp>
-        <p:nvSpPr>
-          <p:cNvPr id="7" name="Rounded Rectangle 6"/>
+              <a:t>One Pipeline. Model to Deployment.</a:t>
+            </a:r>
+          </a:p>
+        </p:txBody>
+      </p:sp>
+      <p:sp>
+        <p:nvSpPr>
+          <p:cNvPr id="3" name="Rounded Rectangle 2"/>
           <p:cNvSpPr/>
           <p:nvPr/>
         </p:nvSpPr>
         <p:spPr>
           <a:xfrm>
-            <a:off x="6217920" y="1188720"/>
-            <a:ext cx="5303520" cy="3657600"/>
+            <a:off x="457200" y="1371600"/>
+            <a:ext cx="6675120" cy="1234440"/>
           </a:xfrm>
           <a:prstGeom prst="roundRect">
             <a:avLst/>
@@ -4838,27 +4641,276 @@
       </p:sp>
       <p:sp>
         <p:nvSpPr>
+          <p:cNvPr id="4" name="TextBox 3"/>
+          <p:cNvSpPr txBox="1"/>
+          <p:nvPr/>
+        </p:nvSpPr>
+        <p:spPr>
+          <a:xfrm>
+            <a:off x="731520" y="1508760"/>
+            <a:ext cx="6217920" cy="1005840"/>
+          </a:xfrm>
+          <a:prstGeom prst="rect">
+            <a:avLst/>
+          </a:prstGeom>
+          <a:noFill/>
+        </p:spPr>
+        <p:txBody>
+          <a:bodyPr wrap="square">
+            <a:spAutoFit/>
+          </a:bodyPr>
+          <a:lstStyle/>
+          <a:p>
+            <a:pPr algn="l">
+              <a:spcAft>
+                <a:spcPts val="400"/>
+              </a:spcAft>
+            </a:pPr>
+            <a:r>
+              <a:rPr sz="1500" b="1">
+                <a:solidFill>
+                  <a:srgbClr val="0069B0"/>
+                </a:solidFill>
+              </a:rPr>
+              <a:t>No Shared Language</a:t>
+            </a:r>
+          </a:p>
+          <a:p>
+            <a:pPr algn="l">
+              <a:spcAft>
+                <a:spcPts val="0"/>
+              </a:spcAft>
+            </a:pPr>
+            <a:r>
+              <a:rPr sz="1000" b="0">
+                <a:solidFill>
+                  <a:srgbClr val="555555"/>
+                </a:solidFill>
+              </a:rPr>
+              <a:t>SEs work in the model, developers work in code. Intent gets lost at every handoff — misalignment surfaces at integration.</a:t>
+            </a:r>
+          </a:p>
+        </p:txBody>
+      </p:sp>
+      <p:sp>
+        <p:nvSpPr>
+          <p:cNvPr id="5" name="Rounded Rectangle 4"/>
+          <p:cNvSpPr/>
+          <p:nvPr/>
+        </p:nvSpPr>
+        <p:spPr>
+          <a:xfrm>
+            <a:off x="457200" y="2788920"/>
+            <a:ext cx="6675120" cy="1234440"/>
+          </a:xfrm>
+          <a:prstGeom prst="roundRect">
+            <a:avLst/>
+          </a:prstGeom>
+          <a:solidFill>
+            <a:srgbClr val="F4F7FA"/>
+          </a:solidFill>
+          <a:ln w="12700">
+            <a:solidFill>
+              <a:srgbClr val="D0E8F8"/>
+            </a:solidFill>
+          </a:ln>
+        </p:spPr>
+        <p:style>
+          <a:lnRef idx="1">
+            <a:schemeClr val="accent1"/>
+          </a:lnRef>
+          <a:fillRef idx="3">
+            <a:schemeClr val="accent1"/>
+          </a:fillRef>
+          <a:effectRef idx="2">
+            <a:schemeClr val="accent1"/>
+          </a:effectRef>
+          <a:fontRef idx="minor">
+            <a:schemeClr val="lt1"/>
+          </a:fontRef>
+        </p:style>
+        <p:txBody>
+          <a:bodyPr rtlCol="0" anchor="ctr"/>
+          <a:lstStyle/>
+          <a:p>
+            <a:pPr algn="ctr"/>
+          </a:p>
+        </p:txBody>
+      </p:sp>
+      <p:sp>
+        <p:nvSpPr>
+          <p:cNvPr id="6" name="TextBox 5"/>
+          <p:cNvSpPr txBox="1"/>
+          <p:nvPr/>
+        </p:nvSpPr>
+        <p:spPr>
+          <a:xfrm>
+            <a:off x="731520" y="2926080"/>
+            <a:ext cx="6217920" cy="1005840"/>
+          </a:xfrm>
+          <a:prstGeom prst="rect">
+            <a:avLst/>
+          </a:prstGeom>
+          <a:noFill/>
+        </p:spPr>
+        <p:txBody>
+          <a:bodyPr wrap="square">
+            <a:spAutoFit/>
+          </a:bodyPr>
+          <a:lstStyle/>
+          <a:p>
+            <a:pPr algn="l">
+              <a:spcAft>
+                <a:spcPts val="400"/>
+              </a:spcAft>
+            </a:pPr>
+            <a:r>
+              <a:rPr sz="1500" b="1">
+                <a:solidFill>
+                  <a:srgbClr val="0069B0"/>
+                </a:solidFill>
+              </a:rPr>
+              <a:t>No Reliable Handoff</a:t>
+            </a:r>
+          </a:p>
+          <a:p>
+            <a:pPr algn="l">
+              <a:spcAft>
+                <a:spcPts val="0"/>
+              </a:spcAft>
+            </a:pPr>
+            <a:r>
+              <a:rPr sz="1000" b="0">
+                <a:solidFill>
+                  <a:srgbClr val="555555"/>
+                </a:solidFill>
+              </a:rPr>
+              <a:t>Artifacts shared over email have no version control. When the model changes, nothing alerts the team. Tests go stale silently.</a:t>
+            </a:r>
+          </a:p>
+        </p:txBody>
+      </p:sp>
+      <p:sp>
+        <p:nvSpPr>
+          <p:cNvPr id="7" name="Rounded Rectangle 6"/>
+          <p:cNvSpPr/>
+          <p:nvPr/>
+        </p:nvSpPr>
+        <p:spPr>
+          <a:xfrm>
+            <a:off x="457200" y="4206240"/>
+            <a:ext cx="6675120" cy="1234440"/>
+          </a:xfrm>
+          <a:prstGeom prst="roundRect">
+            <a:avLst/>
+          </a:prstGeom>
+          <a:solidFill>
+            <a:srgbClr val="F4F7FA"/>
+          </a:solidFill>
+          <a:ln w="12700">
+            <a:solidFill>
+              <a:srgbClr val="D0E8F8"/>
+            </a:solidFill>
+          </a:ln>
+        </p:spPr>
+        <p:style>
+          <a:lnRef idx="1">
+            <a:schemeClr val="accent1"/>
+          </a:lnRef>
+          <a:fillRef idx="3">
+            <a:schemeClr val="accent1"/>
+          </a:fillRef>
+          <a:effectRef idx="2">
+            <a:schemeClr val="accent1"/>
+          </a:effectRef>
+          <a:fontRef idx="minor">
+            <a:schemeClr val="lt1"/>
+          </a:fontRef>
+        </p:style>
+        <p:txBody>
+          <a:bodyPr rtlCol="0" anchor="ctr"/>
+          <a:lstStyle/>
+          <a:p>
+            <a:pPr algn="ctr"/>
+          </a:p>
+        </p:txBody>
+      </p:sp>
+      <p:sp>
+        <p:nvSpPr>
           <p:cNvPr id="8" name="TextBox 7"/>
           <p:cNvSpPr txBox="1"/>
           <p:nvPr/>
         </p:nvSpPr>
         <p:spPr>
           <a:xfrm>
-            <a:off x="6400800" y="1371600"/>
-            <a:ext cx="4937760" cy="274320"/>
-          </a:xfrm>
-          <a:prstGeom prst="rect">
-            <a:avLst/>
-          </a:prstGeom>
-          <a:noFill/>
-        </p:spPr>
-        <p:txBody>
-          <a:bodyPr wrap="square">
-            <a:spAutoFit/>
-          </a:bodyPr>
-          <a:lstStyle/>
-          <a:p>
-            <a:pPr algn="l">
+            <a:off x="731520" y="4343400"/>
+            <a:ext cx="6217920" cy="1005840"/>
+          </a:xfrm>
+          <a:prstGeom prst="rect">
+            <a:avLst/>
+          </a:prstGeom>
+          <a:noFill/>
+        </p:spPr>
+        <p:txBody>
+          <a:bodyPr wrap="square">
+            <a:spAutoFit/>
+          </a:bodyPr>
+          <a:lstStyle/>
+          <a:p>
+            <a:pPr algn="l">
+              <a:spcAft>
+                <a:spcPts val="400"/>
+              </a:spcAft>
+            </a:pPr>
+            <a:r>
+              <a:rPr sz="1500" b="1">
+                <a:solidFill>
+                  <a:srgbClr val="0069B0"/>
+                </a:solidFill>
+              </a:rPr>
+              <a:t>No Connected Toolchain</a:t>
+            </a:r>
+          </a:p>
+          <a:p>
+            <a:pPr algn="l">
+              <a:spcAft>
+                <a:spcPts val="0"/>
+              </a:spcAft>
+            </a:pPr>
+            <a:r>
+              <a:rPr sz="1000" b="0">
+                <a:solidFill>
+                  <a:srgbClr val="555555"/>
+                </a:solidFill>
+              </a:rPr>
+              <a:t>Requirements, tests, and deployment live in separate tools. Audit evidence is rebuilt from scratch every review cycle.</a:t>
+            </a:r>
+          </a:p>
+        </p:txBody>
+      </p:sp>
+      <p:sp>
+        <p:nvSpPr>
+          <p:cNvPr id="9" name="TextBox 8"/>
+          <p:cNvSpPr txBox="1"/>
+          <p:nvPr/>
+        </p:nvSpPr>
+        <p:spPr>
+          <a:xfrm>
+            <a:off x="7772400" y="1371600"/>
+            <a:ext cx="3657600" cy="320040"/>
+          </a:xfrm>
+          <a:prstGeom prst="rect">
+            <a:avLst/>
+          </a:prstGeom>
+          <a:noFill/>
+        </p:spPr>
+        <p:txBody>
+          <a:bodyPr wrap="square">
+            <a:spAutoFit/>
+          </a:bodyPr>
+          <a:lstStyle/>
+          <a:p>
+            <a:pPr algn="ctr">
               <a:spcAft>
                 <a:spcPts val="0"/>
               </a:spcAft>
@@ -4866,130 +4918,464 @@
             <a:r>
               <a:rPr sz="1400" b="1">
                 <a:solidFill>
+                  <a:srgbClr val="888888"/>
+                </a:solidFill>
+              </a:rPr>
+              <a:t>Today</a:t>
+            </a:r>
+          </a:p>
+        </p:txBody>
+      </p:sp>
+      <p:sp>
+        <p:nvSpPr>
+          <p:cNvPr id="10" name="Rounded Rectangle 9"/>
+          <p:cNvSpPr/>
+          <p:nvPr/>
+        </p:nvSpPr>
+        <p:spPr>
+          <a:xfrm>
+            <a:off x="8321040" y="1920240"/>
+            <a:ext cx="2560320" cy="594360"/>
+          </a:xfrm>
+          <a:prstGeom prst="roundRect">
+            <a:avLst/>
+          </a:prstGeom>
+          <a:solidFill>
+            <a:srgbClr val="003057"/>
+          </a:solidFill>
+          <a:ln>
+            <a:noFill/>
+          </a:ln>
+        </p:spPr>
+        <p:style>
+          <a:lnRef idx="1">
+            <a:schemeClr val="accent1"/>
+          </a:lnRef>
+          <a:fillRef idx="3">
+            <a:schemeClr val="accent1"/>
+          </a:fillRef>
+          <a:effectRef idx="2">
+            <a:schemeClr val="accent1"/>
+          </a:effectRef>
+          <a:fontRef idx="minor">
+            <a:schemeClr val="lt1"/>
+          </a:fontRef>
+        </p:style>
+        <p:txBody>
+          <a:bodyPr rtlCol="0" anchor="ctr"/>
+          <a:lstStyle/>
+          <a:p>
+            <a:pPr algn="ctr"/>
+          </a:p>
+        </p:txBody>
+      </p:sp>
+      <p:sp>
+        <p:nvSpPr>
+          <p:cNvPr id="11" name="TextBox 10"/>
+          <p:cNvSpPr txBox="1"/>
+          <p:nvPr/>
+        </p:nvSpPr>
+        <p:spPr>
+          <a:xfrm>
+            <a:off x="8412480" y="2029968"/>
+            <a:ext cx="2377440" cy="411480"/>
+          </a:xfrm>
+          <a:prstGeom prst="rect">
+            <a:avLst/>
+          </a:prstGeom>
+          <a:noFill/>
+        </p:spPr>
+        <p:txBody>
+          <a:bodyPr wrap="square">
+            <a:spAutoFit/>
+          </a:bodyPr>
+          <a:lstStyle/>
+          <a:p>
+            <a:pPr algn="ctr">
+              <a:spcAft>
+                <a:spcPts val="0"/>
+              </a:spcAft>
+            </a:pPr>
+            <a:r>
+              <a:rPr sz="1100" b="1">
+                <a:solidFill>
+                  <a:srgbClr val="FFFFFF"/>
+                </a:solidFill>
+              </a:rPr>
+              <a:t>Cameo Model</a:t>
+            </a:r>
+          </a:p>
+        </p:txBody>
+      </p:sp>
+      <p:sp>
+        <p:nvSpPr>
+          <p:cNvPr id="12" name="Rounded Rectangle 11"/>
+          <p:cNvSpPr/>
+          <p:nvPr/>
+        </p:nvSpPr>
+        <p:spPr>
+          <a:xfrm>
+            <a:off x="8321040" y="2880360"/>
+            <a:ext cx="2560320" cy="594360"/>
+          </a:xfrm>
+          <a:prstGeom prst="roundRect">
+            <a:avLst/>
+          </a:prstGeom>
+          <a:solidFill>
+            <a:srgbClr val="004A87"/>
+          </a:solidFill>
+          <a:ln>
+            <a:noFill/>
+          </a:ln>
+        </p:spPr>
+        <p:style>
+          <a:lnRef idx="1">
+            <a:schemeClr val="accent1"/>
+          </a:lnRef>
+          <a:fillRef idx="3">
+            <a:schemeClr val="accent1"/>
+          </a:fillRef>
+          <a:effectRef idx="2">
+            <a:schemeClr val="accent1"/>
+          </a:effectRef>
+          <a:fontRef idx="minor">
+            <a:schemeClr val="lt1"/>
+          </a:fontRef>
+        </p:style>
+        <p:txBody>
+          <a:bodyPr rtlCol="0" anchor="ctr"/>
+          <a:lstStyle/>
+          <a:p>
+            <a:pPr algn="ctr"/>
+          </a:p>
+        </p:txBody>
+      </p:sp>
+      <p:sp>
+        <p:nvSpPr>
+          <p:cNvPr id="13" name="TextBox 12"/>
+          <p:cNvSpPr txBox="1"/>
+          <p:nvPr/>
+        </p:nvSpPr>
+        <p:spPr>
+          <a:xfrm>
+            <a:off x="8412480" y="2990088"/>
+            <a:ext cx="2377440" cy="411480"/>
+          </a:xfrm>
+          <a:prstGeom prst="rect">
+            <a:avLst/>
+          </a:prstGeom>
+          <a:noFill/>
+        </p:spPr>
+        <p:txBody>
+          <a:bodyPr wrap="square">
+            <a:spAutoFit/>
+          </a:bodyPr>
+          <a:lstStyle/>
+          <a:p>
+            <a:pPr algn="ctr">
+              <a:spcAft>
+                <a:spcPts val="0"/>
+              </a:spcAft>
+            </a:pPr>
+            <a:r>
+              <a:rPr sz="1100" b="1">
+                <a:solidFill>
+                  <a:srgbClr val="FFFFFF"/>
+                </a:solidFill>
+              </a:rPr>
+              <a:t>Test Suite</a:t>
+            </a:r>
+          </a:p>
+        </p:txBody>
+      </p:sp>
+      <p:sp>
+        <p:nvSpPr>
+          <p:cNvPr id="14" name="Rounded Rectangle 13"/>
+          <p:cNvSpPr/>
+          <p:nvPr/>
+        </p:nvSpPr>
+        <p:spPr>
+          <a:xfrm>
+            <a:off x="8321040" y="3840480"/>
+            <a:ext cx="2560320" cy="594360"/>
+          </a:xfrm>
+          <a:prstGeom prst="roundRect">
+            <a:avLst/>
+          </a:prstGeom>
+          <a:solidFill>
+            <a:srgbClr val="888888"/>
+          </a:solidFill>
+          <a:ln>
+            <a:noFill/>
+          </a:ln>
+        </p:spPr>
+        <p:style>
+          <a:lnRef idx="1">
+            <a:schemeClr val="accent1"/>
+          </a:lnRef>
+          <a:fillRef idx="3">
+            <a:schemeClr val="accent1"/>
+          </a:fillRef>
+          <a:effectRef idx="2">
+            <a:schemeClr val="accent1"/>
+          </a:effectRef>
+          <a:fontRef idx="minor">
+            <a:schemeClr val="lt1"/>
+          </a:fontRef>
+        </p:style>
+        <p:txBody>
+          <a:bodyPr rtlCol="0" anchor="ctr"/>
+          <a:lstStyle/>
+          <a:p>
+            <a:pPr algn="ctr"/>
+          </a:p>
+        </p:txBody>
+      </p:sp>
+      <p:sp>
+        <p:nvSpPr>
+          <p:cNvPr id="15" name="TextBox 14"/>
+          <p:cNvSpPr txBox="1"/>
+          <p:nvPr/>
+        </p:nvSpPr>
+        <p:spPr>
+          <a:xfrm>
+            <a:off x="8412480" y="3950208"/>
+            <a:ext cx="2377440" cy="411480"/>
+          </a:xfrm>
+          <a:prstGeom prst="rect">
+            <a:avLst/>
+          </a:prstGeom>
+          <a:noFill/>
+        </p:spPr>
+        <p:txBody>
+          <a:bodyPr wrap="square">
+            <a:spAutoFit/>
+          </a:bodyPr>
+          <a:lstStyle/>
+          <a:p>
+            <a:pPr algn="ctr">
+              <a:spcAft>
+                <a:spcPts val="0"/>
+              </a:spcAft>
+            </a:pPr>
+            <a:r>
+              <a:rPr sz="1100" b="1">
+                <a:solidFill>
+                  <a:srgbClr val="FFFFFF"/>
+                </a:solidFill>
+              </a:rPr>
+              <a:t>Deployment</a:t>
+            </a:r>
+          </a:p>
+        </p:txBody>
+      </p:sp>
+      <p:sp>
+        <p:nvSpPr>
+          <p:cNvPr id="16" name="TextBox 15"/>
+          <p:cNvSpPr txBox="1"/>
+          <p:nvPr/>
+        </p:nvSpPr>
+        <p:spPr>
+          <a:xfrm>
+            <a:off x="9326880" y="2587752"/>
+            <a:ext cx="548640" cy="274320"/>
+          </a:xfrm>
+          <a:prstGeom prst="rect">
+            <a:avLst/>
+          </a:prstGeom>
+          <a:noFill/>
+        </p:spPr>
+        <p:txBody>
+          <a:bodyPr wrap="square">
+            <a:spAutoFit/>
+          </a:bodyPr>
+          <a:lstStyle/>
+          <a:p>
+            <a:pPr algn="ctr">
+              <a:spcAft>
+                <a:spcPts val="0"/>
+              </a:spcAft>
+            </a:pPr>
+            <a:r>
+              <a:rPr sz="1600" b="1">
+                <a:solidFill>
+                  <a:srgbClr val="CC3333"/>
+                </a:solidFill>
+              </a:rPr>
+              <a:t>✘</a:t>
+            </a:r>
+          </a:p>
+        </p:txBody>
+      </p:sp>
+      <p:sp>
+        <p:nvSpPr>
+          <p:cNvPr id="17" name="TextBox 16"/>
+          <p:cNvSpPr txBox="1"/>
+          <p:nvPr/>
+        </p:nvSpPr>
+        <p:spPr>
+          <a:xfrm>
+            <a:off x="9326880" y="3547872"/>
+            <a:ext cx="548640" cy="274320"/>
+          </a:xfrm>
+          <a:prstGeom prst="rect">
+            <a:avLst/>
+          </a:prstGeom>
+          <a:noFill/>
+        </p:spPr>
+        <p:txBody>
+          <a:bodyPr wrap="square">
+            <a:spAutoFit/>
+          </a:bodyPr>
+          <a:lstStyle/>
+          <a:p>
+            <a:pPr algn="ctr">
+              <a:spcAft>
+                <a:spcPts val="0"/>
+              </a:spcAft>
+            </a:pPr>
+            <a:r>
+              <a:rPr sz="1600" b="1">
+                <a:solidFill>
+                  <a:srgbClr val="CC3333"/>
+                </a:solidFill>
+              </a:rPr>
+              <a:t>✘</a:t>
+            </a:r>
+          </a:p>
+        </p:txBody>
+      </p:sp>
+      <p:sp>
+        <p:nvSpPr>
+          <p:cNvPr id="18" name="TextBox 17"/>
+          <p:cNvSpPr txBox="1"/>
+          <p:nvPr/>
+        </p:nvSpPr>
+        <p:spPr>
+          <a:xfrm>
+            <a:off x="7772400" y="4709160"/>
+            <a:ext cx="3657600" cy="457200"/>
+          </a:xfrm>
+          <a:prstGeom prst="rect">
+            <a:avLst/>
+          </a:prstGeom>
+          <a:noFill/>
+        </p:spPr>
+        <p:txBody>
+          <a:bodyPr wrap="square">
+            <a:spAutoFit/>
+          </a:bodyPr>
+          <a:lstStyle/>
+          <a:p>
+            <a:pPr algn="ctr">
+              <a:spcAft>
+                <a:spcPts val="200"/>
+              </a:spcAft>
+            </a:pPr>
+            <a:r>
+              <a:rPr sz="1000" b="1">
+                <a:solidFill>
+                  <a:srgbClr val="CC3333"/>
+                </a:solidFill>
+              </a:rPr>
+              <a:t>No automated thread</a:t>
+            </a:r>
+          </a:p>
+          <a:p>
+            <a:pPr algn="ctr">
+              <a:spcAft>
+                <a:spcPts val="0"/>
+              </a:spcAft>
+            </a:pPr>
+            <a:r>
+              <a:rPr sz="900" b="0">
+                <a:solidFill>
+                  <a:srgbClr val="888888"/>
+                </a:solidFill>
+              </a:rPr>
+              <a:t>Manual handoffs at every stage</a:t>
+            </a:r>
+          </a:p>
+        </p:txBody>
+      </p:sp>
+      <p:sp>
+        <p:nvSpPr>
+          <p:cNvPr id="19" name="Rounded Rectangle 18"/>
+          <p:cNvSpPr/>
+          <p:nvPr/>
+        </p:nvSpPr>
+        <p:spPr>
+          <a:xfrm>
+            <a:off x="457200" y="5760720"/>
+            <a:ext cx="11247120" cy="457200"/>
+          </a:xfrm>
+          <a:prstGeom prst="roundRect">
+            <a:avLst/>
+          </a:prstGeom>
+          <a:solidFill>
+            <a:srgbClr val="F4F7FA"/>
+          </a:solidFill>
+          <a:ln w="12700">
+            <a:solidFill>
+              <a:srgbClr val="0069B0"/>
+            </a:solidFill>
+          </a:ln>
+        </p:spPr>
+        <p:style>
+          <a:lnRef idx="1">
+            <a:schemeClr val="accent1"/>
+          </a:lnRef>
+          <a:fillRef idx="3">
+            <a:schemeClr val="accent1"/>
+          </a:fillRef>
+          <a:effectRef idx="2">
+            <a:schemeClr val="accent1"/>
+          </a:effectRef>
+          <a:fontRef idx="minor">
+            <a:schemeClr val="lt1"/>
+          </a:fontRef>
+        </p:style>
+        <p:txBody>
+          <a:bodyPr rtlCol="0" anchor="ctr"/>
+          <a:lstStyle/>
+          <a:p>
+            <a:pPr algn="ctr"/>
+          </a:p>
+        </p:txBody>
+      </p:sp>
+      <p:sp>
+        <p:nvSpPr>
+          <p:cNvPr id="20" name="TextBox 19"/>
+          <p:cNvSpPr txBox="1"/>
+          <p:nvPr/>
+        </p:nvSpPr>
+        <p:spPr>
+          <a:xfrm>
+            <a:off x="731520" y="5815584"/>
+            <a:ext cx="10789920" cy="365760"/>
+          </a:xfrm>
+          <a:prstGeom prst="rect">
+            <a:avLst/>
+          </a:prstGeom>
+          <a:noFill/>
+        </p:spPr>
+        <p:txBody>
+          <a:bodyPr wrap="square">
+            <a:spAutoFit/>
+          </a:bodyPr>
+          <a:lstStyle/>
+          <a:p>
+            <a:pPr algn="ctr">
+              <a:spcAft>
+                <a:spcPts val="0"/>
+              </a:spcAft>
+            </a:pPr>
+            <a:r>
+              <a:rPr sz="1200" b="1">
+                <a:solidFill>
                   <a:srgbClr val="0D1B2A"/>
                 </a:solidFill>
               </a:rPr>
-              <a:t>Why the Old Approach Falls Short</a:t>
-            </a:r>
-          </a:p>
-        </p:txBody>
-      </p:sp>
-      <p:sp>
-        <p:nvSpPr>
-          <p:cNvPr id="9" name="TextBox 8"/>
-          <p:cNvSpPr txBox="1"/>
-          <p:nvPr/>
-        </p:nvSpPr>
-        <p:spPr>
-          <a:xfrm>
-            <a:off x="6400800" y="1920240"/>
-            <a:ext cx="4937760" cy="2560320"/>
-          </a:xfrm>
-          <a:prstGeom prst="rect">
-            <a:avLst/>
-          </a:prstGeom>
-          <a:noFill/>
-        </p:spPr>
-        <p:txBody>
-          <a:bodyPr wrap="square">
-            <a:spAutoFit/>
-          </a:bodyPr>
-          <a:lstStyle/>
-          <a:p>
-            <a:pPr algn="l">
-              <a:spcAft>
-                <a:spcPts val="800"/>
-              </a:spcAft>
-            </a:pPr>
-            <a:r>
-              <a:rPr sz="1000" b="0">
-                <a:solidFill>
-                  <a:srgbClr val="555555"/>
-                </a:solidFill>
-              </a:rPr>
-              <a:t>•  Requirements are living targets — this program moves faster than any manual process can track.</a:t>
-            </a:r>
-          </a:p>
-          <a:p>
-            <a:pPr algn="l">
-              <a:spcAft>
-                <a:spcPts val="800"/>
-              </a:spcAft>
-            </a:pPr>
-            <a:r>
-              <a:rPr sz="1000" b="0">
-                <a:solidFill>
-                  <a:srgbClr val="555555"/>
-                </a:solidFill>
-              </a:rPr>
-              <a:t>•  SE/SW misalignment surfaces at integration — the most expensive point to find it.</a:t>
-            </a:r>
-          </a:p>
-          <a:p>
-            <a:pPr algn="l">
-              <a:spcAft>
-                <a:spcPts val="800"/>
-              </a:spcAft>
-            </a:pPr>
-            <a:r>
-              <a:rPr sz="1000" b="0">
-                <a:solidFill>
-                  <a:srgbClr val="555555"/>
-                </a:solidFill>
-              </a:rPr>
-              <a:t>•  Audit evidence reconstructed from scratch each review cycle — unsustainable at this pace.</a:t>
-            </a:r>
-          </a:p>
-          <a:p>
-            <a:pPr algn="l">
-              <a:spcAft>
-                <a:spcPts val="800"/>
-              </a:spcAft>
-            </a:pPr>
-            <a:r>
-              <a:rPr sz="1000" b="0">
-                <a:solidFill>
-                  <a:srgbClr val="555555"/>
-                </a:solidFill>
-              </a:rPr>
-              <a:t>•  Requirement changes silently invalidate tests — no alert, no flag, no enforcement.</a:t>
-            </a:r>
-          </a:p>
-        </p:txBody>
-      </p:sp>
-      <p:sp>
-        <p:nvSpPr>
-          <p:cNvPr id="10" name="TextBox 9"/>
-          <p:cNvSpPr txBox="1"/>
-          <p:nvPr/>
-        </p:nvSpPr>
-        <p:spPr>
-          <a:xfrm>
-            <a:off x="731520" y="5303520"/>
-            <a:ext cx="10515600" cy="365760"/>
-          </a:xfrm>
-          <a:prstGeom prst="rect">
-            <a:avLst/>
-          </a:prstGeom>
-          <a:noFill/>
-        </p:spPr>
-        <p:txBody>
-          <a:bodyPr wrap="square">
-            <a:spAutoFit/>
-          </a:bodyPr>
-          <a:lstStyle/>
-          <a:p>
-            <a:pPr algn="l">
-              <a:spcAft>
-                <a:spcPts val="0"/>
-              </a:spcAft>
-            </a:pPr>
-            <a:r>
-              <a:rPr sz="1300" b="1">
-                <a:solidFill>
-                  <a:srgbClr val="0D1B2A"/>
-                </a:solidFill>
-              </a:rPr>
               <a:t>This program moves too fast for manual traceability. The pipeline keeps pace.</a:t>
             </a:r>
           </a:p>
@@ -4997,7 +5383,7 @@
       </p:sp>
       <p:sp>
         <p:nvSpPr>
-          <p:cNvPr id="11" name="TextBox 10"/>
+          <p:cNvPr id="21" name="TextBox 20"/>
           <p:cNvSpPr txBox="1"/>
           <p:nvPr/>
         </p:nvSpPr>
@@ -6577,7 +6963,7 @@
         <p:spPr>
           <a:xfrm>
             <a:off x="457200" y="1645920"/>
-            <a:ext cx="2103120" cy="1828800"/>
+            <a:ext cx="3474720" cy="1828800"/>
           </a:xfrm>
           <a:prstGeom prst="roundRect">
             <a:avLst/>
@@ -6622,7 +7008,7 @@
         <p:spPr>
           <a:xfrm>
             <a:off x="457200" y="1645920"/>
-            <a:ext cx="2103120" cy="411480"/>
+            <a:ext cx="3474720" cy="411480"/>
           </a:xfrm>
           <a:prstGeom prst="roundRect">
             <a:avLst/>
@@ -6665,7 +7051,7 @@
         <p:spPr>
           <a:xfrm>
             <a:off x="548640" y="1673352"/>
-            <a:ext cx="1920240" cy="320040"/>
+            <a:ext cx="3291840" cy="320040"/>
           </a:xfrm>
           <a:prstGeom prst="rect">
             <a:avLst/>
@@ -6703,7 +7089,7 @@
         <p:spPr>
           <a:xfrm>
             <a:off x="548640" y="2148840"/>
-            <a:ext cx="1920240" cy="274320"/>
+            <a:ext cx="3291840" cy="274320"/>
           </a:xfrm>
           <a:prstGeom prst="rect">
             <a:avLst/>
@@ -6741,7 +7127,7 @@
         <p:spPr>
           <a:xfrm>
             <a:off x="548640" y="2423160"/>
-            <a:ext cx="1920240" cy="822960"/>
+            <a:ext cx="3291840" cy="822960"/>
           </a:xfrm>
           <a:prstGeom prst="rect">
             <a:avLst/>
@@ -6779,8 +7165,8 @@
         </p:nvSpPr>
         <p:spPr>
           <a:xfrm>
-            <a:off x="2697480" y="1645920"/>
-            <a:ext cx="2103120" cy="1828800"/>
+            <a:off x="4160520" y="1645920"/>
+            <a:ext cx="3474720" cy="1828800"/>
           </a:xfrm>
           <a:prstGeom prst="roundRect">
             <a:avLst/>
@@ -6824,14 +7210,14 @@
         </p:nvSpPr>
         <p:spPr>
           <a:xfrm>
-            <a:off x="2697480" y="1645920"/>
-            <a:ext cx="2103120" cy="411480"/>
+            <a:off x="4160520" y="1645920"/>
+            <a:ext cx="3474720" cy="411480"/>
           </a:xfrm>
           <a:prstGeom prst="roundRect">
             <a:avLst/>
           </a:prstGeom>
           <a:solidFill>
-            <a:srgbClr val="0082CC"/>
+            <a:srgbClr val="0069B0"/>
           </a:solidFill>
           <a:ln>
             <a:noFill/>
@@ -6867,8 +7253,8 @@
         </p:nvSpPr>
         <p:spPr>
           <a:xfrm>
-            <a:off x="2788920" y="1673352"/>
-            <a:ext cx="1920240" cy="320040"/>
+            <a:off x="4251960" y="1673352"/>
+            <a:ext cx="3291840" cy="320040"/>
           </a:xfrm>
           <a:prstGeom prst="rect">
             <a:avLst/>
@@ -6892,7 +7278,7 @@
                   <a:srgbClr val="FFFFFF"/>
                 </a:solidFill>
               </a:rPr>
-              <a:t>Release 1.1.0</a:t>
+              <a:t>Release 1.2.0</a:t>
             </a:r>
           </a:p>
         </p:txBody>
@@ -6905,8 +7291,8 @@
         </p:nvSpPr>
         <p:spPr>
           <a:xfrm>
-            <a:off x="2788920" y="2148840"/>
-            <a:ext cx="1920240" cy="274320"/>
+            <a:off x="4251960" y="2148840"/>
+            <a:ext cx="3291840" cy="274320"/>
           </a:xfrm>
           <a:prstGeom prst="rect">
             <a:avLst/>
@@ -6927,10 +7313,10 @@
             <a:r>
               <a:rPr sz="800" b="1">
                 <a:solidFill>
-                  <a:srgbClr val="0099D6"/>
-                </a:solidFill>
-              </a:rPr>
-              <a:t>SHIPPED</a:t>
+                  <a:srgbClr val="0069B0"/>
+                </a:solidFill>
+              </a:rPr>
+              <a:t>CURRENT</a:t>
             </a:r>
           </a:p>
         </p:txBody>
@@ -6943,8 +7329,8 @@
         </p:nvSpPr>
         <p:spPr>
           <a:xfrm>
-            <a:off x="2788920" y="2423160"/>
-            <a:ext cx="1920240" cy="822960"/>
+            <a:off x="4251960" y="2423160"/>
+            <a:ext cx="3291840" cy="822960"/>
           </a:xfrm>
           <a:prstGeom prst="rect">
             <a:avLst/>
@@ -6968,8 +7354,8 @@
                   <a:srgbClr val="555555"/>
                 </a:solidFill>
               </a:rPr>
-              <a:t>Error Handling &amp;
-Message Validation</a:t>
+              <a:t>Degradation &amp;
+Configuration Mgmt</a:t>
             </a:r>
           </a:p>
         </p:txBody>
@@ -6982,8 +7368,8 @@
         </p:nvSpPr>
         <p:spPr>
           <a:xfrm>
-            <a:off x="4937760" y="1645920"/>
-            <a:ext cx="2103120" cy="1828800"/>
+            <a:off x="7863840" y="1645920"/>
+            <a:ext cx="3474720" cy="1828800"/>
           </a:xfrm>
           <a:prstGeom prst="roundRect">
             <a:avLst/>
@@ -7027,211 +7413,8 @@
         </p:nvSpPr>
         <p:spPr>
           <a:xfrm>
-            <a:off x="4937760" y="1645920"/>
-            <a:ext cx="2103120" cy="411480"/>
-          </a:xfrm>
-          <a:prstGeom prst="roundRect">
-            <a:avLst/>
-          </a:prstGeom>
-          <a:solidFill>
-            <a:srgbClr val="0069B0"/>
-          </a:solidFill>
-          <a:ln>
-            <a:noFill/>
-          </a:ln>
-        </p:spPr>
-        <p:style>
-          <a:lnRef idx="1">
-            <a:schemeClr val="accent1"/>
-          </a:lnRef>
-          <a:fillRef idx="3">
-            <a:schemeClr val="accent1"/>
-          </a:fillRef>
-          <a:effectRef idx="2">
-            <a:schemeClr val="accent1"/>
-          </a:effectRef>
-          <a:fontRef idx="minor">
-            <a:schemeClr val="lt1"/>
-          </a:fontRef>
-        </p:style>
-        <p:txBody>
-          <a:bodyPr rtlCol="0" anchor="ctr"/>
-          <a:lstStyle/>
-          <a:p>
-            <a:pPr algn="ctr"/>
-          </a:p>
-        </p:txBody>
-      </p:sp>
-      <p:sp>
-        <p:nvSpPr>
-          <p:cNvPr id="16" name="TextBox 15"/>
-          <p:cNvSpPr txBox="1"/>
-          <p:nvPr/>
-        </p:nvSpPr>
-        <p:spPr>
-          <a:xfrm>
-            <a:off x="5029200" y="1673352"/>
-            <a:ext cx="1920240" cy="320040"/>
-          </a:xfrm>
-          <a:prstGeom prst="rect">
-            <a:avLst/>
-          </a:prstGeom>
-          <a:noFill/>
-        </p:spPr>
-        <p:txBody>
-          <a:bodyPr wrap="square">
-            <a:spAutoFit/>
-          </a:bodyPr>
-          <a:lstStyle/>
-          <a:p>
-            <a:pPr algn="l">
-              <a:spcAft>
-                <a:spcPts val="0"/>
-              </a:spcAft>
-            </a:pPr>
-            <a:r>
-              <a:rPr sz="1100" b="1">
-                <a:solidFill>
-                  <a:srgbClr val="FFFFFF"/>
-                </a:solidFill>
-              </a:rPr>
-              <a:t>Release 1.2.0</a:t>
-            </a:r>
-          </a:p>
-        </p:txBody>
-      </p:sp>
-      <p:sp>
-        <p:nvSpPr>
-          <p:cNvPr id="17" name="TextBox 16"/>
-          <p:cNvSpPr txBox="1"/>
-          <p:nvPr/>
-        </p:nvSpPr>
-        <p:spPr>
-          <a:xfrm>
-            <a:off x="5029200" y="2148840"/>
-            <a:ext cx="1920240" cy="274320"/>
-          </a:xfrm>
-          <a:prstGeom prst="rect">
-            <a:avLst/>
-          </a:prstGeom>
-          <a:noFill/>
-        </p:spPr>
-        <p:txBody>
-          <a:bodyPr wrap="square">
-            <a:spAutoFit/>
-          </a:bodyPr>
-          <a:lstStyle/>
-          <a:p>
-            <a:pPr algn="l">
-              <a:spcAft>
-                <a:spcPts val="0"/>
-              </a:spcAft>
-            </a:pPr>
-            <a:r>
-              <a:rPr sz="800" b="1">
-                <a:solidFill>
-                  <a:srgbClr val="0069B0"/>
-                </a:solidFill>
-              </a:rPr>
-              <a:t>CURRENT</a:t>
-            </a:r>
-          </a:p>
-        </p:txBody>
-      </p:sp>
-      <p:sp>
-        <p:nvSpPr>
-          <p:cNvPr id="18" name="TextBox 17"/>
-          <p:cNvSpPr txBox="1"/>
-          <p:nvPr/>
-        </p:nvSpPr>
-        <p:spPr>
-          <a:xfrm>
-            <a:off x="5029200" y="2423160"/>
-            <a:ext cx="1920240" cy="822960"/>
-          </a:xfrm>
-          <a:prstGeom prst="rect">
-            <a:avLst/>
-          </a:prstGeom>
-          <a:noFill/>
-        </p:spPr>
-        <p:txBody>
-          <a:bodyPr wrap="square">
-            <a:spAutoFit/>
-          </a:bodyPr>
-          <a:lstStyle/>
-          <a:p>
-            <a:pPr algn="l">
-              <a:spcAft>
-                <a:spcPts val="0"/>
-              </a:spcAft>
-            </a:pPr>
-            <a:r>
-              <a:rPr sz="900" b="0">
-                <a:solidFill>
-                  <a:srgbClr val="555555"/>
-                </a:solidFill>
-              </a:rPr>
-              <a:t>Degradation &amp;
-Configuration Mgmt</a:t>
-            </a:r>
-          </a:p>
-        </p:txBody>
-      </p:sp>
-      <p:sp>
-        <p:nvSpPr>
-          <p:cNvPr id="19" name="Rounded Rectangle 18"/>
-          <p:cNvSpPr/>
-          <p:nvPr/>
-        </p:nvSpPr>
-        <p:spPr>
-          <a:xfrm>
-            <a:off x="7178040" y="1645920"/>
-            <a:ext cx="2103120" cy="1828800"/>
-          </a:xfrm>
-          <a:prstGeom prst="roundRect">
-            <a:avLst/>
-          </a:prstGeom>
-          <a:solidFill>
-            <a:srgbClr val="F4F7FA"/>
-          </a:solidFill>
-          <a:ln w="12700">
-            <a:solidFill>
-              <a:srgbClr val="D0E8F8"/>
-            </a:solidFill>
-          </a:ln>
-        </p:spPr>
-        <p:style>
-          <a:lnRef idx="1">
-            <a:schemeClr val="accent1"/>
-          </a:lnRef>
-          <a:fillRef idx="3">
-            <a:schemeClr val="accent1"/>
-          </a:fillRef>
-          <a:effectRef idx="2">
-            <a:schemeClr val="accent1"/>
-          </a:effectRef>
-          <a:fontRef idx="minor">
-            <a:schemeClr val="lt1"/>
-          </a:fontRef>
-        </p:style>
-        <p:txBody>
-          <a:bodyPr rtlCol="0" anchor="ctr"/>
-          <a:lstStyle/>
-          <a:p>
-            <a:pPr algn="ctr"/>
-          </a:p>
-        </p:txBody>
-      </p:sp>
-      <p:sp>
-        <p:nvSpPr>
-          <p:cNvPr id="20" name="Rounded Rectangle 19"/>
-          <p:cNvSpPr/>
-          <p:nvPr/>
-        </p:nvSpPr>
-        <p:spPr>
-          <a:xfrm>
-            <a:off x="7178040" y="1645920"/>
-            <a:ext cx="2103120" cy="411480"/>
+            <a:off x="7863840" y="1645920"/>
+            <a:ext cx="3474720" cy="411480"/>
           </a:xfrm>
           <a:prstGeom prst="roundRect">
             <a:avLst/>
@@ -7267,14 +7450,14 @@
       </p:sp>
       <p:sp>
         <p:nvSpPr>
-          <p:cNvPr id="21" name="TextBox 20"/>
-          <p:cNvSpPr txBox="1"/>
-          <p:nvPr/>
-        </p:nvSpPr>
-        <p:spPr>
-          <a:xfrm>
-            <a:off x="7269480" y="1673352"/>
-            <a:ext cx="1920240" cy="320040"/>
+          <p:cNvPr id="16" name="TextBox 15"/>
+          <p:cNvSpPr txBox="1"/>
+          <p:nvPr/>
+        </p:nvSpPr>
+        <p:spPr>
+          <a:xfrm>
+            <a:off x="7955280" y="1673352"/>
+            <a:ext cx="3291840" cy="320040"/>
           </a:xfrm>
           <a:prstGeom prst="rect">
             <a:avLst/>
@@ -7305,14 +7488,14 @@
       </p:sp>
       <p:sp>
         <p:nvSpPr>
-          <p:cNvPr id="22" name="TextBox 21"/>
-          <p:cNvSpPr txBox="1"/>
-          <p:nvPr/>
-        </p:nvSpPr>
-        <p:spPr>
-          <a:xfrm>
-            <a:off x="7269480" y="2148840"/>
-            <a:ext cx="1920240" cy="274320"/>
+          <p:cNvPr id="17" name="TextBox 16"/>
+          <p:cNvSpPr txBox="1"/>
+          <p:nvPr/>
+        </p:nvSpPr>
+        <p:spPr>
+          <a:xfrm>
+            <a:off x="7955280" y="2148840"/>
+            <a:ext cx="3291840" cy="274320"/>
           </a:xfrm>
           <a:prstGeom prst="rect">
             <a:avLst/>
@@ -7343,14 +7526,14 @@
       </p:sp>
       <p:sp>
         <p:nvSpPr>
-          <p:cNvPr id="23" name="TextBox 22"/>
-          <p:cNvSpPr txBox="1"/>
-          <p:nvPr/>
-        </p:nvSpPr>
-        <p:spPr>
-          <a:xfrm>
-            <a:off x="7269480" y="2423160"/>
-            <a:ext cx="1920240" cy="822960"/>
+          <p:cNvPr id="18" name="TextBox 17"/>
+          <p:cNvSpPr txBox="1"/>
+          <p:nvPr/>
+        </p:nvSpPr>
+        <p:spPr>
+          <a:xfrm>
+            <a:off x="7955280" y="2423160"/>
+            <a:ext cx="3291840" cy="822960"/>
           </a:xfrm>
           <a:prstGeom prst="rect">
             <a:avLst/>
@@ -7382,210 +7565,7 @@
       </p:sp>
       <p:sp>
         <p:nvSpPr>
-          <p:cNvPr id="24" name="Rounded Rectangle 23"/>
-          <p:cNvSpPr/>
-          <p:nvPr/>
-        </p:nvSpPr>
-        <p:spPr>
-          <a:xfrm>
-            <a:off x="9418320" y="1645920"/>
-            <a:ext cx="2103120" cy="1828800"/>
-          </a:xfrm>
-          <a:prstGeom prst="roundRect">
-            <a:avLst/>
-          </a:prstGeom>
-          <a:solidFill>
-            <a:srgbClr val="F4F7FA"/>
-          </a:solidFill>
-          <a:ln w="12700">
-            <a:solidFill>
-              <a:srgbClr val="D0E8F8"/>
-            </a:solidFill>
-          </a:ln>
-        </p:spPr>
-        <p:style>
-          <a:lnRef idx="1">
-            <a:schemeClr val="accent1"/>
-          </a:lnRef>
-          <a:fillRef idx="3">
-            <a:schemeClr val="accent1"/>
-          </a:fillRef>
-          <a:effectRef idx="2">
-            <a:schemeClr val="accent1"/>
-          </a:effectRef>
-          <a:fontRef idx="minor">
-            <a:schemeClr val="lt1"/>
-          </a:fontRef>
-        </p:style>
-        <p:txBody>
-          <a:bodyPr rtlCol="0" anchor="ctr"/>
-          <a:lstStyle/>
-          <a:p>
-            <a:pPr algn="ctr"/>
-          </a:p>
-        </p:txBody>
-      </p:sp>
-      <p:sp>
-        <p:nvSpPr>
-          <p:cNvPr id="25" name="Rounded Rectangle 24"/>
-          <p:cNvSpPr/>
-          <p:nvPr/>
-        </p:nvSpPr>
-        <p:spPr>
-          <a:xfrm>
-            <a:off x="9418320" y="1645920"/>
-            <a:ext cx="2103120" cy="411480"/>
-          </a:xfrm>
-          <a:prstGeom prst="roundRect">
-            <a:avLst/>
-          </a:prstGeom>
-          <a:solidFill>
-            <a:srgbClr val="888888"/>
-          </a:solidFill>
-          <a:ln>
-            <a:noFill/>
-          </a:ln>
-        </p:spPr>
-        <p:style>
-          <a:lnRef idx="1">
-            <a:schemeClr val="accent1"/>
-          </a:lnRef>
-          <a:fillRef idx="3">
-            <a:schemeClr val="accent1"/>
-          </a:fillRef>
-          <a:effectRef idx="2">
-            <a:schemeClr val="accent1"/>
-          </a:effectRef>
-          <a:fontRef idx="minor">
-            <a:schemeClr val="lt1"/>
-          </a:fontRef>
-        </p:style>
-        <p:txBody>
-          <a:bodyPr rtlCol="0" anchor="ctr"/>
-          <a:lstStyle/>
-          <a:p>
-            <a:pPr algn="ctr"/>
-          </a:p>
-        </p:txBody>
-      </p:sp>
-      <p:sp>
-        <p:nvSpPr>
-          <p:cNvPr id="26" name="TextBox 25"/>
-          <p:cNvSpPr txBox="1"/>
-          <p:nvPr/>
-        </p:nvSpPr>
-        <p:spPr>
-          <a:xfrm>
-            <a:off x="9509760" y="1673352"/>
-            <a:ext cx="1920240" cy="320040"/>
-          </a:xfrm>
-          <a:prstGeom prst="rect">
-            <a:avLst/>
-          </a:prstGeom>
-          <a:noFill/>
-        </p:spPr>
-        <p:txBody>
-          <a:bodyPr wrap="square">
-            <a:spAutoFit/>
-          </a:bodyPr>
-          <a:lstStyle/>
-          <a:p>
-            <a:pPr algn="l">
-              <a:spcAft>
-                <a:spcPts val="0"/>
-              </a:spcAft>
-            </a:pPr>
-            <a:r>
-              <a:rPr sz="1100" b="1">
-                <a:solidFill>
-                  <a:srgbClr val="FFFFFF"/>
-                </a:solidFill>
-              </a:rPr>
-              <a:t>Release 2.1.0</a:t>
-            </a:r>
-          </a:p>
-        </p:txBody>
-      </p:sp>
-      <p:sp>
-        <p:nvSpPr>
-          <p:cNvPr id="27" name="TextBox 26"/>
-          <p:cNvSpPr txBox="1"/>
-          <p:nvPr/>
-        </p:nvSpPr>
-        <p:spPr>
-          <a:xfrm>
-            <a:off x="9509760" y="2148840"/>
-            <a:ext cx="1920240" cy="274320"/>
-          </a:xfrm>
-          <a:prstGeom prst="rect">
-            <a:avLst/>
-          </a:prstGeom>
-          <a:noFill/>
-        </p:spPr>
-        <p:txBody>
-          <a:bodyPr wrap="square">
-            <a:spAutoFit/>
-          </a:bodyPr>
-          <a:lstStyle/>
-          <a:p>
-            <a:pPr algn="l">
-              <a:spcAft>
-                <a:spcPts val="0"/>
-              </a:spcAft>
-            </a:pPr>
-            <a:r>
-              <a:rPr sz="800" b="1">
-                <a:solidFill>
-                  <a:srgbClr val="888888"/>
-                </a:solidFill>
-              </a:rPr>
-              <a:t>PLANNED</a:t>
-            </a:r>
-          </a:p>
-        </p:txBody>
-      </p:sp>
-      <p:sp>
-        <p:nvSpPr>
-          <p:cNvPr id="28" name="TextBox 27"/>
-          <p:cNvSpPr txBox="1"/>
-          <p:nvPr/>
-        </p:nvSpPr>
-        <p:spPr>
-          <a:xfrm>
-            <a:off x="9509760" y="2423160"/>
-            <a:ext cx="1920240" cy="822960"/>
-          </a:xfrm>
-          <a:prstGeom prst="rect">
-            <a:avLst/>
-          </a:prstGeom>
-          <a:noFill/>
-        </p:spPr>
-        <p:txBody>
-          <a:bodyPr wrap="square">
-            <a:spAutoFit/>
-          </a:bodyPr>
-          <a:lstStyle/>
-          <a:p>
-            <a:pPr algn="l">
-              <a:spcAft>
-                <a:spcPts val="0"/>
-              </a:spcAft>
-            </a:pPr>
-            <a:r>
-              <a:rPr sz="900" b="0">
-                <a:solidFill>
-                  <a:srgbClr val="555555"/>
-                </a:solidFill>
-              </a:rPr>
-              <a:t>Firmware Update &amp;
-Network Tolerance</a:t>
-            </a:r>
-          </a:p>
-        </p:txBody>
-      </p:sp>
-      <p:sp>
-        <p:nvSpPr>
-          <p:cNvPr id="29" name="TextBox 28"/>
+          <p:cNvPr id="19" name="TextBox 18"/>
           <p:cNvSpPr txBox="1"/>
           <p:nvPr/>
         </p:nvSpPr>
@@ -7623,7 +7603,7 @@
       </p:sp>
       <p:sp>
         <p:nvSpPr>
-          <p:cNvPr id="30" name="TextBox 29"/>
+          <p:cNvPr id="20" name="TextBox 19"/>
           <p:cNvSpPr txBox="1"/>
           <p:nvPr/>
         </p:nvSpPr>
@@ -7676,7 +7656,7 @@
       </p:sp>
       <p:sp>
         <p:nvSpPr>
-          <p:cNvPr id="31" name="TextBox 30"/>
+          <p:cNvPr id="21" name="TextBox 20"/>
           <p:cNvSpPr txBox="1"/>
           <p:nvPr/>
         </p:nvSpPr>
@@ -7729,7 +7709,7 @@
       </p:sp>
       <p:sp>
         <p:nvSpPr>
-          <p:cNvPr id="32" name="TextBox 31"/>
+          <p:cNvPr id="22" name="TextBox 21"/>
           <p:cNvSpPr txBox="1"/>
           <p:nvPr/>
         </p:nvSpPr>
@@ -7782,7 +7762,7 @@
       </p:sp>
       <p:sp>
         <p:nvSpPr>
-          <p:cNvPr id="33" name="TextBox 32"/>
+          <p:cNvPr id="23" name="TextBox 22"/>
           <p:cNvSpPr txBox="1"/>
           <p:nvPr/>
         </p:nvSpPr>
@@ -7820,7 +7800,7 @@
       </p:sp>
       <p:sp>
         <p:nvSpPr>
-          <p:cNvPr id="34" name="TextBox 33"/>
+          <p:cNvPr id="24" name="TextBox 23"/>
           <p:cNvSpPr txBox="1"/>
           <p:nvPr/>
         </p:nvSpPr>
@@ -7873,7 +7853,7 @@
       </p:sp>
       <p:sp>
         <p:nvSpPr>
-          <p:cNvPr id="35" name="TextBox 34"/>
+          <p:cNvPr id="25" name="TextBox 24"/>
           <p:cNvSpPr txBox="1"/>
           <p:nvPr/>
         </p:nvSpPr>
@@ -7926,7 +7906,7 @@
       </p:sp>
       <p:sp>
         <p:nvSpPr>
-          <p:cNvPr id="36" name="TextBox 35"/>
+          <p:cNvPr id="26" name="TextBox 25"/>
           <p:cNvSpPr txBox="1"/>
           <p:nvPr/>
         </p:nvSpPr>
@@ -7979,7 +7959,7 @@
       </p:sp>
       <p:sp>
         <p:nvSpPr>
-          <p:cNvPr id="37" name="Rounded Rectangle 36"/>
+          <p:cNvPr id="27" name="Rounded Rectangle 26"/>
           <p:cNvSpPr/>
           <p:nvPr/>
         </p:nvSpPr>
@@ -8024,7 +8004,7 @@
       </p:sp>
       <p:sp>
         <p:nvSpPr>
-          <p:cNvPr id="38" name="TextBox 37"/>
+          <p:cNvPr id="28" name="TextBox 27"/>
           <p:cNvSpPr txBox="1"/>
           <p:nvPr/>
         </p:nvSpPr>
@@ -8062,7 +8042,7 @@
       </p:sp>
       <p:sp>
         <p:nvSpPr>
-          <p:cNvPr id="39" name="TextBox 38"/>
+          <p:cNvPr id="29" name="TextBox 28"/>
           <p:cNvSpPr txBox="1"/>
           <p:nvPr/>
         </p:nvSpPr>
@@ -10471,7 +10451,90 @@
       </p:sp>
       <p:sp>
         <p:nvSpPr>
-          <p:cNvPr id="13" name="TextBox 12"/>
+          <p:cNvPr id="13" name="Rounded Rectangle 12"/>
+          <p:cNvSpPr/>
+          <p:nvPr/>
+        </p:nvSpPr>
+        <p:spPr>
+          <a:xfrm>
+            <a:off x="457200" y="5486400"/>
+            <a:ext cx="11247120" cy="411480"/>
+          </a:xfrm>
+          <a:prstGeom prst="roundRect">
+            <a:avLst/>
+          </a:prstGeom>
+          <a:solidFill>
+            <a:srgbClr val="142538"/>
+          </a:solidFill>
+          <a:ln w="12700">
+            <a:solidFill>
+              <a:srgbClr val="0069B0"/>
+            </a:solidFill>
+          </a:ln>
+        </p:spPr>
+        <p:style>
+          <a:lnRef idx="1">
+            <a:schemeClr val="accent1"/>
+          </a:lnRef>
+          <a:fillRef idx="3">
+            <a:schemeClr val="accent1"/>
+          </a:fillRef>
+          <a:effectRef idx="2">
+            <a:schemeClr val="accent1"/>
+          </a:effectRef>
+          <a:fontRef idx="minor">
+            <a:schemeClr val="lt1"/>
+          </a:fontRef>
+        </p:style>
+        <p:txBody>
+          <a:bodyPr rtlCol="0" anchor="ctr"/>
+          <a:lstStyle/>
+          <a:p>
+            <a:pPr algn="ctr"/>
+          </a:p>
+        </p:txBody>
+      </p:sp>
+      <p:sp>
+        <p:nvSpPr>
+          <p:cNvPr id="14" name="TextBox 13"/>
+          <p:cNvSpPr txBox="1"/>
+          <p:nvPr/>
+        </p:nvSpPr>
+        <p:spPr>
+          <a:xfrm>
+            <a:off x="731520" y="5541264"/>
+            <a:ext cx="10789920" cy="320040"/>
+          </a:xfrm>
+          <a:prstGeom prst="rect">
+            <a:avLst/>
+          </a:prstGeom>
+          <a:noFill/>
+        </p:spPr>
+        <p:txBody>
+          <a:bodyPr wrap="square">
+            <a:spAutoFit/>
+          </a:bodyPr>
+          <a:lstStyle/>
+          <a:p>
+            <a:pPr algn="ctr">
+              <a:spcAft>
+                <a:spcPts val="0"/>
+              </a:spcAft>
+            </a:pPr>
+            <a:r>
+              <a:rPr sz="1100" b="1">
+                <a:solidFill>
+                  <a:srgbClr val="FFFFFF"/>
+                </a:solidFill>
+              </a:rPr>
+              <a:t>One spec. Readable by engineers. Executable by machines. Traceable to every requirement.</a:t>
+            </a:r>
+          </a:p>
+        </p:txBody>
+      </p:sp>
+      <p:sp>
+        <p:nvSpPr>
+          <p:cNvPr id="15" name="TextBox 14"/>
           <p:cNvSpPr txBox="1"/>
           <p:nvPr/>
         </p:nvSpPr>

</xml_diff>

<commit_message>
Update slide 2 diagram to manual handoff style, fix docs commands
Slide 2: Replace red X marks with hand icon + "manual handoff" labels
between silo boxes. Fix pipeline-guide.md to use correct release-plan
path and output filename.

Co-Authored-By: Claude Opus 4.6 (1M context) <noreply@anthropic.com>
</commit_message>
<xml_diff>
--- a/docs/presentations/MBSE_Pipeline_Executive_Brief.pptx
+++ b/docs/presentations/MBSE_Pipeline_Executive_Brief.pptx
@@ -5177,8 +5177,8 @@
         </p:nvSpPr>
         <p:spPr>
           <a:xfrm>
-            <a:off x="9326880" y="2587752"/>
-            <a:ext cx="548640" cy="274320"/>
+            <a:off x="8321040" y="2560320"/>
+            <a:ext cx="2560320" cy="274320"/>
           </a:xfrm>
           <a:prstGeom prst="rect">
             <a:avLst/>
@@ -5197,12 +5197,12 @@
               </a:spcAft>
             </a:pPr>
             <a:r>
-              <a:rPr sz="1600" b="1">
-                <a:solidFill>
-                  <a:srgbClr val="CC3333"/>
-                </a:solidFill>
-              </a:rPr>
-              <a:t>✘</a:t>
+              <a:rPr sz="900" b="1">
+                <a:solidFill>
+                  <a:srgbClr val="924000"/>
+                </a:solidFill>
+              </a:rPr>
+              <a:t>✋  manual handoff</a:t>
             </a:r>
           </a:p>
         </p:txBody>
@@ -5215,8 +5215,8 @@
         </p:nvSpPr>
         <p:spPr>
           <a:xfrm>
-            <a:off x="9326880" y="3547872"/>
-            <a:ext cx="548640" cy="274320"/>
+            <a:off x="8321040" y="3520440"/>
+            <a:ext cx="2560320" cy="274320"/>
           </a:xfrm>
           <a:prstGeom prst="rect">
             <a:avLst/>
@@ -5235,12 +5235,12 @@
               </a:spcAft>
             </a:pPr>
             <a:r>
-              <a:rPr sz="1600" b="1">
-                <a:solidFill>
-                  <a:srgbClr val="CC3333"/>
-                </a:solidFill>
-              </a:rPr>
-              <a:t>✘</a:t>
+              <a:rPr sz="900" b="1">
+                <a:solidFill>
+                  <a:srgbClr val="924000"/>
+                </a:solidFill>
+              </a:rPr>
+              <a:t>✋  manual handoff</a:t>
             </a:r>
           </a:p>
         </p:txBody>
@@ -5275,7 +5275,7 @@
             <a:r>
               <a:rPr sz="1000" b="1">
                 <a:solidFill>
-                  <a:srgbClr val="CC3333"/>
+                  <a:srgbClr val="924000"/>
                 </a:solidFill>
               </a:rPr>
               <a:t>No automated thread</a:t>
@@ -5293,7 +5293,7 @@
                   <a:srgbClr val="888888"/>
                 </a:solidFill>
               </a:rPr>
-              <a:t>Manual handoffs at every stage</a:t>
+              <a:t>Slow, fragile, unversioned</a:t>
             </a:r>
           </a:p>
         </p:txBody>

</xml_diff>

<commit_message>
Rework layered testing slide: descriptions inside pyramid bars
Move layer descriptions inside each bar as a second line instead of
floating text outside. Trim right panel from 5 to 4 items. Full white
text for readability on projectors.

Co-Authored-By: Claude Opus 4.6 (1M context) <noreply@anthropic.com>
</commit_message>
<xml_diff>
--- a/docs/presentations/MBSE_Pipeline_Executive_Brief.pptx
+++ b/docs/presentations/MBSE_Pipeline_Executive_Brief.pptx
@@ -8188,8 +8188,8 @@
         </p:nvSpPr>
         <p:spPr>
           <a:xfrm>
-            <a:off x="457200" y="4937760"/>
-            <a:ext cx="5029200" cy="685800"/>
+            <a:off x="731520" y="5029200"/>
+            <a:ext cx="4572000" cy="640080"/>
           </a:xfrm>
           <a:prstGeom prst="roundRect">
             <a:avLst/>
@@ -8231,8 +8231,8 @@
         </p:nvSpPr>
         <p:spPr>
           <a:xfrm>
-            <a:off x="548640" y="5029200"/>
-            <a:ext cx="4846320" cy="594360"/>
+            <a:off x="822960" y="5074920"/>
+            <a:ext cx="4389120" cy="274320"/>
           </a:xfrm>
           <a:prstGeom prst="rect">
             <a:avLst/>
@@ -8263,14 +8263,52 @@
       </p:sp>
       <p:sp>
         <p:nvSpPr>
-          <p:cNvPr id="6" name="Rounded Rectangle 5"/>
+          <p:cNvPr id="6" name="TextBox 5"/>
+          <p:cNvSpPr txBox="1"/>
+          <p:nvPr/>
+        </p:nvSpPr>
+        <p:spPr>
+          <a:xfrm>
+            <a:off x="822960" y="5349240"/>
+            <a:ext cx="4389120" cy="274320"/>
+          </a:xfrm>
+          <a:prstGeom prst="rect">
+            <a:avLst/>
+          </a:prstGeom>
+          <a:noFill/>
+        </p:spPr>
+        <p:txBody>
+          <a:bodyPr wrap="square">
+            <a:spAutoFit/>
+          </a:bodyPr>
+          <a:lstStyle/>
+          <a:p>
+            <a:pPr algn="ctr">
+              <a:spcAft>
+                <a:spcPts val="0"/>
+              </a:spcAft>
+            </a:pPr>
+            <a:r>
+              <a:rPr sz="800" b="0">
+                <a:solidFill>
+                  <a:srgbClr val="FFFFFF"/>
+                </a:solidFill>
+              </a:rPr>
+              <a:t>Linting, type checks, code standards</a:t>
+            </a:r>
+          </a:p>
+        </p:txBody>
+      </p:sp>
+      <p:sp>
+        <p:nvSpPr>
+          <p:cNvPr id="7" name="Rounded Rectangle 6"/>
           <p:cNvSpPr/>
           <p:nvPr/>
         </p:nvSpPr>
         <p:spPr>
           <a:xfrm>
-            <a:off x="822960" y="4114800"/>
-            <a:ext cx="4297680" cy="685800"/>
+            <a:off x="1051560" y="4251960"/>
+            <a:ext cx="3931920" cy="640080"/>
           </a:xfrm>
           <a:prstGeom prst="roundRect">
             <a:avLst/>
@@ -8306,14 +8344,14 @@
       </p:sp>
       <p:sp>
         <p:nvSpPr>
-          <p:cNvPr id="7" name="TextBox 6"/>
-          <p:cNvSpPr txBox="1"/>
-          <p:nvPr/>
-        </p:nvSpPr>
-        <p:spPr>
-          <a:xfrm>
-            <a:off x="914400" y="4206240"/>
-            <a:ext cx="4114800" cy="594360"/>
+          <p:cNvPr id="8" name="TextBox 7"/>
+          <p:cNvSpPr txBox="1"/>
+          <p:nvPr/>
+        </p:nvSpPr>
+        <p:spPr>
+          <a:xfrm>
+            <a:off x="1143000" y="4297680"/>
+            <a:ext cx="3749040" cy="274320"/>
           </a:xfrm>
           <a:prstGeom prst="rect">
             <a:avLst/>
@@ -8344,14 +8382,52 @@
       </p:sp>
       <p:sp>
         <p:nvSpPr>
-          <p:cNvPr id="8" name="Rounded Rectangle 7"/>
+          <p:cNvPr id="9" name="TextBox 8"/>
+          <p:cNvSpPr txBox="1"/>
+          <p:nvPr/>
+        </p:nvSpPr>
+        <p:spPr>
+          <a:xfrm>
+            <a:off x="1143000" y="4572000"/>
+            <a:ext cx="3749040" cy="274320"/>
+          </a:xfrm>
+          <a:prstGeom prst="rect">
+            <a:avLst/>
+          </a:prstGeom>
+          <a:noFill/>
+        </p:spPr>
+        <p:txBody>
+          <a:bodyPr wrap="square">
+            <a:spAutoFit/>
+          </a:bodyPr>
+          <a:lstStyle/>
+          <a:p>
+            <a:pPr algn="ctr">
+              <a:spcAft>
+                <a:spcPts val="0"/>
+              </a:spcAft>
+            </a:pPr>
+            <a:r>
+              <a:rPr sz="800" b="0">
+                <a:solidFill>
+                  <a:srgbClr val="FFFFFF"/>
+                </a:solidFill>
+              </a:rPr>
+              <a:t>Individual functions, logic correctness</a:t>
+            </a:r>
+          </a:p>
+        </p:txBody>
+      </p:sp>
+      <p:sp>
+        <p:nvSpPr>
+          <p:cNvPr id="10" name="Rounded Rectangle 9"/>
           <p:cNvSpPr/>
           <p:nvPr/>
         </p:nvSpPr>
         <p:spPr>
           <a:xfrm>
-            <a:off x="1188720" y="3291840"/>
-            <a:ext cx="3566160" cy="685800"/>
+            <a:off x="1371600" y="3474720"/>
+            <a:ext cx="3291840" cy="640080"/>
           </a:xfrm>
           <a:prstGeom prst="roundRect">
             <a:avLst/>
@@ -8387,14 +8463,14 @@
       </p:sp>
       <p:sp>
         <p:nvSpPr>
-          <p:cNvPr id="9" name="TextBox 8"/>
-          <p:cNvSpPr txBox="1"/>
-          <p:nvPr/>
-        </p:nvSpPr>
-        <p:spPr>
-          <a:xfrm>
-            <a:off x="1280160" y="3383280"/>
-            <a:ext cx="3383280" cy="594360"/>
+          <p:cNvPr id="11" name="TextBox 10"/>
+          <p:cNvSpPr txBox="1"/>
+          <p:nvPr/>
+        </p:nvSpPr>
+        <p:spPr>
+          <a:xfrm>
+            <a:off x="1463040" y="3520440"/>
+            <a:ext cx="3108960" cy="274320"/>
           </a:xfrm>
           <a:prstGeom prst="rect">
             <a:avLst/>
@@ -8425,14 +8501,52 @@
       </p:sp>
       <p:sp>
         <p:nvSpPr>
-          <p:cNvPr id="10" name="Rounded Rectangle 9"/>
+          <p:cNvPr id="12" name="TextBox 11"/>
+          <p:cNvSpPr txBox="1"/>
+          <p:nvPr/>
+        </p:nvSpPr>
+        <p:spPr>
+          <a:xfrm>
+            <a:off x="1463040" y="3794760"/>
+            <a:ext cx="3108960" cy="274320"/>
+          </a:xfrm>
+          <a:prstGeom prst="rect">
+            <a:avLst/>
+          </a:prstGeom>
+          <a:noFill/>
+        </p:spPr>
+        <p:txBody>
+          <a:bodyPr wrap="square">
+            <a:spAutoFit/>
+          </a:bodyPr>
+          <a:lstStyle/>
+          <a:p>
+            <a:pPr algn="ctr">
+              <a:spcAft>
+                <a:spcPts val="0"/>
+              </a:spcAft>
+            </a:pPr>
+            <a:r>
+              <a:rPr sz="800" b="0">
+                <a:solidFill>
+                  <a:srgbClr val="FFFFFF"/>
+                </a:solidFill>
+              </a:rPr>
+              <a:t>Component interfaces, API contracts</a:t>
+            </a:r>
+          </a:p>
+        </p:txBody>
+      </p:sp>
+      <p:sp>
+        <p:nvSpPr>
+          <p:cNvPr id="13" name="Rounded Rectangle 12"/>
           <p:cNvSpPr/>
           <p:nvPr/>
         </p:nvSpPr>
         <p:spPr>
           <a:xfrm>
-            <a:off x="1554480" y="2468880"/>
-            <a:ext cx="2834640" cy="685800"/>
+            <a:off x="1691640" y="2697480"/>
+            <a:ext cx="2651760" cy="640080"/>
           </a:xfrm>
           <a:prstGeom prst="roundRect">
             <a:avLst/>
@@ -8470,14 +8584,14 @@
       </p:sp>
       <p:sp>
         <p:nvSpPr>
-          <p:cNvPr id="11" name="TextBox 10"/>
-          <p:cNvSpPr txBox="1"/>
-          <p:nvPr/>
-        </p:nvSpPr>
-        <p:spPr>
-          <a:xfrm>
-            <a:off x="1645920" y="2560320"/>
-            <a:ext cx="2651760" cy="594360"/>
+          <p:cNvPr id="14" name="TextBox 13"/>
+          <p:cNvSpPr txBox="1"/>
+          <p:nvPr/>
+        </p:nvSpPr>
+        <p:spPr>
+          <a:xfrm>
+            <a:off x="1783080" y="2743200"/>
+            <a:ext cx="2468880" cy="274320"/>
           </a:xfrm>
           <a:prstGeom prst="rect">
             <a:avLst/>
@@ -8501,21 +8615,59 @@
                   <a:srgbClr val="FFFFFF"/>
                 </a:solidFill>
               </a:rPr>
-              <a:t>E2E Tests</a:t>
-            </a:r>
-          </a:p>
-        </p:txBody>
-      </p:sp>
-      <p:sp>
-        <p:nvSpPr>
-          <p:cNvPr id="12" name="Rounded Rectangle 11"/>
+              <a:t>E2E / System Tests</a:t>
+            </a:r>
+          </a:p>
+        </p:txBody>
+      </p:sp>
+      <p:sp>
+        <p:nvSpPr>
+          <p:cNvPr id="15" name="TextBox 14"/>
+          <p:cNvSpPr txBox="1"/>
+          <p:nvPr/>
+        </p:nvSpPr>
+        <p:spPr>
+          <a:xfrm>
+            <a:off x="1783080" y="3017520"/>
+            <a:ext cx="2468880" cy="274320"/>
+          </a:xfrm>
+          <a:prstGeom prst="rect">
+            <a:avLst/>
+          </a:prstGeom>
+          <a:noFill/>
+        </p:spPr>
+        <p:txBody>
+          <a:bodyPr wrap="square">
+            <a:spAutoFit/>
+          </a:bodyPr>
+          <a:lstStyle/>
+          <a:p>
+            <a:pPr algn="ctr">
+              <a:spcAft>
+                <a:spcPts val="0"/>
+              </a:spcAft>
+            </a:pPr>
+            <a:r>
+              <a:rPr sz="800" b="0">
+                <a:solidFill>
+                  <a:srgbClr val="FFFFFF"/>
+                </a:solidFill>
+              </a:rPr>
+              <a:t>Requirements verified against deployed product</a:t>
+            </a:r>
+          </a:p>
+        </p:txBody>
+      </p:sp>
+      <p:sp>
+        <p:nvSpPr>
+          <p:cNvPr id="16" name="Rounded Rectangle 15"/>
           <p:cNvSpPr/>
           <p:nvPr/>
         </p:nvSpPr>
         <p:spPr>
           <a:xfrm>
-            <a:off x="1920240" y="1645920"/>
-            <a:ext cx="2103120" cy="685800"/>
+            <a:off x="2011680" y="1920240"/>
+            <a:ext cx="2011680" cy="640080"/>
           </a:xfrm>
           <a:prstGeom prst="roundRect">
             <a:avLst/>
@@ -8551,14 +8703,14 @@
       </p:sp>
       <p:sp>
         <p:nvSpPr>
-          <p:cNvPr id="13" name="TextBox 12"/>
-          <p:cNvSpPr txBox="1"/>
-          <p:nvPr/>
-        </p:nvSpPr>
-        <p:spPr>
-          <a:xfrm>
-            <a:off x="2011680" y="1737360"/>
-            <a:ext cx="1920240" cy="594360"/>
+          <p:cNvPr id="17" name="TextBox 16"/>
+          <p:cNvSpPr txBox="1"/>
+          <p:nvPr/>
+        </p:nvSpPr>
+        <p:spPr>
+          <a:xfrm>
+            <a:off x="2103120" y="1965960"/>
+            <a:ext cx="1828800" cy="274320"/>
           </a:xfrm>
           <a:prstGeom prst="rect">
             <a:avLst/>
@@ -8582,22 +8734,21 @@
                   <a:srgbClr val="FFFFFF"/>
                 </a:solidFill>
               </a:rPr>
-              <a:t>Manual &amp;
-Exploratory</a:t>
-            </a:r>
-          </a:p>
-        </p:txBody>
-      </p:sp>
-      <p:sp>
-        <p:nvSpPr>
-          <p:cNvPr id="14" name="TextBox 13"/>
-          <p:cNvSpPr txBox="1"/>
-          <p:nvPr/>
-        </p:nvSpPr>
-        <p:spPr>
-          <a:xfrm>
-            <a:off x="45720" y="1554480"/>
-            <a:ext cx="365760" cy="4114800"/>
+              <a:t>Manual &amp; Exploratory</a:t>
+            </a:r>
+          </a:p>
+        </p:txBody>
+      </p:sp>
+      <p:sp>
+        <p:nvSpPr>
+          <p:cNvPr id="18" name="TextBox 17"/>
+          <p:cNvSpPr txBox="1"/>
+          <p:nvPr/>
+        </p:nvSpPr>
+        <p:spPr>
+          <a:xfrm>
+            <a:off x="2103120" y="2240280"/>
+            <a:ext cx="1828800" cy="274320"/>
           </a:xfrm>
           <a:prstGeom prst="rect">
             <a:avLst/>
@@ -8616,63 +8767,25 @@
               </a:spcAft>
             </a:pPr>
             <a:r>
-              <a:rPr sz="900" b="1">
-                <a:solidFill>
-                  <a:srgbClr val="888888"/>
-                </a:solidFill>
-              </a:rPr>
-              <a:t>Cost ↑</a:t>
-            </a:r>
-          </a:p>
-        </p:txBody>
-      </p:sp>
-      <p:sp>
-        <p:nvSpPr>
-          <p:cNvPr id="15" name="TextBox 14"/>
-          <p:cNvSpPr txBox="1"/>
-          <p:nvPr/>
-        </p:nvSpPr>
-        <p:spPr>
-          <a:xfrm>
-            <a:off x="5029200" y="5669280"/>
-            <a:ext cx="731520" cy="274320"/>
-          </a:xfrm>
-          <a:prstGeom prst="rect">
-            <a:avLst/>
-          </a:prstGeom>
-          <a:noFill/>
-        </p:spPr>
-        <p:txBody>
-          <a:bodyPr wrap="square">
-            <a:spAutoFit/>
-          </a:bodyPr>
-          <a:lstStyle/>
-          <a:p>
-            <a:pPr algn="l">
-              <a:spcAft>
-                <a:spcPts val="0"/>
-              </a:spcAft>
-            </a:pPr>
-            <a:r>
-              <a:rPr sz="900" b="1">
-                <a:solidFill>
-                  <a:srgbClr val="888888"/>
-                </a:solidFill>
-              </a:rPr>
-              <a:t>Speed →</a:t>
-            </a:r>
-          </a:p>
-        </p:txBody>
-      </p:sp>
-      <p:sp>
-        <p:nvSpPr>
-          <p:cNvPr id="16" name="TextBox 15"/>
-          <p:cNvSpPr txBox="1"/>
-          <p:nvPr/>
-        </p:nvSpPr>
-        <p:spPr>
-          <a:xfrm>
-            <a:off x="4663440" y="2560320"/>
+              <a:rPr sz="800" b="0">
+                <a:solidFill>
+                  <a:srgbClr val="FFFFFF"/>
+                </a:solidFill>
+              </a:rPr>
+              <a:t>Usability, edge cases, human judgment</a:t>
+            </a:r>
+          </a:p>
+        </p:txBody>
+      </p:sp>
+      <p:sp>
+        <p:nvSpPr>
+          <p:cNvPr id="19" name="TextBox 18"/>
+          <p:cNvSpPr txBox="1"/>
+          <p:nvPr/>
+        </p:nvSpPr>
+        <p:spPr>
+          <a:xfrm>
+            <a:off x="4572000" y="2788920"/>
             <a:ext cx="1645920" cy="274320"/>
           </a:xfrm>
           <a:prstGeom prst="rect">
@@ -8704,13 +8817,13 @@
       </p:sp>
       <p:sp>
         <p:nvSpPr>
-          <p:cNvPr id="17" name="TextBox 16"/>
-          <p:cNvSpPr txBox="1"/>
-          <p:nvPr/>
-        </p:nvSpPr>
-        <p:spPr>
-          <a:xfrm>
-            <a:off x="6858000" y="1371600"/>
+          <p:cNvPr id="20" name="TextBox 19"/>
+          <p:cNvSpPr txBox="1"/>
+          <p:nvPr/>
+        </p:nvSpPr>
+        <p:spPr>
+          <a:xfrm>
+            <a:off x="6858000" y="1645920"/>
             <a:ext cx="4572000" cy="274320"/>
           </a:xfrm>
           <a:prstGeom prst="rect">
@@ -8742,14 +8855,14 @@
       </p:sp>
       <p:sp>
         <p:nvSpPr>
-          <p:cNvPr id="18" name="TextBox 17"/>
-          <p:cNvSpPr txBox="1"/>
-          <p:nvPr/>
-        </p:nvSpPr>
-        <p:spPr>
-          <a:xfrm>
-            <a:off x="6858000" y="1828800"/>
-            <a:ext cx="4754880" cy="640080"/>
+          <p:cNvPr id="21" name="TextBox 20"/>
+          <p:cNvSpPr txBox="1"/>
+          <p:nvPr/>
+        </p:nvSpPr>
+        <p:spPr>
+          <a:xfrm>
+            <a:off x="6858000" y="2103120"/>
+            <a:ext cx="4754880" cy="731520"/>
           </a:xfrm>
           <a:prstGeom prst="rect">
             <a:avLst/>
@@ -8768,7 +8881,7 @@
               </a:spcAft>
             </a:pPr>
             <a:r>
-              <a:rPr sz="1100" b="1">
+              <a:rPr sz="1200" b="1">
                 <a:solidFill>
                   <a:srgbClr val="0069B0"/>
                 </a:solidFill>
@@ -8788,21 +8901,22 @@
                   <a:srgbClr val="555555"/>
                 </a:solidFill>
               </a:rPr>
-              <a:t>Every Cameo requirement maps to a Gherkin scenario. Gate A enforces 100% coverage.</a:t>
-            </a:r>
-          </a:p>
-        </p:txBody>
-      </p:sp>
-      <p:sp>
-        <p:nvSpPr>
-          <p:cNvPr id="19" name="TextBox 18"/>
-          <p:cNvSpPr txBox="1"/>
-          <p:nvPr/>
-        </p:nvSpPr>
-        <p:spPr>
-          <a:xfrm>
-            <a:off x="6858000" y="2542032"/>
-            <a:ext cx="4754880" cy="640080"/>
+              <a:t>Every Cameo requirement maps to a Gherkin scenario.
+Gate A enforces 100% coverage.</a:t>
+            </a:r>
+          </a:p>
+        </p:txBody>
+      </p:sp>
+      <p:sp>
+        <p:nvSpPr>
+          <p:cNvPr id="22" name="TextBox 21"/>
+          <p:cNvSpPr txBox="1"/>
+          <p:nvPr/>
+        </p:nvSpPr>
+        <p:spPr>
+          <a:xfrm>
+            <a:off x="6858000" y="2971800"/>
+            <a:ext cx="4754880" cy="731520"/>
           </a:xfrm>
           <a:prstGeom prst="rect">
             <a:avLst/>
@@ -8821,12 +8935,12 @@
               </a:spcAft>
             </a:pPr>
             <a:r>
-              <a:rPr sz="1100" b="1">
+              <a:rPr sz="1200" b="1">
                 <a:solidFill>
                   <a:srgbClr val="0069B0"/>
                 </a:solidFill>
               </a:rPr>
-              <a:t>Automated E2E Verification</a:t>
+              <a:t>Automated Verification</a:t>
             </a:r>
           </a:p>
           <a:p>
@@ -8841,21 +8955,22 @@
                   <a:srgbClr val="555555"/>
                 </a:solidFill>
               </a:rPr>
-              <a:t>BDD scenarios run against simulation logs after product deployment. Results captured automatically.</a:t>
-            </a:r>
-          </a:p>
-        </p:txBody>
-      </p:sp>
-      <p:sp>
-        <p:nvSpPr>
-          <p:cNvPr id="20" name="TextBox 19"/>
-          <p:cNvSpPr txBox="1"/>
-          <p:nvPr/>
-        </p:nvSpPr>
-        <p:spPr>
-          <a:xfrm>
-            <a:off x="6858000" y="3255264"/>
-            <a:ext cx="4754880" cy="640080"/>
+              <a:t>BDD scenarios run against the deployed product.
+Results captured automatically on every build.</a:t>
+            </a:r>
+          </a:p>
+        </p:txBody>
+      </p:sp>
+      <p:sp>
+        <p:nvSpPr>
+          <p:cNvPr id="23" name="TextBox 22"/>
+          <p:cNvSpPr txBox="1"/>
+          <p:nvPr/>
+        </p:nvSpPr>
+        <p:spPr>
+          <a:xfrm>
+            <a:off x="6858000" y="3840480"/>
+            <a:ext cx="4754880" cy="731520"/>
           </a:xfrm>
           <a:prstGeom prst="rect">
             <a:avLst/>
@@ -8874,7 +8989,7 @@
               </a:spcAft>
             </a:pPr>
             <a:r>
-              <a:rPr sz="1100" b="1">
+              <a:rPr sz="1200" b="1">
                 <a:solidFill>
                   <a:srgbClr val="0069B0"/>
                 </a:solidFill>
@@ -8894,21 +9009,22 @@
                   <a:srgbClr val="555555"/>
                 </a:solidFill>
               </a:rPr>
-              <a:t>Gate B detects when the model changes and flags tests for review — no silent invalidation.</a:t>
-            </a:r>
-          </a:p>
-        </p:txBody>
-      </p:sp>
-      <p:sp>
-        <p:nvSpPr>
-          <p:cNvPr id="21" name="TextBox 20"/>
-          <p:cNvSpPr txBox="1"/>
-          <p:nvPr/>
-        </p:nvSpPr>
-        <p:spPr>
-          <a:xfrm>
-            <a:off x="6858000" y="3968496"/>
-            <a:ext cx="4754880" cy="640080"/>
+              <a:t>Gate B flags tests when the model changes —
+no silent invalidation.</a:t>
+            </a:r>
+          </a:p>
+        </p:txBody>
+      </p:sp>
+      <p:sp>
+        <p:nvSpPr>
+          <p:cNvPr id="24" name="TextBox 23"/>
+          <p:cNvSpPr txBox="1"/>
+          <p:nvPr/>
+        </p:nvSpPr>
+        <p:spPr>
+          <a:xfrm>
+            <a:off x="6858000" y="4709160"/>
+            <a:ext cx="4754880" cy="731520"/>
           </a:xfrm>
           <a:prstGeom prst="rect">
             <a:avLst/>
@@ -8927,12 +9043,12 @@
               </a:spcAft>
             </a:pPr>
             <a:r>
-              <a:rPr sz="1100" b="1">
+              <a:rPr sz="1200" b="1">
                 <a:solidFill>
                   <a:srgbClr val="0069B0"/>
                 </a:solidFill>
               </a:rPr>
-              <a:t>Evidence Generation</a:t>
+              <a:t>Audit Evidence</a:t>
             </a:r>
           </a:p>
           <a:p>
@@ -8947,67 +9063,15 @@
                   <a:srgbClr val="555555"/>
                 </a:solidFill>
               </a:rPr>
-              <a:t>The Deployment Pipeline Report is produced on every build — a complete audit trail.</a:t>
-            </a:r>
-          </a:p>
-        </p:txBody>
-      </p:sp>
-      <p:sp>
-        <p:nvSpPr>
-          <p:cNvPr id="22" name="TextBox 21"/>
-          <p:cNvSpPr txBox="1"/>
-          <p:nvPr/>
-        </p:nvSpPr>
-        <p:spPr>
-          <a:xfrm>
-            <a:off x="6858000" y="4681728"/>
-            <a:ext cx="4754880" cy="640080"/>
-          </a:xfrm>
-          <a:prstGeom prst="rect">
-            <a:avLst/>
-          </a:prstGeom>
-          <a:noFill/>
-        </p:spPr>
-        <p:txBody>
-          <a:bodyPr wrap="square">
-            <a:spAutoFit/>
-          </a:bodyPr>
-          <a:lstStyle/>
-          <a:p>
-            <a:pPr algn="l">
-              <a:spcAft>
-                <a:spcPts val="200"/>
-              </a:spcAft>
-            </a:pPr>
-            <a:r>
-              <a:rPr sz="1100" b="1">
-                <a:solidFill>
-                  <a:srgbClr val="0069B0"/>
-                </a:solidFill>
-              </a:rPr>
-              <a:t>Release-Aware Gating</a:t>
-            </a:r>
-          </a:p>
-          <a:p>
-            <a:pPr algn="l">
-              <a:spcAft>
-                <a:spcPts val="0"/>
-              </a:spcAft>
-            </a:pPr>
-            <a:r>
-              <a:rPr sz="900" b="0">
-                <a:solidFill>
-                  <a:srgbClr val="555555"/>
-                </a:solidFill>
-              </a:rPr>
-              <a:t>Quality gates only enforce VCs in scope for the current release. Future work is tracked but not blocking.</a:t>
-            </a:r>
-          </a:p>
-        </p:txBody>
-      </p:sp>
-      <p:sp>
-        <p:nvSpPr>
-          <p:cNvPr id="23" name="TextBox 22"/>
+              <a:t>The Deployment Pipeline Report is a complete,
+automatically generated audit trail.</a:t>
+            </a:r>
+          </a:p>
+        </p:txBody>
+      </p:sp>
+      <p:sp>
+        <p:nvSpPr>
+          <p:cNvPr id="25" name="TextBox 24"/>
           <p:cNvSpPr txBox="1"/>
           <p:nvPr/>
         </p:nvSpPr>
@@ -9045,7 +9109,7 @@
       </p:sp>
       <p:sp>
         <p:nvSpPr>
-          <p:cNvPr id="24" name="TextBox 23"/>
+          <p:cNvPr id="26" name="TextBox 25"/>
           <p:cNvSpPr txBox="1"/>
           <p:nvPr/>
         </p:nvSpPr>

</xml_diff>